<commit_message>
update lectures 1 & 2
</commit_message>
<xml_diff>
--- a/lecture_1/Lecture_1.pptx
+++ b/lecture_1/Lecture_1.pptx
@@ -5,30 +5,33 @@
     <p:sldMasterId id="2147483968" r:id="rId1"/>
   </p:sldMasterIdLst>
   <p:notesMasterIdLst>
-    <p:notesMasterId r:id="rId23"/>
+    <p:notesMasterId r:id="rId26"/>
   </p:notesMasterIdLst>
   <p:sldIdLst>
     <p:sldId id="256" r:id="rId2"/>
-    <p:sldId id="264" r:id="rId3"/>
-    <p:sldId id="258" r:id="rId4"/>
-    <p:sldId id="260" r:id="rId5"/>
-    <p:sldId id="261" r:id="rId6"/>
-    <p:sldId id="262" r:id="rId7"/>
-    <p:sldId id="263" r:id="rId8"/>
-    <p:sldId id="265" r:id="rId9"/>
-    <p:sldId id="266" r:id="rId10"/>
-    <p:sldId id="267" r:id="rId11"/>
-    <p:sldId id="268" r:id="rId12"/>
-    <p:sldId id="269" r:id="rId13"/>
-    <p:sldId id="270" r:id="rId14"/>
-    <p:sldId id="271" r:id="rId15"/>
-    <p:sldId id="278" r:id="rId16"/>
-    <p:sldId id="272" r:id="rId17"/>
-    <p:sldId id="273" r:id="rId18"/>
-    <p:sldId id="279" r:id="rId19"/>
-    <p:sldId id="274" r:id="rId20"/>
-    <p:sldId id="275" r:id="rId21"/>
-    <p:sldId id="280" r:id="rId22"/>
+    <p:sldId id="282" r:id="rId3"/>
+    <p:sldId id="264" r:id="rId4"/>
+    <p:sldId id="258" r:id="rId5"/>
+    <p:sldId id="260" r:id="rId6"/>
+    <p:sldId id="261" r:id="rId7"/>
+    <p:sldId id="262" r:id="rId8"/>
+    <p:sldId id="263" r:id="rId9"/>
+    <p:sldId id="265" r:id="rId10"/>
+    <p:sldId id="266" r:id="rId11"/>
+    <p:sldId id="267" r:id="rId12"/>
+    <p:sldId id="268" r:id="rId13"/>
+    <p:sldId id="281" r:id="rId14"/>
+    <p:sldId id="269" r:id="rId15"/>
+    <p:sldId id="270" r:id="rId16"/>
+    <p:sldId id="271" r:id="rId17"/>
+    <p:sldId id="278" r:id="rId18"/>
+    <p:sldId id="272" r:id="rId19"/>
+    <p:sldId id="273" r:id="rId20"/>
+    <p:sldId id="279" r:id="rId21"/>
+    <p:sldId id="274" r:id="rId22"/>
+    <p:sldId id="275" r:id="rId23"/>
+    <p:sldId id="280" r:id="rId24"/>
+    <p:sldId id="283" r:id="rId25"/>
   </p:sldIdLst>
   <p:sldSz cx="12192000" cy="6858000"/>
   <p:notesSz cx="6858000" cy="9144000"/>
@@ -217,7 +220,7 @@
           <a:p>
             <a:fld id="{870534A9-6018-2047-913D-1953A2F6D512}" type="datetimeFigureOut">
               <a:rPr lang="en-US" smtClean="0"/>
-              <a:t>12/27/2021</a:t>
+              <a:t>12/28/2021</a:t>
             </a:fld>
             <a:endParaRPr lang="en-US"/>
           </a:p>
@@ -549,7 +552,7 @@
           <a:p>
             <a:fld id="{70AE8F9F-6DA5-A84A-A6AC-9F6E4BC07FF0}" type="slidenum">
               <a:rPr lang="en-US" smtClean="0"/>
-              <a:t>7</a:t>
+              <a:t>8</a:t>
             </a:fld>
             <a:endParaRPr lang="en-US"/>
           </a:p>
@@ -633,7 +636,7 @@
           <a:p>
             <a:fld id="{70AE8F9F-6DA5-A84A-A6AC-9F6E4BC07FF0}" type="slidenum">
               <a:rPr lang="en-US" smtClean="0"/>
-              <a:t>16</a:t>
+              <a:t>18</a:t>
             </a:fld>
             <a:endParaRPr lang="en-US"/>
           </a:p>
@@ -709,7 +712,7 @@
           <a:noFill/>
           <a:extLst>
             <a:ext uri="{909E8E84-426E-40dd-AFC4-6F175D3DCCD1}">
-              <a14:hiddenFill xmlns="" xmlns:a14="http://schemas.microsoft.com/office/drawing/2010/main">
+              <a14:hiddenFill xmlns:a14="http://schemas.microsoft.com/office/drawing/2010/main" xmlns="">
                 <a:solidFill>
                   <a:srgbClr val="FFFFFF"/>
                 </a:solidFill>
@@ -768,7 +771,7 @@
             </a:ln>
             <a:extLst>
               <a:ext uri="{91240B29-F687-4f45-9708-019B960494DF}">
-                <a14:hiddenLine xmlns="" xmlns:a14="http://schemas.microsoft.com/office/drawing/2010/main" w="9525">
+                <a14:hiddenLine xmlns:a14="http://schemas.microsoft.com/office/drawing/2010/main" xmlns="" w="9525">
                   <a:solidFill>
                     <a:srgbClr val="000000"/>
                   </a:solidFill>
@@ -858,7 +861,7 @@
             </a:ln>
             <a:extLst>
               <a:ext uri="{91240B29-F687-4f45-9708-019B960494DF}">
-                <a14:hiddenLine xmlns="" xmlns:a14="http://schemas.microsoft.com/office/drawing/2010/main" w="9525">
+                <a14:hiddenLine xmlns:a14="http://schemas.microsoft.com/office/drawing/2010/main" xmlns="" w="9525">
                   <a:solidFill>
                     <a:srgbClr val="000000"/>
                   </a:solidFill>
@@ -948,7 +951,7 @@
             </a:ln>
             <a:extLst>
               <a:ext uri="{91240B29-F687-4f45-9708-019B960494DF}">
-                <a14:hiddenLine xmlns="" xmlns:a14="http://schemas.microsoft.com/office/drawing/2010/main" w="9525">
+                <a14:hiddenLine xmlns:a14="http://schemas.microsoft.com/office/drawing/2010/main" xmlns="" w="9525">
                   <a:solidFill>
                     <a:srgbClr val="000000"/>
                   </a:solidFill>
@@ -982,7 +985,7 @@
             </a:ln>
             <a:extLst>
               <a:ext uri="{91240B29-F687-4f45-9708-019B960494DF}">
-                <a14:hiddenLine xmlns="" xmlns:a14="http://schemas.microsoft.com/office/drawing/2010/main" w="9525">
+                <a14:hiddenLine xmlns:a14="http://schemas.microsoft.com/office/drawing/2010/main" xmlns="" w="9525">
                   <a:solidFill>
                     <a:srgbClr val="000000"/>
                   </a:solidFill>
@@ -1072,7 +1075,7 @@
             </a:ln>
             <a:extLst>
               <a:ext uri="{91240B29-F687-4f45-9708-019B960494DF}">
-                <a14:hiddenLine xmlns="" xmlns:a14="http://schemas.microsoft.com/office/drawing/2010/main" w="9525">
+                <a14:hiddenLine xmlns:a14="http://schemas.microsoft.com/office/drawing/2010/main" xmlns="" w="9525">
                   <a:solidFill>
                     <a:srgbClr val="000000"/>
                   </a:solidFill>
@@ -1134,7 +1137,7 @@
             </a:ln>
             <a:extLst>
               <a:ext uri="{91240B29-F687-4f45-9708-019B960494DF}">
-                <a14:hiddenLine xmlns="" xmlns:a14="http://schemas.microsoft.com/office/drawing/2010/main" w="9525">
+                <a14:hiddenLine xmlns:a14="http://schemas.microsoft.com/office/drawing/2010/main" xmlns="" w="9525">
                   <a:solidFill>
                     <a:srgbClr val="000000"/>
                   </a:solidFill>
@@ -1196,7 +1199,7 @@
             </a:ln>
             <a:extLst>
               <a:ext uri="{91240B29-F687-4f45-9708-019B960494DF}">
-                <a14:hiddenLine xmlns="" xmlns:a14="http://schemas.microsoft.com/office/drawing/2010/main" w="9525">
+                <a14:hiddenLine xmlns:a14="http://schemas.microsoft.com/office/drawing/2010/main" xmlns="" w="9525">
                   <a:solidFill>
                     <a:srgbClr val="000000"/>
                   </a:solidFill>
@@ -1286,7 +1289,7 @@
             </a:ln>
             <a:extLst>
               <a:ext uri="{91240B29-F687-4f45-9708-019B960494DF}">
-                <a14:hiddenLine xmlns="" xmlns:a14="http://schemas.microsoft.com/office/drawing/2010/main" w="9525">
+                <a14:hiddenLine xmlns:a14="http://schemas.microsoft.com/office/drawing/2010/main" xmlns="" w="9525">
                   <a:solidFill>
                     <a:srgbClr val="000000"/>
                   </a:solidFill>
@@ -1348,7 +1351,7 @@
             </a:ln>
             <a:extLst>
               <a:ext uri="{91240B29-F687-4f45-9708-019B960494DF}">
-                <a14:hiddenLine xmlns="" xmlns:a14="http://schemas.microsoft.com/office/drawing/2010/main" w="9525">
+                <a14:hiddenLine xmlns:a14="http://schemas.microsoft.com/office/drawing/2010/main" xmlns="" w="9525">
                   <a:solidFill>
                     <a:srgbClr val="000000"/>
                   </a:solidFill>
@@ -1410,7 +1413,7 @@
             </a:ln>
             <a:extLst>
               <a:ext uri="{91240B29-F687-4f45-9708-019B960494DF}">
-                <a14:hiddenLine xmlns="" xmlns:a14="http://schemas.microsoft.com/office/drawing/2010/main" w="9525">
+                <a14:hiddenLine xmlns:a14="http://schemas.microsoft.com/office/drawing/2010/main" xmlns="" w="9525">
                   <a:solidFill>
                     <a:srgbClr val="000000"/>
                   </a:solidFill>
@@ -1500,7 +1503,7 @@
             </a:ln>
             <a:extLst>
               <a:ext uri="{91240B29-F687-4f45-9708-019B960494DF}">
-                <a14:hiddenLine xmlns="" xmlns:a14="http://schemas.microsoft.com/office/drawing/2010/main" w="9525">
+                <a14:hiddenLine xmlns:a14="http://schemas.microsoft.com/office/drawing/2010/main" xmlns="" w="9525">
                   <a:solidFill>
                     <a:srgbClr val="000000"/>
                   </a:solidFill>
@@ -1590,7 +1593,7 @@
             </a:ln>
             <a:extLst>
               <a:ext uri="{91240B29-F687-4f45-9708-019B960494DF}">
-                <a14:hiddenLine xmlns="" xmlns:a14="http://schemas.microsoft.com/office/drawing/2010/main" w="9525">
+                <a14:hiddenLine xmlns:a14="http://schemas.microsoft.com/office/drawing/2010/main" xmlns="" w="9525">
                   <a:solidFill>
                     <a:srgbClr val="000000"/>
                   </a:solidFill>
@@ -1652,7 +1655,7 @@
             </a:ln>
             <a:extLst>
               <a:ext uri="{91240B29-F687-4f45-9708-019B960494DF}">
-                <a14:hiddenLine xmlns="" xmlns:a14="http://schemas.microsoft.com/office/drawing/2010/main" w="9525">
+                <a14:hiddenLine xmlns:a14="http://schemas.microsoft.com/office/drawing/2010/main" xmlns="" w="9525">
                   <a:solidFill>
                     <a:srgbClr val="000000"/>
                   </a:solidFill>
@@ -1762,7 +1765,7 @@
             </a:ln>
             <a:extLst>
               <a:ext uri="{91240B29-F687-4f45-9708-019B960494DF}">
-                <a14:hiddenLine xmlns="" xmlns:a14="http://schemas.microsoft.com/office/drawing/2010/main" w="9525">
+                <a14:hiddenLine xmlns:a14="http://schemas.microsoft.com/office/drawing/2010/main" xmlns="" w="9525">
                   <a:solidFill>
                     <a:srgbClr val="000000"/>
                   </a:solidFill>
@@ -1824,7 +1827,7 @@
             </a:ln>
             <a:extLst>
               <a:ext uri="{91240B29-F687-4f45-9708-019B960494DF}">
-                <a14:hiddenLine xmlns="" xmlns:a14="http://schemas.microsoft.com/office/drawing/2010/main" w="9525">
+                <a14:hiddenLine xmlns:a14="http://schemas.microsoft.com/office/drawing/2010/main" xmlns="" w="9525">
                   <a:solidFill>
                     <a:srgbClr val="000000"/>
                   </a:solidFill>
@@ -1914,7 +1917,7 @@
             </a:ln>
             <a:extLst>
               <a:ext uri="{91240B29-F687-4f45-9708-019B960494DF}">
-                <a14:hiddenLine xmlns="" xmlns:a14="http://schemas.microsoft.com/office/drawing/2010/main" w="9525">
+                <a14:hiddenLine xmlns:a14="http://schemas.microsoft.com/office/drawing/2010/main" xmlns="" w="9525">
                   <a:solidFill>
                     <a:srgbClr val="000000"/>
                   </a:solidFill>
@@ -2004,7 +2007,7 @@
             </a:ln>
             <a:extLst>
               <a:ext uri="{91240B29-F687-4f45-9708-019B960494DF}">
-                <a14:hiddenLine xmlns="" xmlns:a14="http://schemas.microsoft.com/office/drawing/2010/main" w="9525">
+                <a14:hiddenLine xmlns:a14="http://schemas.microsoft.com/office/drawing/2010/main" xmlns="" w="9525">
                   <a:solidFill>
                     <a:srgbClr val="000000"/>
                   </a:solidFill>
@@ -2066,7 +2069,7 @@
             </a:ln>
             <a:extLst>
               <a:ext uri="{91240B29-F687-4f45-9708-019B960494DF}">
-                <a14:hiddenLine xmlns="" xmlns:a14="http://schemas.microsoft.com/office/drawing/2010/main" w="9525">
+                <a14:hiddenLine xmlns:a14="http://schemas.microsoft.com/office/drawing/2010/main" xmlns="" w="9525">
                   <a:solidFill>
                     <a:srgbClr val="000000"/>
                   </a:solidFill>
@@ -2156,7 +2159,7 @@
             </a:ln>
             <a:extLst>
               <a:ext uri="{91240B29-F687-4f45-9708-019B960494DF}">
-                <a14:hiddenLine xmlns="" xmlns:a14="http://schemas.microsoft.com/office/drawing/2010/main" w="9525">
+                <a14:hiddenLine xmlns:a14="http://schemas.microsoft.com/office/drawing/2010/main" xmlns="" w="9525">
                   <a:solidFill>
                     <a:srgbClr val="000000"/>
                   </a:solidFill>
@@ -2246,7 +2249,7 @@
             </a:ln>
             <a:extLst>
               <a:ext uri="{91240B29-F687-4f45-9708-019B960494DF}">
-                <a14:hiddenLine xmlns="" xmlns:a14="http://schemas.microsoft.com/office/drawing/2010/main" w="9525">
+                <a14:hiddenLine xmlns:a14="http://schemas.microsoft.com/office/drawing/2010/main" xmlns="" w="9525">
                   <a:solidFill>
                     <a:srgbClr val="000000"/>
                   </a:solidFill>
@@ -2302,7 +2305,7 @@
             </a:ln>
             <a:extLst>
               <a:ext uri="{91240B29-F687-4f45-9708-019B960494DF}">
-                <a14:hiddenLine xmlns="" xmlns:a14="http://schemas.microsoft.com/office/drawing/2010/main" w="9525">
+                <a14:hiddenLine xmlns:a14="http://schemas.microsoft.com/office/drawing/2010/main" xmlns="" w="9525">
                   <a:solidFill>
                     <a:srgbClr val="000000"/>
                   </a:solidFill>
@@ -2392,7 +2395,7 @@
             </a:ln>
             <a:extLst>
               <a:ext uri="{91240B29-F687-4f45-9708-019B960494DF}">
-                <a14:hiddenLine xmlns="" xmlns:a14="http://schemas.microsoft.com/office/drawing/2010/main" w="9525">
+                <a14:hiddenLine xmlns:a14="http://schemas.microsoft.com/office/drawing/2010/main" xmlns="" w="9525">
                   <a:solidFill>
                     <a:srgbClr val="000000"/>
                   </a:solidFill>
@@ -2448,7 +2451,7 @@
             </a:ln>
             <a:extLst>
               <a:ext uri="{91240B29-F687-4f45-9708-019B960494DF}">
-                <a14:hiddenLine xmlns="" xmlns:a14="http://schemas.microsoft.com/office/drawing/2010/main" w="9525">
+                <a14:hiddenLine xmlns:a14="http://schemas.microsoft.com/office/drawing/2010/main" xmlns="" w="9525">
                   <a:solidFill>
                     <a:srgbClr val="000000"/>
                   </a:solidFill>
@@ -2538,7 +2541,7 @@
             </a:ln>
             <a:extLst>
               <a:ext uri="{91240B29-F687-4f45-9708-019B960494DF}">
-                <a14:hiddenLine xmlns="" xmlns:a14="http://schemas.microsoft.com/office/drawing/2010/main" w="9525">
+                <a14:hiddenLine xmlns:a14="http://schemas.microsoft.com/office/drawing/2010/main" xmlns="" w="9525">
                   <a:solidFill>
                     <a:srgbClr val="000000"/>
                   </a:solidFill>
@@ -2606,7 +2609,7 @@
             </a:ln>
             <a:extLst>
               <a:ext uri="{91240B29-F687-4f45-9708-019B960494DF}">
-                <a14:hiddenLine xmlns="" xmlns:a14="http://schemas.microsoft.com/office/drawing/2010/main" w="9525">
+                <a14:hiddenLine xmlns:a14="http://schemas.microsoft.com/office/drawing/2010/main" xmlns="" w="9525">
                   <a:solidFill>
                     <a:srgbClr val="000000"/>
                   </a:solidFill>
@@ -2696,7 +2699,7 @@
             </a:ln>
             <a:extLst>
               <a:ext uri="{91240B29-F687-4f45-9708-019B960494DF}">
-                <a14:hiddenLine xmlns="" xmlns:a14="http://schemas.microsoft.com/office/drawing/2010/main" w="9525">
+                <a14:hiddenLine xmlns:a14="http://schemas.microsoft.com/office/drawing/2010/main" xmlns="" w="9525">
                   <a:solidFill>
                     <a:srgbClr val="000000"/>
                   </a:solidFill>
@@ -2764,7 +2767,7 @@
             </a:ln>
             <a:extLst>
               <a:ext uri="{91240B29-F687-4f45-9708-019B960494DF}">
-                <a14:hiddenLine xmlns="" xmlns:a14="http://schemas.microsoft.com/office/drawing/2010/main" w="9525">
+                <a14:hiddenLine xmlns:a14="http://schemas.microsoft.com/office/drawing/2010/main" xmlns="" w="9525">
                   <a:solidFill>
                     <a:srgbClr val="000000"/>
                   </a:solidFill>
@@ -2854,7 +2857,7 @@
             </a:ln>
             <a:extLst>
               <a:ext uri="{91240B29-F687-4f45-9708-019B960494DF}">
-                <a14:hiddenLine xmlns="" xmlns:a14="http://schemas.microsoft.com/office/drawing/2010/main" w="9525">
+                <a14:hiddenLine xmlns:a14="http://schemas.microsoft.com/office/drawing/2010/main" xmlns="" w="9525">
                   <a:solidFill>
                     <a:srgbClr val="000000"/>
                   </a:solidFill>
@@ -2888,7 +2891,7 @@
             </a:ln>
             <a:extLst>
               <a:ext uri="{91240B29-F687-4f45-9708-019B960494DF}">
-                <a14:hiddenLine xmlns="" xmlns:a14="http://schemas.microsoft.com/office/drawing/2010/main" w="9525">
+                <a14:hiddenLine xmlns:a14="http://schemas.microsoft.com/office/drawing/2010/main" xmlns="" w="9525">
                   <a:solidFill>
                     <a:srgbClr val="000000"/>
                   </a:solidFill>
@@ -2978,7 +2981,7 @@
             </a:ln>
             <a:extLst>
               <a:ext uri="{91240B29-F687-4f45-9708-019B960494DF}">
-                <a14:hiddenLine xmlns="" xmlns:a14="http://schemas.microsoft.com/office/drawing/2010/main" w="9525">
+                <a14:hiddenLine xmlns:a14="http://schemas.microsoft.com/office/drawing/2010/main" xmlns="" w="9525">
                   <a:solidFill>
                     <a:srgbClr val="000000"/>
                   </a:solidFill>
@@ -3040,7 +3043,7 @@
             </a:ln>
             <a:extLst>
               <a:ext uri="{91240B29-F687-4f45-9708-019B960494DF}">
-                <a14:hiddenLine xmlns="" xmlns:a14="http://schemas.microsoft.com/office/drawing/2010/main" w="9525">
+                <a14:hiddenLine xmlns:a14="http://schemas.microsoft.com/office/drawing/2010/main" xmlns="" w="9525">
                   <a:solidFill>
                     <a:srgbClr val="000000"/>
                   </a:solidFill>
@@ -3102,7 +3105,7 @@
             </a:ln>
             <a:extLst>
               <a:ext uri="{91240B29-F687-4f45-9708-019B960494DF}">
-                <a14:hiddenLine xmlns="" xmlns:a14="http://schemas.microsoft.com/office/drawing/2010/main" w="9525">
+                <a14:hiddenLine xmlns:a14="http://schemas.microsoft.com/office/drawing/2010/main" xmlns="" w="9525">
                   <a:solidFill>
                     <a:srgbClr val="000000"/>
                   </a:solidFill>
@@ -3192,7 +3195,7 @@
             </a:ln>
             <a:extLst>
               <a:ext uri="{91240B29-F687-4f45-9708-019B960494DF}">
-                <a14:hiddenLine xmlns="" xmlns:a14="http://schemas.microsoft.com/office/drawing/2010/main" w="9525">
+                <a14:hiddenLine xmlns:a14="http://schemas.microsoft.com/office/drawing/2010/main" xmlns="" w="9525">
                   <a:solidFill>
                     <a:srgbClr val="000000"/>
                   </a:solidFill>
@@ -3260,7 +3263,7 @@
             </a:ln>
             <a:extLst>
               <a:ext uri="{91240B29-F687-4f45-9708-019B960494DF}">
-                <a14:hiddenLine xmlns="" xmlns:a14="http://schemas.microsoft.com/office/drawing/2010/main" w="9525">
+                <a14:hiddenLine xmlns:a14="http://schemas.microsoft.com/office/drawing/2010/main" xmlns="" w="9525">
                   <a:solidFill>
                     <a:srgbClr val="000000"/>
                   </a:solidFill>
@@ -3322,7 +3325,7 @@
             </a:ln>
             <a:extLst>
               <a:ext uri="{91240B29-F687-4f45-9708-019B960494DF}">
-                <a14:hiddenLine xmlns="" xmlns:a14="http://schemas.microsoft.com/office/drawing/2010/main" w="9525">
+                <a14:hiddenLine xmlns:a14="http://schemas.microsoft.com/office/drawing/2010/main" xmlns="" w="9525">
                   <a:solidFill>
                     <a:srgbClr val="000000"/>
                   </a:solidFill>
@@ -3412,7 +3415,7 @@
             </a:ln>
             <a:extLst>
               <a:ext uri="{91240B29-F687-4f45-9708-019B960494DF}">
-                <a14:hiddenLine xmlns="" xmlns:a14="http://schemas.microsoft.com/office/drawing/2010/main" w="9525">
+                <a14:hiddenLine xmlns:a14="http://schemas.microsoft.com/office/drawing/2010/main" xmlns="" w="9525">
                   <a:solidFill>
                     <a:srgbClr val="000000"/>
                   </a:solidFill>
@@ -3474,7 +3477,7 @@
             </a:ln>
             <a:extLst>
               <a:ext uri="{91240B29-F687-4f45-9708-019B960494DF}">
-                <a14:hiddenLine xmlns="" xmlns:a14="http://schemas.microsoft.com/office/drawing/2010/main" w="9525">
+                <a14:hiddenLine xmlns:a14="http://schemas.microsoft.com/office/drawing/2010/main" xmlns="" w="9525">
                   <a:solidFill>
                     <a:srgbClr val="000000"/>
                   </a:solidFill>
@@ -3564,7 +3567,7 @@
             </a:ln>
             <a:extLst>
               <a:ext uri="{91240B29-F687-4f45-9708-019B960494DF}">
-                <a14:hiddenLine xmlns="" xmlns:a14="http://schemas.microsoft.com/office/drawing/2010/main" w="9525">
+                <a14:hiddenLine xmlns:a14="http://schemas.microsoft.com/office/drawing/2010/main" xmlns="" w="9525">
                   <a:solidFill>
                     <a:srgbClr val="000000"/>
                   </a:solidFill>
@@ -3626,7 +3629,7 @@
             </a:ln>
             <a:extLst>
               <a:ext uri="{91240B29-F687-4f45-9708-019B960494DF}">
-                <a14:hiddenLine xmlns="" xmlns:a14="http://schemas.microsoft.com/office/drawing/2010/main" w="9525">
+                <a14:hiddenLine xmlns:a14="http://schemas.microsoft.com/office/drawing/2010/main" xmlns="" w="9525">
                   <a:solidFill>
                     <a:srgbClr val="000000"/>
                   </a:solidFill>
@@ -3716,7 +3719,7 @@
             </a:ln>
             <a:extLst>
               <a:ext uri="{91240B29-F687-4f45-9708-019B960494DF}">
-                <a14:hiddenLine xmlns="" xmlns:a14="http://schemas.microsoft.com/office/drawing/2010/main" w="9525">
+                <a14:hiddenLine xmlns:a14="http://schemas.microsoft.com/office/drawing/2010/main" xmlns="" w="9525">
                   <a:solidFill>
                     <a:srgbClr val="000000"/>
                   </a:solidFill>
@@ -3750,7 +3753,7 @@
             </a:ln>
             <a:extLst>
               <a:ext uri="{91240B29-F687-4f45-9708-019B960494DF}">
-                <a14:hiddenLine xmlns="" xmlns:a14="http://schemas.microsoft.com/office/drawing/2010/main" w="9525">
+                <a14:hiddenLine xmlns:a14="http://schemas.microsoft.com/office/drawing/2010/main" xmlns="" w="9525">
                   <a:solidFill>
                     <a:srgbClr val="000000"/>
                   </a:solidFill>
@@ -3815,7 +3818,7 @@
             </a:ln>
             <a:extLst>
               <a:ext uri="{91240B29-F687-4f45-9708-019B960494DF}">
-                <a14:hiddenLine xmlns="" xmlns:a14="http://schemas.microsoft.com/office/drawing/2010/main" w="9525">
+                <a14:hiddenLine xmlns:a14="http://schemas.microsoft.com/office/drawing/2010/main" xmlns="" w="9525">
                   <a:solidFill>
                     <a:srgbClr val="000000"/>
                   </a:solidFill>
@@ -3905,7 +3908,7 @@
             </a:ln>
             <a:extLst>
               <a:ext uri="{91240B29-F687-4f45-9708-019B960494DF}">
-                <a14:hiddenLine xmlns="" xmlns:a14="http://schemas.microsoft.com/office/drawing/2010/main" w="9525">
+                <a14:hiddenLine xmlns:a14="http://schemas.microsoft.com/office/drawing/2010/main" xmlns="" w="9525">
                   <a:solidFill>
                     <a:srgbClr val="000000"/>
                   </a:solidFill>
@@ -3967,7 +3970,7 @@
             </a:ln>
             <a:extLst>
               <a:ext uri="{91240B29-F687-4f45-9708-019B960494DF}">
-                <a14:hiddenLine xmlns="" xmlns:a14="http://schemas.microsoft.com/office/drawing/2010/main" w="9525">
+                <a14:hiddenLine xmlns:a14="http://schemas.microsoft.com/office/drawing/2010/main" xmlns="" w="9525">
                   <a:solidFill>
                     <a:srgbClr val="000000"/>
                   </a:solidFill>
@@ -4057,7 +4060,7 @@
             </a:ln>
             <a:extLst>
               <a:ext uri="{91240B29-F687-4f45-9708-019B960494DF}">
-                <a14:hiddenLine xmlns="" xmlns:a14="http://schemas.microsoft.com/office/drawing/2010/main" w="9525">
+                <a14:hiddenLine xmlns:a14="http://schemas.microsoft.com/office/drawing/2010/main" xmlns="" w="9525">
                   <a:solidFill>
                     <a:srgbClr val="000000"/>
                   </a:solidFill>
@@ -4147,7 +4150,7 @@
             </a:ln>
             <a:extLst>
               <a:ext uri="{91240B29-F687-4f45-9708-019B960494DF}">
-                <a14:hiddenLine xmlns="" xmlns:a14="http://schemas.microsoft.com/office/drawing/2010/main" w="9525">
+                <a14:hiddenLine xmlns:a14="http://schemas.microsoft.com/office/drawing/2010/main" xmlns="" w="9525">
                   <a:solidFill>
                     <a:srgbClr val="000000"/>
                   </a:solidFill>
@@ -4212,7 +4215,7 @@
             </a:ln>
             <a:extLst>
               <a:ext uri="{91240B29-F687-4f45-9708-019B960494DF}">
-                <a14:hiddenLine xmlns="" xmlns:a14="http://schemas.microsoft.com/office/drawing/2010/main" w="9525">
+                <a14:hiddenLine xmlns:a14="http://schemas.microsoft.com/office/drawing/2010/main" xmlns="" w="9525">
                   <a:solidFill>
                     <a:srgbClr val="000000"/>
                   </a:solidFill>
@@ -4274,7 +4277,7 @@
             </a:ln>
             <a:extLst>
               <a:ext uri="{91240B29-F687-4f45-9708-019B960494DF}">
-                <a14:hiddenLine xmlns="" xmlns:a14="http://schemas.microsoft.com/office/drawing/2010/main" w="9525">
+                <a14:hiddenLine xmlns:a14="http://schemas.microsoft.com/office/drawing/2010/main" xmlns="" w="9525">
                   <a:solidFill>
                     <a:srgbClr val="000000"/>
                   </a:solidFill>
@@ -4364,7 +4367,7 @@
             </a:ln>
             <a:extLst>
               <a:ext uri="{91240B29-F687-4f45-9708-019B960494DF}">
-                <a14:hiddenLine xmlns="" xmlns:a14="http://schemas.microsoft.com/office/drawing/2010/main" w="9525">
+                <a14:hiddenLine xmlns:a14="http://schemas.microsoft.com/office/drawing/2010/main" xmlns="" w="9525">
                   <a:solidFill>
                     <a:srgbClr val="000000"/>
                   </a:solidFill>
@@ -4454,7 +4457,7 @@
             </a:ln>
             <a:extLst>
               <a:ext uri="{91240B29-F687-4f45-9708-019B960494DF}">
-                <a14:hiddenLine xmlns="" xmlns:a14="http://schemas.microsoft.com/office/drawing/2010/main" w="9525">
+                <a14:hiddenLine xmlns:a14="http://schemas.microsoft.com/office/drawing/2010/main" xmlns="" w="9525">
                   <a:solidFill>
                     <a:srgbClr val="000000"/>
                   </a:solidFill>
@@ -4516,7 +4519,7 @@
             </a:ln>
             <a:extLst>
               <a:ext uri="{91240B29-F687-4f45-9708-019B960494DF}">
-                <a14:hiddenLine xmlns="" xmlns:a14="http://schemas.microsoft.com/office/drawing/2010/main" w="9525">
+                <a14:hiddenLine xmlns:a14="http://schemas.microsoft.com/office/drawing/2010/main" xmlns="" w="9525">
                   <a:solidFill>
                     <a:srgbClr val="000000"/>
                   </a:solidFill>
@@ -4636,7 +4639,7 @@
             </a:ln>
             <a:extLst>
               <a:ext uri="{91240B29-F687-4f45-9708-019B960494DF}">
-                <a14:hiddenLine xmlns="" xmlns:a14="http://schemas.microsoft.com/office/drawing/2010/main" w="9525">
+                <a14:hiddenLine xmlns:a14="http://schemas.microsoft.com/office/drawing/2010/main" xmlns="" w="9525">
                   <a:solidFill>
                     <a:srgbClr val="000000"/>
                   </a:solidFill>
@@ -4704,7 +4707,7 @@
             </a:ln>
             <a:extLst>
               <a:ext uri="{91240B29-F687-4f45-9708-019B960494DF}">
-                <a14:hiddenLine xmlns="" xmlns:a14="http://schemas.microsoft.com/office/drawing/2010/main" w="9525">
+                <a14:hiddenLine xmlns:a14="http://schemas.microsoft.com/office/drawing/2010/main" xmlns="" w="9525">
                   <a:solidFill>
                     <a:srgbClr val="000000"/>
                   </a:solidFill>
@@ -4794,7 +4797,7 @@
             </a:ln>
             <a:extLst>
               <a:ext uri="{91240B29-F687-4f45-9708-019B960494DF}">
-                <a14:hiddenLine xmlns="" xmlns:a14="http://schemas.microsoft.com/office/drawing/2010/main" w="9525">
+                <a14:hiddenLine xmlns:a14="http://schemas.microsoft.com/office/drawing/2010/main" xmlns="" w="9525">
                   <a:solidFill>
                     <a:srgbClr val="000000"/>
                   </a:solidFill>
@@ -4934,7 +4937,7 @@
           <a:p>
             <a:fld id="{B3A65DBF-A9F0-C148-993C-2303F706A4CD}" type="datetimeFigureOut">
               <a:rPr lang="en-US" smtClean="0"/>
-              <a:t>12/27/2021</a:t>
+              <a:t>12/28/2021</a:t>
             </a:fld>
             <a:endParaRPr lang="en-US"/>
           </a:p>
@@ -5201,7 +5204,7 @@
           <a:p>
             <a:fld id="{B3A65DBF-A9F0-C148-993C-2303F706A4CD}" type="datetimeFigureOut">
               <a:rPr lang="en-US" smtClean="0"/>
-              <a:t>12/27/2021</a:t>
+              <a:t>12/28/2021</a:t>
             </a:fld>
             <a:endParaRPr lang="en-US"/>
           </a:p>
@@ -5397,7 +5400,7 @@
           <a:p>
             <a:fld id="{B3A65DBF-A9F0-C148-993C-2303F706A4CD}" type="datetimeFigureOut">
               <a:rPr lang="en-US" smtClean="0"/>
-              <a:t>12/27/2021</a:t>
+              <a:t>12/28/2021</a:t>
             </a:fld>
             <a:endParaRPr lang="en-US"/>
           </a:p>
@@ -5660,7 +5663,7 @@
           <a:p>
             <a:fld id="{B3A65DBF-A9F0-C148-993C-2303F706A4CD}" type="datetimeFigureOut">
               <a:rPr lang="en-US" smtClean="0"/>
-              <a:t>12/27/2021</a:t>
+              <a:t>12/28/2021</a:t>
             </a:fld>
             <a:endParaRPr lang="en-US"/>
           </a:p>
@@ -6094,7 +6097,7 @@
           <a:p>
             <a:fld id="{B3A65DBF-A9F0-C148-993C-2303F706A4CD}" type="datetimeFigureOut">
               <a:rPr lang="en-US" smtClean="0"/>
-              <a:t>12/27/2021</a:t>
+              <a:t>12/28/2021</a:t>
             </a:fld>
             <a:endParaRPr lang="en-US"/>
           </a:p>
@@ -6640,7 +6643,7 @@
           <a:p>
             <a:fld id="{B3A65DBF-A9F0-C148-993C-2303F706A4CD}" type="datetimeFigureOut">
               <a:rPr lang="en-US" smtClean="0"/>
-              <a:t>12/27/2021</a:t>
+              <a:t>12/28/2021</a:t>
             </a:fld>
             <a:endParaRPr lang="en-US"/>
           </a:p>
@@ -7360,7 +7363,7 @@
           <a:p>
             <a:fld id="{B3A65DBF-A9F0-C148-993C-2303F706A4CD}" type="datetimeFigureOut">
               <a:rPr lang="en-US" smtClean="0"/>
-              <a:t>12/27/2021</a:t>
+              <a:t>12/28/2021</a:t>
             </a:fld>
             <a:endParaRPr lang="en-US"/>
           </a:p>
@@ -7530,7 +7533,7 @@
           <a:p>
             <a:fld id="{B3A65DBF-A9F0-C148-993C-2303F706A4CD}" type="datetimeFigureOut">
               <a:rPr lang="en-US" smtClean="0"/>
-              <a:t>12/27/2021</a:t>
+              <a:t>12/28/2021</a:t>
             </a:fld>
             <a:endParaRPr lang="en-US"/>
           </a:p>
@@ -7710,7 +7713,7 @@
           <a:p>
             <a:fld id="{B3A65DBF-A9F0-C148-993C-2303F706A4CD}" type="datetimeFigureOut">
               <a:rPr lang="en-US" smtClean="0"/>
-              <a:t>12/27/2021</a:t>
+              <a:t>12/28/2021</a:t>
             </a:fld>
             <a:endParaRPr lang="en-US"/>
           </a:p>
@@ -7880,7 +7883,7 @@
           <a:p>
             <a:fld id="{B3A65DBF-A9F0-C148-993C-2303F706A4CD}" type="datetimeFigureOut">
               <a:rPr lang="en-US" smtClean="0"/>
-              <a:t>12/27/2021</a:t>
+              <a:t>12/28/2021</a:t>
             </a:fld>
             <a:endParaRPr lang="en-US"/>
           </a:p>
@@ -8130,7 +8133,7 @@
           <a:p>
             <a:fld id="{B3A65DBF-A9F0-C148-993C-2303F706A4CD}" type="datetimeFigureOut">
               <a:rPr lang="en-US" smtClean="0"/>
-              <a:t>12/27/2021</a:t>
+              <a:t>12/28/2021</a:t>
             </a:fld>
             <a:endParaRPr lang="en-US"/>
           </a:p>
@@ -8362,7 +8365,7 @@
           <a:p>
             <a:fld id="{B3A65DBF-A9F0-C148-993C-2303F706A4CD}" type="datetimeFigureOut">
               <a:rPr lang="en-US" smtClean="0"/>
-              <a:t>12/27/2021</a:t>
+              <a:t>12/28/2021</a:t>
             </a:fld>
             <a:endParaRPr lang="en-US"/>
           </a:p>
@@ -8743,7 +8746,7 @@
           <a:p>
             <a:fld id="{B3A65DBF-A9F0-C148-993C-2303F706A4CD}" type="datetimeFigureOut">
               <a:rPr lang="en-US" smtClean="0"/>
-              <a:t>12/27/2021</a:t>
+              <a:t>12/28/2021</a:t>
             </a:fld>
             <a:endParaRPr lang="en-US"/>
           </a:p>
@@ -8861,7 +8864,7 @@
           <a:p>
             <a:fld id="{B3A65DBF-A9F0-C148-993C-2303F706A4CD}" type="datetimeFigureOut">
               <a:rPr lang="en-US" smtClean="0"/>
-              <a:t>12/27/2021</a:t>
+              <a:t>12/28/2021</a:t>
             </a:fld>
             <a:endParaRPr lang="en-US"/>
           </a:p>
@@ -8956,7 +8959,7 @@
           <a:p>
             <a:fld id="{B3A65DBF-A9F0-C148-993C-2303F706A4CD}" type="datetimeFigureOut">
               <a:rPr lang="en-US" smtClean="0"/>
-              <a:t>12/27/2021</a:t>
+              <a:t>12/28/2021</a:t>
             </a:fld>
             <a:endParaRPr lang="en-US"/>
           </a:p>
@@ -9205,7 +9208,7 @@
           <a:p>
             <a:fld id="{B3A65DBF-A9F0-C148-993C-2303F706A4CD}" type="datetimeFigureOut">
               <a:rPr lang="en-US" smtClean="0"/>
-              <a:t>12/27/2021</a:t>
+              <a:t>12/28/2021</a:t>
             </a:fld>
             <a:endParaRPr lang="en-US"/>
           </a:p>
@@ -9485,7 +9488,7 @@
           <a:p>
             <a:fld id="{B3A65DBF-A9F0-C148-993C-2303F706A4CD}" type="datetimeFigureOut">
               <a:rPr lang="en-US" smtClean="0"/>
-              <a:t>12/27/2021</a:t>
+              <a:t>12/28/2021</a:t>
             </a:fld>
             <a:endParaRPr lang="en-US"/>
           </a:p>
@@ -9608,7 +9611,7 @@
           <a:noFill/>
           <a:extLst>
             <a:ext uri="{909E8E84-426E-40dd-AFC4-6F175D3DCCD1}">
-              <a14:hiddenFill xmlns="" xmlns:a14="http://schemas.microsoft.com/office/drawing/2010/main">
+              <a14:hiddenFill xmlns:a14="http://schemas.microsoft.com/office/drawing/2010/main" xmlns="">
                 <a:solidFill>
                   <a:srgbClr val="FFFFFF"/>
                 </a:solidFill>
@@ -9682,7 +9685,7 @@
               </a:ln>
               <a:extLst>
                 <a:ext uri="{91240B29-F687-4f45-9708-019B960494DF}">
-                  <a14:hiddenLine xmlns="" xmlns:a14="http://schemas.microsoft.com/office/drawing/2010/main" w="9525">
+                  <a14:hiddenLine xmlns:a14="http://schemas.microsoft.com/office/drawing/2010/main" xmlns="" w="9525">
                     <a:solidFill>
                       <a:srgbClr val="000000"/>
                     </a:solidFill>
@@ -9772,7 +9775,7 @@
               </a:ln>
               <a:extLst>
                 <a:ext uri="{91240B29-F687-4f45-9708-019B960494DF}">
-                  <a14:hiddenLine xmlns="" xmlns:a14="http://schemas.microsoft.com/office/drawing/2010/main" w="9525">
+                  <a14:hiddenLine xmlns:a14="http://schemas.microsoft.com/office/drawing/2010/main" xmlns="" w="9525">
                     <a:solidFill>
                       <a:srgbClr val="000000"/>
                     </a:solidFill>
@@ -9862,7 +9865,7 @@
               </a:ln>
               <a:extLst>
                 <a:ext uri="{91240B29-F687-4f45-9708-019B960494DF}">
-                  <a14:hiddenLine xmlns="" xmlns:a14="http://schemas.microsoft.com/office/drawing/2010/main" w="9525">
+                  <a14:hiddenLine xmlns:a14="http://schemas.microsoft.com/office/drawing/2010/main" xmlns="" w="9525">
                     <a:solidFill>
                       <a:srgbClr val="000000"/>
                     </a:solidFill>
@@ -9924,7 +9927,7 @@
               </a:ln>
               <a:extLst>
                 <a:ext uri="{91240B29-F687-4f45-9708-019B960494DF}">
-                  <a14:hiddenLine xmlns="" xmlns:a14="http://schemas.microsoft.com/office/drawing/2010/main" w="9525">
+                  <a14:hiddenLine xmlns:a14="http://schemas.microsoft.com/office/drawing/2010/main" xmlns="" w="9525">
                     <a:solidFill>
                       <a:srgbClr val="000000"/>
                     </a:solidFill>
@@ -10014,7 +10017,7 @@
               </a:ln>
               <a:extLst>
                 <a:ext uri="{91240B29-F687-4f45-9708-019B960494DF}">
-                  <a14:hiddenLine xmlns="" xmlns:a14="http://schemas.microsoft.com/office/drawing/2010/main" w="9525">
+                  <a14:hiddenLine xmlns:a14="http://schemas.microsoft.com/office/drawing/2010/main" xmlns="" w="9525">
                     <a:solidFill>
                       <a:srgbClr val="000000"/>
                     </a:solidFill>
@@ -10076,7 +10079,7 @@
               </a:ln>
               <a:extLst>
                 <a:ext uri="{91240B29-F687-4f45-9708-019B960494DF}">
-                  <a14:hiddenLine xmlns="" xmlns:a14="http://schemas.microsoft.com/office/drawing/2010/main" w="9525">
+                  <a14:hiddenLine xmlns:a14="http://schemas.microsoft.com/office/drawing/2010/main" xmlns="" w="9525">
                     <a:solidFill>
                       <a:srgbClr val="000000"/>
                     </a:solidFill>
@@ -10138,7 +10141,7 @@
               </a:ln>
               <a:extLst>
                 <a:ext uri="{91240B29-F687-4f45-9708-019B960494DF}">
-                  <a14:hiddenLine xmlns="" xmlns:a14="http://schemas.microsoft.com/office/drawing/2010/main" w="9525">
+                  <a14:hiddenLine xmlns:a14="http://schemas.microsoft.com/office/drawing/2010/main" xmlns="" w="9525">
                     <a:solidFill>
                       <a:srgbClr val="000000"/>
                     </a:solidFill>
@@ -10228,7 +10231,7 @@
               </a:ln>
               <a:extLst>
                 <a:ext uri="{91240B29-F687-4f45-9708-019B960494DF}">
-                  <a14:hiddenLine xmlns="" xmlns:a14="http://schemas.microsoft.com/office/drawing/2010/main" w="9525">
+                  <a14:hiddenLine xmlns:a14="http://schemas.microsoft.com/office/drawing/2010/main" xmlns="" w="9525">
                     <a:solidFill>
                       <a:srgbClr val="000000"/>
                     </a:solidFill>
@@ -10318,7 +10321,7 @@
               </a:ln>
               <a:extLst>
                 <a:ext uri="{91240B29-F687-4f45-9708-019B960494DF}">
-                  <a14:hiddenLine xmlns="" xmlns:a14="http://schemas.microsoft.com/office/drawing/2010/main" w="9525">
+                  <a14:hiddenLine xmlns:a14="http://schemas.microsoft.com/office/drawing/2010/main" xmlns="" w="9525">
                     <a:solidFill>
                       <a:srgbClr val="000000"/>
                     </a:solidFill>
@@ -10380,7 +10383,7 @@
               </a:ln>
               <a:extLst>
                 <a:ext uri="{91240B29-F687-4f45-9708-019B960494DF}">
-                  <a14:hiddenLine xmlns="" xmlns:a14="http://schemas.microsoft.com/office/drawing/2010/main" w="9525">
+                  <a14:hiddenLine xmlns:a14="http://schemas.microsoft.com/office/drawing/2010/main" xmlns="" w="9525">
                     <a:solidFill>
                       <a:srgbClr val="000000"/>
                     </a:solidFill>
@@ -10490,7 +10493,7 @@
               </a:ln>
               <a:extLst>
                 <a:ext uri="{91240B29-F687-4f45-9708-019B960494DF}">
-                  <a14:hiddenLine xmlns="" xmlns:a14="http://schemas.microsoft.com/office/drawing/2010/main" w="9525">
+                  <a14:hiddenLine xmlns:a14="http://schemas.microsoft.com/office/drawing/2010/main" xmlns="" w="9525">
                     <a:solidFill>
                       <a:srgbClr val="000000"/>
                     </a:solidFill>
@@ -10574,7 +10577,7 @@
               </a:ln>
               <a:extLst>
                 <a:ext uri="{91240B29-F687-4f45-9708-019B960494DF}">
-                  <a14:hiddenLine xmlns="" xmlns:a14="http://schemas.microsoft.com/office/drawing/2010/main" w="9525">
+                  <a14:hiddenLine xmlns:a14="http://schemas.microsoft.com/office/drawing/2010/main" xmlns="" w="9525">
                     <a:solidFill>
                       <a:srgbClr val="000000"/>
                     </a:solidFill>
@@ -10636,7 +10639,7 @@
               </a:ln>
               <a:extLst>
                 <a:ext uri="{91240B29-F687-4f45-9708-019B960494DF}">
-                  <a14:hiddenLine xmlns="" xmlns:a14="http://schemas.microsoft.com/office/drawing/2010/main" w="9525">
+                  <a14:hiddenLine xmlns:a14="http://schemas.microsoft.com/office/drawing/2010/main" xmlns="" w="9525">
                     <a:solidFill>
                       <a:srgbClr val="000000"/>
                     </a:solidFill>
@@ -10698,7 +10701,7 @@
               </a:ln>
               <a:extLst>
                 <a:ext uri="{91240B29-F687-4f45-9708-019B960494DF}">
-                  <a14:hiddenLine xmlns="" xmlns:a14="http://schemas.microsoft.com/office/drawing/2010/main" w="9525">
+                  <a14:hiddenLine xmlns:a14="http://schemas.microsoft.com/office/drawing/2010/main" xmlns="" w="9525">
                     <a:solidFill>
                       <a:srgbClr val="000000"/>
                     </a:solidFill>
@@ -10788,7 +10791,7 @@
               </a:ln>
               <a:extLst>
                 <a:ext uri="{91240B29-F687-4f45-9708-019B960494DF}">
-                  <a14:hiddenLine xmlns="" xmlns:a14="http://schemas.microsoft.com/office/drawing/2010/main" w="9525">
+                  <a14:hiddenLine xmlns:a14="http://schemas.microsoft.com/office/drawing/2010/main" xmlns="" w="9525">
                     <a:solidFill>
                       <a:srgbClr val="000000"/>
                     </a:solidFill>
@@ -10822,7 +10825,7 @@
               </a:ln>
               <a:extLst>
                 <a:ext uri="{91240B29-F687-4f45-9708-019B960494DF}">
-                  <a14:hiddenLine xmlns="" xmlns:a14="http://schemas.microsoft.com/office/drawing/2010/main" w="9525">
+                  <a14:hiddenLine xmlns:a14="http://schemas.microsoft.com/office/drawing/2010/main" xmlns="" w="9525">
                     <a:solidFill>
                       <a:srgbClr val="000000"/>
                     </a:solidFill>
@@ -10887,7 +10890,7 @@
               </a:ln>
               <a:extLst>
                 <a:ext uri="{91240B29-F687-4f45-9708-019B960494DF}">
-                  <a14:hiddenLine xmlns="" xmlns:a14="http://schemas.microsoft.com/office/drawing/2010/main" w="9525">
+                  <a14:hiddenLine xmlns:a14="http://schemas.microsoft.com/office/drawing/2010/main" xmlns="" w="9525">
                     <a:solidFill>
                       <a:srgbClr val="000000"/>
                     </a:solidFill>
@@ -10977,7 +10980,7 @@
               </a:ln>
               <a:extLst>
                 <a:ext uri="{91240B29-F687-4f45-9708-019B960494DF}">
-                  <a14:hiddenLine xmlns="" xmlns:a14="http://schemas.microsoft.com/office/drawing/2010/main" w="9525">
+                  <a14:hiddenLine xmlns:a14="http://schemas.microsoft.com/office/drawing/2010/main" xmlns="" w="9525">
                     <a:solidFill>
                       <a:srgbClr val="000000"/>
                     </a:solidFill>
@@ -11039,7 +11042,7 @@
               </a:ln>
               <a:extLst>
                 <a:ext uri="{91240B29-F687-4f45-9708-019B960494DF}">
-                  <a14:hiddenLine xmlns="" xmlns:a14="http://schemas.microsoft.com/office/drawing/2010/main" w="9525">
+                  <a14:hiddenLine xmlns:a14="http://schemas.microsoft.com/office/drawing/2010/main" xmlns="" w="9525">
                     <a:solidFill>
                       <a:srgbClr val="000000"/>
                     </a:solidFill>
@@ -11129,7 +11132,7 @@
               </a:ln>
               <a:extLst>
                 <a:ext uri="{91240B29-F687-4f45-9708-019B960494DF}">
-                  <a14:hiddenLine xmlns="" xmlns:a14="http://schemas.microsoft.com/office/drawing/2010/main" w="9525">
+                  <a14:hiddenLine xmlns:a14="http://schemas.microsoft.com/office/drawing/2010/main" xmlns="" w="9525">
                     <a:solidFill>
                       <a:srgbClr val="000000"/>
                     </a:solidFill>
@@ -11194,7 +11197,7 @@
               </a:ln>
               <a:extLst>
                 <a:ext uri="{91240B29-F687-4f45-9708-019B960494DF}">
-                  <a14:hiddenLine xmlns="" xmlns:a14="http://schemas.microsoft.com/office/drawing/2010/main" w="9525">
+                  <a14:hiddenLine xmlns:a14="http://schemas.microsoft.com/office/drawing/2010/main" xmlns="" w="9525">
                     <a:solidFill>
                       <a:srgbClr val="000000"/>
                     </a:solidFill>
@@ -11256,7 +11259,7 @@
               </a:ln>
               <a:extLst>
                 <a:ext uri="{91240B29-F687-4f45-9708-019B960494DF}">
-                  <a14:hiddenLine xmlns="" xmlns:a14="http://schemas.microsoft.com/office/drawing/2010/main" w="9525">
+                  <a14:hiddenLine xmlns:a14="http://schemas.microsoft.com/office/drawing/2010/main" xmlns="" w="9525">
                     <a:solidFill>
                       <a:srgbClr val="000000"/>
                     </a:solidFill>
@@ -11346,7 +11349,7 @@
               </a:ln>
               <a:extLst>
                 <a:ext uri="{91240B29-F687-4f45-9708-019B960494DF}">
-                  <a14:hiddenLine xmlns="" xmlns:a14="http://schemas.microsoft.com/office/drawing/2010/main" w="9525">
+                  <a14:hiddenLine xmlns:a14="http://schemas.microsoft.com/office/drawing/2010/main" xmlns="" w="9525">
                     <a:solidFill>
                       <a:srgbClr val="000000"/>
                     </a:solidFill>
@@ -11436,7 +11439,7 @@
               </a:ln>
               <a:extLst>
                 <a:ext uri="{91240B29-F687-4f45-9708-019B960494DF}">
-                  <a14:hiddenLine xmlns="" xmlns:a14="http://schemas.microsoft.com/office/drawing/2010/main" w="9525">
+                  <a14:hiddenLine xmlns:a14="http://schemas.microsoft.com/office/drawing/2010/main" xmlns="" w="9525">
                     <a:solidFill>
                       <a:srgbClr val="000000"/>
                     </a:solidFill>
@@ -11501,7 +11504,7 @@
               </a:ln>
               <a:extLst>
                 <a:ext uri="{91240B29-F687-4f45-9708-019B960494DF}">
-                  <a14:hiddenLine xmlns="" xmlns:a14="http://schemas.microsoft.com/office/drawing/2010/main" w="9525">
+                  <a14:hiddenLine xmlns:a14="http://schemas.microsoft.com/office/drawing/2010/main" xmlns="" w="9525">
                     <a:solidFill>
                       <a:srgbClr val="000000"/>
                     </a:solidFill>
@@ -11621,7 +11624,7 @@
               </a:ln>
               <a:extLst>
                 <a:ext uri="{91240B29-F687-4f45-9708-019B960494DF}">
-                  <a14:hiddenLine xmlns="" xmlns:a14="http://schemas.microsoft.com/office/drawing/2010/main" w="9525">
+                  <a14:hiddenLine xmlns:a14="http://schemas.microsoft.com/office/drawing/2010/main" xmlns="" w="9525">
                     <a:solidFill>
                       <a:srgbClr val="000000"/>
                     </a:solidFill>
@@ -11702,7 +11705,7 @@
               </a:ln>
               <a:extLst>
                 <a:ext uri="{91240B29-F687-4f45-9708-019B960494DF}">
-                  <a14:hiddenLine xmlns="" xmlns:a14="http://schemas.microsoft.com/office/drawing/2010/main" w="9525">
+                  <a14:hiddenLine xmlns:a14="http://schemas.microsoft.com/office/drawing/2010/main" xmlns="" w="9525">
                     <a:solidFill>
                       <a:srgbClr val="000000"/>
                     </a:solidFill>
@@ -11817,7 +11820,7 @@
               </a:ln>
               <a:extLst>
                 <a:ext uri="{91240B29-F687-4f45-9708-019B960494DF}">
-                  <a14:hiddenLine xmlns="" xmlns:a14="http://schemas.microsoft.com/office/drawing/2010/main" w="9525">
+                  <a14:hiddenLine xmlns:a14="http://schemas.microsoft.com/office/drawing/2010/main" xmlns="" w="9525">
                     <a:solidFill>
                       <a:srgbClr val="000000"/>
                     </a:solidFill>
@@ -11907,7 +11910,7 @@
               </a:ln>
               <a:extLst>
                 <a:ext uri="{91240B29-F687-4f45-9708-019B960494DF}">
-                  <a14:hiddenLine xmlns="" xmlns:a14="http://schemas.microsoft.com/office/drawing/2010/main" w="9525">
+                  <a14:hiddenLine xmlns:a14="http://schemas.microsoft.com/office/drawing/2010/main" xmlns="" w="9525">
                     <a:solidFill>
                       <a:srgbClr val="000000"/>
                     </a:solidFill>
@@ -11972,7 +11975,7 @@
               </a:ln>
               <a:extLst>
                 <a:ext uri="{91240B29-F687-4f45-9708-019B960494DF}">
-                  <a14:hiddenLine xmlns="" xmlns:a14="http://schemas.microsoft.com/office/drawing/2010/main" w="9525">
+                  <a14:hiddenLine xmlns:a14="http://schemas.microsoft.com/office/drawing/2010/main" xmlns="" w="9525">
                     <a:solidFill>
                       <a:srgbClr val="000000"/>
                     </a:solidFill>
@@ -12062,7 +12065,7 @@
               </a:ln>
               <a:extLst>
                 <a:ext uri="{91240B29-F687-4f45-9708-019B960494DF}">
-                  <a14:hiddenLine xmlns="" xmlns:a14="http://schemas.microsoft.com/office/drawing/2010/main" w="9525">
+                  <a14:hiddenLine xmlns:a14="http://schemas.microsoft.com/office/drawing/2010/main" xmlns="" w="9525">
                     <a:solidFill>
                       <a:srgbClr val="000000"/>
                     </a:solidFill>
@@ -12130,7 +12133,7 @@
               </a:ln>
               <a:extLst>
                 <a:ext uri="{91240B29-F687-4f45-9708-019B960494DF}">
-                  <a14:hiddenLine xmlns="" xmlns:a14="http://schemas.microsoft.com/office/drawing/2010/main" w="9525">
+                  <a14:hiddenLine xmlns:a14="http://schemas.microsoft.com/office/drawing/2010/main" xmlns="" w="9525">
                     <a:solidFill>
                       <a:srgbClr val="000000"/>
                     </a:solidFill>
@@ -12220,7 +12223,7 @@
               </a:ln>
               <a:extLst>
                 <a:ext uri="{91240B29-F687-4f45-9708-019B960494DF}">
-                  <a14:hiddenLine xmlns="" xmlns:a14="http://schemas.microsoft.com/office/drawing/2010/main" w="9525">
+                  <a14:hiddenLine xmlns:a14="http://schemas.microsoft.com/office/drawing/2010/main" xmlns="" w="9525">
                     <a:solidFill>
                       <a:srgbClr val="000000"/>
                     </a:solidFill>
@@ -12288,7 +12291,7 @@
               </a:ln>
               <a:extLst>
                 <a:ext uri="{91240B29-F687-4f45-9708-019B960494DF}">
-                  <a14:hiddenLine xmlns="" xmlns:a14="http://schemas.microsoft.com/office/drawing/2010/main" w="9525">
+                  <a14:hiddenLine xmlns:a14="http://schemas.microsoft.com/office/drawing/2010/main" xmlns="" w="9525">
                     <a:solidFill>
                       <a:srgbClr val="000000"/>
                     </a:solidFill>
@@ -12378,7 +12381,7 @@
               </a:ln>
               <a:extLst>
                 <a:ext uri="{91240B29-F687-4f45-9708-019B960494DF}">
-                  <a14:hiddenLine xmlns="" xmlns:a14="http://schemas.microsoft.com/office/drawing/2010/main" w="9525">
+                  <a14:hiddenLine xmlns:a14="http://schemas.microsoft.com/office/drawing/2010/main" xmlns="" w="9525">
                     <a:solidFill>
                       <a:srgbClr val="000000"/>
                     </a:solidFill>
@@ -12412,7 +12415,7 @@
               </a:ln>
               <a:extLst>
                 <a:ext uri="{91240B29-F687-4f45-9708-019B960494DF}">
-                  <a14:hiddenLine xmlns="" xmlns:a14="http://schemas.microsoft.com/office/drawing/2010/main" w="9525">
+                  <a14:hiddenLine xmlns:a14="http://schemas.microsoft.com/office/drawing/2010/main" xmlns="" w="9525">
                     <a:solidFill>
                       <a:srgbClr val="000000"/>
                     </a:solidFill>
@@ -12552,7 +12555,7 @@
           <a:p>
             <a:fld id="{B3A65DBF-A9F0-C148-993C-2303F706A4CD}" type="datetimeFigureOut">
               <a:rPr lang="en-US" smtClean="0"/>
-              <a:t>12/27/2021</a:t>
+              <a:t>12/28/2021</a:t>
             </a:fld>
             <a:endParaRPr lang="en-US"/>
           </a:p>
@@ -13140,7 +13143,7 @@
             <a:noFill/>
             <a:extLst>
               <a:ext uri="{909E8E84-426E-40dd-AFC4-6F175D3DCCD1}">
-                <a14:hiddenFill xmlns:p14="http://schemas.microsoft.com/office/powerpoint/2010/main" xmlns:a14="http://schemas.microsoft.com/office/drawing/2010/main" xmlns:a16="http://schemas.microsoft.com/office/drawing/2014/main" xmlns="">
+                <a14:hiddenFill xmlns="" xmlns:a16="http://schemas.microsoft.com/office/drawing/2014/main" xmlns:a14="http://schemas.microsoft.com/office/drawing/2010/main" xmlns:p14="http://schemas.microsoft.com/office/powerpoint/2010/main">
                   <a:solidFill>
                     <a:srgbClr val="FFFFFF"/>
                   </a:solidFill>
@@ -13180,8 +13183,20 @@
           <a:p>
             <a:r>
               <a:rPr lang="en-US" dirty="0"/>
-              <a:t>CSC 119:Intro to Programming</a:t>
-            </a:r>
+              <a:t>CSC 119:Intro </a:t>
+            </a:r>
+            <a:r>
+              <a:rPr lang="en-US"/>
+              <a:t>to Programming</a:t>
+            </a:r>
+            <a:br>
+              <a:rPr lang="en-US"/>
+            </a:br>
+            <a:r>
+              <a:rPr lang="en-US"/>
+              <a:t>Lecture 1</a:t>
+            </a:r>
+            <a:endParaRPr lang="en-US" dirty="0"/>
           </a:p>
         </p:txBody>
       </p:sp>
@@ -13288,7 +13303,7 @@
             </a:ln>
             <a:extLst>
               <a:ext uri="{91240B29-F687-4f45-9708-019B960494DF}">
-                <a14:hiddenLine xmlns:p14="http://schemas.microsoft.com/office/powerpoint/2010/main" xmlns:a14="http://schemas.microsoft.com/office/drawing/2010/main" xmlns:a16="http://schemas.microsoft.com/office/drawing/2014/main" xmlns="" w="9525">
+                <a14:hiddenLine xmlns="" xmlns:a16="http://schemas.microsoft.com/office/drawing/2014/main" xmlns:a14="http://schemas.microsoft.com/office/drawing/2010/main" xmlns:p14="http://schemas.microsoft.com/office/powerpoint/2010/main" w="9525">
                   <a:solidFill>
                     <a:srgbClr val="000000"/>
                   </a:solidFill>
@@ -13393,7 +13408,7 @@
             </a:ln>
             <a:extLst>
               <a:ext uri="{91240B29-F687-4f45-9708-019B960494DF}">
-                <a14:hiddenLine xmlns:p14="http://schemas.microsoft.com/office/powerpoint/2010/main" xmlns:a14="http://schemas.microsoft.com/office/drawing/2010/main" xmlns:a16="http://schemas.microsoft.com/office/drawing/2014/main" xmlns="" w="9525">
+                <a14:hiddenLine xmlns="" xmlns:a16="http://schemas.microsoft.com/office/drawing/2014/main" xmlns:a14="http://schemas.microsoft.com/office/drawing/2010/main" xmlns:p14="http://schemas.microsoft.com/office/powerpoint/2010/main" w="9525">
                   <a:solidFill>
                     <a:srgbClr val="000000"/>
                   </a:solidFill>
@@ -13498,7 +13513,7 @@
             </a:ln>
             <a:extLst>
               <a:ext uri="{91240B29-F687-4f45-9708-019B960494DF}">
-                <a14:hiddenLine xmlns:p14="http://schemas.microsoft.com/office/powerpoint/2010/main" xmlns:a14="http://schemas.microsoft.com/office/drawing/2010/main" xmlns:a16="http://schemas.microsoft.com/office/drawing/2014/main" xmlns="" w="9525">
+                <a14:hiddenLine xmlns="" xmlns:a16="http://schemas.microsoft.com/office/drawing/2014/main" xmlns:a14="http://schemas.microsoft.com/office/drawing/2010/main" xmlns:p14="http://schemas.microsoft.com/office/powerpoint/2010/main" w="9525">
                   <a:solidFill>
                     <a:srgbClr val="000000"/>
                   </a:solidFill>
@@ -13547,7 +13562,7 @@
             </a:ln>
             <a:extLst>
               <a:ext uri="{91240B29-F687-4f45-9708-019B960494DF}">
-                <a14:hiddenLine xmlns:p14="http://schemas.microsoft.com/office/powerpoint/2010/main" xmlns:a14="http://schemas.microsoft.com/office/drawing/2010/main" xmlns:a16="http://schemas.microsoft.com/office/drawing/2014/main" xmlns="" w="9525">
+                <a14:hiddenLine xmlns="" xmlns:a16="http://schemas.microsoft.com/office/drawing/2014/main" xmlns:a14="http://schemas.microsoft.com/office/drawing/2010/main" xmlns:p14="http://schemas.microsoft.com/office/powerpoint/2010/main" w="9525">
                   <a:solidFill>
                     <a:srgbClr val="000000"/>
                   </a:solidFill>
@@ -13652,7 +13667,7 @@
             </a:ln>
             <a:extLst>
               <a:ext uri="{91240B29-F687-4f45-9708-019B960494DF}">
-                <a14:hiddenLine xmlns:p14="http://schemas.microsoft.com/office/powerpoint/2010/main" xmlns:a14="http://schemas.microsoft.com/office/drawing/2010/main" xmlns:a16="http://schemas.microsoft.com/office/drawing/2014/main" xmlns="" w="9525">
+                <a14:hiddenLine xmlns="" xmlns:a16="http://schemas.microsoft.com/office/drawing/2014/main" xmlns:a14="http://schemas.microsoft.com/office/drawing/2010/main" xmlns:p14="http://schemas.microsoft.com/office/powerpoint/2010/main" w="9525">
                   <a:solidFill>
                     <a:srgbClr val="000000"/>
                   </a:solidFill>
@@ -13729,7 +13744,7 @@
             </a:ln>
             <a:extLst>
               <a:ext uri="{91240B29-F687-4f45-9708-019B960494DF}">
-                <a14:hiddenLine xmlns:p14="http://schemas.microsoft.com/office/powerpoint/2010/main" xmlns:a14="http://schemas.microsoft.com/office/drawing/2010/main" xmlns:a16="http://schemas.microsoft.com/office/drawing/2014/main" xmlns="" w="9525">
+                <a14:hiddenLine xmlns="" xmlns:a16="http://schemas.microsoft.com/office/drawing/2014/main" xmlns:a14="http://schemas.microsoft.com/office/drawing/2010/main" xmlns:p14="http://schemas.microsoft.com/office/powerpoint/2010/main" w="9525">
                   <a:solidFill>
                     <a:srgbClr val="000000"/>
                   </a:solidFill>
@@ -13806,7 +13821,7 @@
             </a:ln>
             <a:extLst>
               <a:ext uri="{91240B29-F687-4f45-9708-019B960494DF}">
-                <a14:hiddenLine xmlns:p14="http://schemas.microsoft.com/office/powerpoint/2010/main" xmlns:a14="http://schemas.microsoft.com/office/drawing/2010/main" xmlns:a16="http://schemas.microsoft.com/office/drawing/2014/main" xmlns="" w="9525">
+                <a14:hiddenLine xmlns="" xmlns:a16="http://schemas.microsoft.com/office/drawing/2014/main" xmlns:a14="http://schemas.microsoft.com/office/drawing/2010/main" xmlns:p14="http://schemas.microsoft.com/office/powerpoint/2010/main" w="9525">
                   <a:solidFill>
                     <a:srgbClr val="000000"/>
                   </a:solidFill>
@@ -13911,7 +13926,7 @@
             </a:ln>
             <a:extLst>
               <a:ext uri="{91240B29-F687-4f45-9708-019B960494DF}">
-                <a14:hiddenLine xmlns:p14="http://schemas.microsoft.com/office/powerpoint/2010/main" xmlns:a14="http://schemas.microsoft.com/office/drawing/2010/main" xmlns:a16="http://schemas.microsoft.com/office/drawing/2014/main" xmlns="" w="9525">
+                <a14:hiddenLine xmlns="" xmlns:a16="http://schemas.microsoft.com/office/drawing/2014/main" xmlns:a14="http://schemas.microsoft.com/office/drawing/2010/main" xmlns:p14="http://schemas.microsoft.com/office/powerpoint/2010/main" w="9525">
                   <a:solidFill>
                     <a:srgbClr val="000000"/>
                   </a:solidFill>
@@ -13988,7 +14003,7 @@
             </a:ln>
             <a:extLst>
               <a:ext uri="{91240B29-F687-4f45-9708-019B960494DF}">
-                <a14:hiddenLine xmlns:p14="http://schemas.microsoft.com/office/powerpoint/2010/main" xmlns:a14="http://schemas.microsoft.com/office/drawing/2010/main" xmlns:a16="http://schemas.microsoft.com/office/drawing/2014/main" xmlns="" w="9525">
+                <a14:hiddenLine xmlns="" xmlns:a16="http://schemas.microsoft.com/office/drawing/2014/main" xmlns:a14="http://schemas.microsoft.com/office/drawing/2010/main" xmlns:p14="http://schemas.microsoft.com/office/powerpoint/2010/main" w="9525">
                   <a:solidFill>
                     <a:srgbClr val="000000"/>
                   </a:solidFill>
@@ -14065,7 +14080,7 @@
             </a:ln>
             <a:extLst>
               <a:ext uri="{91240B29-F687-4f45-9708-019B960494DF}">
-                <a14:hiddenLine xmlns:p14="http://schemas.microsoft.com/office/powerpoint/2010/main" xmlns:a14="http://schemas.microsoft.com/office/drawing/2010/main" xmlns:a16="http://schemas.microsoft.com/office/drawing/2014/main" xmlns="" w="9525">
+                <a14:hiddenLine xmlns="" xmlns:a16="http://schemas.microsoft.com/office/drawing/2014/main" xmlns:a14="http://schemas.microsoft.com/office/drawing/2010/main" xmlns:p14="http://schemas.microsoft.com/office/powerpoint/2010/main" w="9525">
                   <a:solidFill>
                     <a:srgbClr val="000000"/>
                   </a:solidFill>
@@ -14170,7 +14185,7 @@
             </a:ln>
             <a:extLst>
               <a:ext uri="{91240B29-F687-4f45-9708-019B960494DF}">
-                <a14:hiddenLine xmlns:p14="http://schemas.microsoft.com/office/powerpoint/2010/main" xmlns:a14="http://schemas.microsoft.com/office/drawing/2010/main" xmlns:a16="http://schemas.microsoft.com/office/drawing/2014/main" xmlns="" w="9525">
+                <a14:hiddenLine xmlns="" xmlns:a16="http://schemas.microsoft.com/office/drawing/2014/main" xmlns:a14="http://schemas.microsoft.com/office/drawing/2010/main" xmlns:p14="http://schemas.microsoft.com/office/powerpoint/2010/main" w="9525">
                   <a:solidFill>
                     <a:srgbClr val="000000"/>
                   </a:solidFill>
@@ -14275,7 +14290,7 @@
             </a:ln>
             <a:extLst>
               <a:ext uri="{91240B29-F687-4f45-9708-019B960494DF}">
-                <a14:hiddenLine xmlns:p14="http://schemas.microsoft.com/office/powerpoint/2010/main" xmlns:a14="http://schemas.microsoft.com/office/drawing/2010/main" xmlns:a16="http://schemas.microsoft.com/office/drawing/2014/main" xmlns="" w="9525">
+                <a14:hiddenLine xmlns="" xmlns:a16="http://schemas.microsoft.com/office/drawing/2014/main" xmlns:a14="http://schemas.microsoft.com/office/drawing/2010/main" xmlns:p14="http://schemas.microsoft.com/office/powerpoint/2010/main" w="9525">
                   <a:solidFill>
                     <a:srgbClr val="000000"/>
                   </a:solidFill>
@@ -14352,7 +14367,7 @@
             </a:ln>
             <a:extLst>
               <a:ext uri="{91240B29-F687-4f45-9708-019B960494DF}">
-                <a14:hiddenLine xmlns:p14="http://schemas.microsoft.com/office/powerpoint/2010/main" xmlns:a14="http://schemas.microsoft.com/office/drawing/2010/main" xmlns:a16="http://schemas.microsoft.com/office/drawing/2014/main" xmlns="" w="9525">
+                <a14:hiddenLine xmlns="" xmlns:a16="http://schemas.microsoft.com/office/drawing/2014/main" xmlns:a14="http://schemas.microsoft.com/office/drawing/2010/main" xmlns:p14="http://schemas.microsoft.com/office/powerpoint/2010/main" w="9525">
                   <a:solidFill>
                     <a:srgbClr val="000000"/>
                   </a:solidFill>
@@ -14477,7 +14492,7 @@
             </a:ln>
             <a:extLst>
               <a:ext uri="{91240B29-F687-4f45-9708-019B960494DF}">
-                <a14:hiddenLine xmlns:p14="http://schemas.microsoft.com/office/powerpoint/2010/main" xmlns:a14="http://schemas.microsoft.com/office/drawing/2010/main" xmlns:a16="http://schemas.microsoft.com/office/drawing/2014/main" xmlns="" w="9525">
+                <a14:hiddenLine xmlns="" xmlns:a16="http://schemas.microsoft.com/office/drawing/2014/main" xmlns:a14="http://schemas.microsoft.com/office/drawing/2010/main" xmlns:p14="http://schemas.microsoft.com/office/powerpoint/2010/main" w="9525">
                   <a:solidFill>
                     <a:srgbClr val="000000"/>
                   </a:solidFill>
@@ -14554,7 +14569,7 @@
             </a:ln>
             <a:extLst>
               <a:ext uri="{91240B29-F687-4f45-9708-019B960494DF}">
-                <a14:hiddenLine xmlns:p14="http://schemas.microsoft.com/office/powerpoint/2010/main" xmlns:a14="http://schemas.microsoft.com/office/drawing/2010/main" xmlns:a16="http://schemas.microsoft.com/office/drawing/2014/main" xmlns="" w="9525">
+                <a14:hiddenLine xmlns="" xmlns:a16="http://schemas.microsoft.com/office/drawing/2014/main" xmlns:a14="http://schemas.microsoft.com/office/drawing/2010/main" xmlns:p14="http://schemas.microsoft.com/office/powerpoint/2010/main" w="9525">
                   <a:solidFill>
                     <a:srgbClr val="000000"/>
                   </a:solidFill>
@@ -14659,7 +14674,7 @@
             </a:ln>
             <a:extLst>
               <a:ext uri="{91240B29-F687-4f45-9708-019B960494DF}">
-                <a14:hiddenLine xmlns:p14="http://schemas.microsoft.com/office/powerpoint/2010/main" xmlns:a14="http://schemas.microsoft.com/office/drawing/2010/main" xmlns:a16="http://schemas.microsoft.com/office/drawing/2014/main" xmlns="" w="9525">
+                <a14:hiddenLine xmlns="" xmlns:a16="http://schemas.microsoft.com/office/drawing/2014/main" xmlns:a14="http://schemas.microsoft.com/office/drawing/2010/main" xmlns:p14="http://schemas.microsoft.com/office/powerpoint/2010/main" w="9525">
                   <a:solidFill>
                     <a:srgbClr val="000000"/>
                   </a:solidFill>
@@ -14764,7 +14779,7 @@
             </a:ln>
             <a:extLst>
               <a:ext uri="{91240B29-F687-4f45-9708-019B960494DF}">
-                <a14:hiddenLine xmlns:p14="http://schemas.microsoft.com/office/powerpoint/2010/main" xmlns:a14="http://schemas.microsoft.com/office/drawing/2010/main" xmlns:a16="http://schemas.microsoft.com/office/drawing/2014/main" xmlns="" w="9525">
+                <a14:hiddenLine xmlns="" xmlns:a16="http://schemas.microsoft.com/office/drawing/2014/main" xmlns:a14="http://schemas.microsoft.com/office/drawing/2010/main" xmlns:p14="http://schemas.microsoft.com/office/powerpoint/2010/main" w="9525">
                   <a:solidFill>
                     <a:srgbClr val="000000"/>
                   </a:solidFill>
@@ -14841,7 +14856,7 @@
             </a:ln>
             <a:extLst>
               <a:ext uri="{91240B29-F687-4f45-9708-019B960494DF}">
-                <a14:hiddenLine xmlns:p14="http://schemas.microsoft.com/office/powerpoint/2010/main" xmlns:a14="http://schemas.microsoft.com/office/drawing/2010/main" xmlns:a16="http://schemas.microsoft.com/office/drawing/2014/main" xmlns="" w="9525">
+                <a14:hiddenLine xmlns="" xmlns:a16="http://schemas.microsoft.com/office/drawing/2014/main" xmlns:a14="http://schemas.microsoft.com/office/drawing/2010/main" xmlns:p14="http://schemas.microsoft.com/office/powerpoint/2010/main" w="9525">
                   <a:solidFill>
                     <a:srgbClr val="000000"/>
                   </a:solidFill>
@@ -14946,7 +14961,7 @@
             </a:ln>
             <a:extLst>
               <a:ext uri="{91240B29-F687-4f45-9708-019B960494DF}">
-                <a14:hiddenLine xmlns:p14="http://schemas.microsoft.com/office/powerpoint/2010/main" xmlns:a14="http://schemas.microsoft.com/office/drawing/2010/main" xmlns:a16="http://schemas.microsoft.com/office/drawing/2014/main" xmlns="" w="9525">
+                <a14:hiddenLine xmlns="" xmlns:a16="http://schemas.microsoft.com/office/drawing/2014/main" xmlns:a14="http://schemas.microsoft.com/office/drawing/2010/main" xmlns:p14="http://schemas.microsoft.com/office/powerpoint/2010/main" w="9525">
                   <a:solidFill>
                     <a:srgbClr val="000000"/>
                   </a:solidFill>
@@ -15051,7 +15066,7 @@
             </a:ln>
             <a:extLst>
               <a:ext uri="{91240B29-F687-4f45-9708-019B960494DF}">
-                <a14:hiddenLine xmlns:p14="http://schemas.microsoft.com/office/powerpoint/2010/main" xmlns:a14="http://schemas.microsoft.com/office/drawing/2010/main" xmlns:a16="http://schemas.microsoft.com/office/drawing/2014/main" xmlns="" w="9525">
+                <a14:hiddenLine xmlns="" xmlns:a16="http://schemas.microsoft.com/office/drawing/2014/main" xmlns:a14="http://schemas.microsoft.com/office/drawing/2010/main" xmlns:p14="http://schemas.microsoft.com/office/powerpoint/2010/main" w="9525">
                   <a:solidFill>
                     <a:srgbClr val="000000"/>
                   </a:solidFill>
@@ -15122,7 +15137,7 @@
             </a:ln>
             <a:extLst>
               <a:ext uri="{91240B29-F687-4f45-9708-019B960494DF}">
-                <a14:hiddenLine xmlns:p14="http://schemas.microsoft.com/office/powerpoint/2010/main" xmlns:a14="http://schemas.microsoft.com/office/drawing/2010/main" xmlns:a16="http://schemas.microsoft.com/office/drawing/2014/main" xmlns="" w="9525">
+                <a14:hiddenLine xmlns="" xmlns:a16="http://schemas.microsoft.com/office/drawing/2014/main" xmlns:a14="http://schemas.microsoft.com/office/drawing/2010/main" xmlns:p14="http://schemas.microsoft.com/office/powerpoint/2010/main" w="9525">
                   <a:solidFill>
                     <a:srgbClr val="000000"/>
                   </a:solidFill>
@@ -15227,7 +15242,7 @@
             </a:ln>
             <a:extLst>
               <a:ext uri="{91240B29-F687-4f45-9708-019B960494DF}">
-                <a14:hiddenLine xmlns:p14="http://schemas.microsoft.com/office/powerpoint/2010/main" xmlns:a14="http://schemas.microsoft.com/office/drawing/2010/main" xmlns:a16="http://schemas.microsoft.com/office/drawing/2014/main" xmlns="" w="9525">
+                <a14:hiddenLine xmlns="" xmlns:a16="http://schemas.microsoft.com/office/drawing/2014/main" xmlns:a14="http://schemas.microsoft.com/office/drawing/2010/main" xmlns:p14="http://schemas.microsoft.com/office/powerpoint/2010/main" w="9525">
                   <a:solidFill>
                     <a:srgbClr val="000000"/>
                   </a:solidFill>
@@ -15298,7 +15313,7 @@
             </a:ln>
             <a:extLst>
               <a:ext uri="{91240B29-F687-4f45-9708-019B960494DF}">
-                <a14:hiddenLine xmlns:p14="http://schemas.microsoft.com/office/powerpoint/2010/main" xmlns:a14="http://schemas.microsoft.com/office/drawing/2010/main" xmlns:a16="http://schemas.microsoft.com/office/drawing/2014/main" xmlns="" w="9525">
+                <a14:hiddenLine xmlns="" xmlns:a16="http://schemas.microsoft.com/office/drawing/2014/main" xmlns:a14="http://schemas.microsoft.com/office/drawing/2010/main" xmlns:p14="http://schemas.microsoft.com/office/powerpoint/2010/main" w="9525">
                   <a:solidFill>
                     <a:srgbClr val="000000"/>
                   </a:solidFill>
@@ -15403,7 +15418,7 @@
             </a:ln>
             <a:extLst>
               <a:ext uri="{91240B29-F687-4f45-9708-019B960494DF}">
-                <a14:hiddenLine xmlns:p14="http://schemas.microsoft.com/office/powerpoint/2010/main" xmlns:a14="http://schemas.microsoft.com/office/drawing/2010/main" xmlns:a16="http://schemas.microsoft.com/office/drawing/2014/main" xmlns="" w="9525">
+                <a14:hiddenLine xmlns="" xmlns:a16="http://schemas.microsoft.com/office/drawing/2014/main" xmlns:a14="http://schemas.microsoft.com/office/drawing/2010/main" xmlns:p14="http://schemas.microsoft.com/office/powerpoint/2010/main" w="9525">
                   <a:solidFill>
                     <a:srgbClr val="000000"/>
                   </a:solidFill>
@@ -15486,7 +15501,7 @@
             </a:ln>
             <a:extLst>
               <a:ext uri="{91240B29-F687-4f45-9708-019B960494DF}">
-                <a14:hiddenLine xmlns:p14="http://schemas.microsoft.com/office/powerpoint/2010/main" xmlns:a14="http://schemas.microsoft.com/office/drawing/2010/main" xmlns:a16="http://schemas.microsoft.com/office/drawing/2014/main" xmlns="" w="9525">
+                <a14:hiddenLine xmlns="" xmlns:a16="http://schemas.microsoft.com/office/drawing/2014/main" xmlns:a14="http://schemas.microsoft.com/office/drawing/2010/main" xmlns:p14="http://schemas.microsoft.com/office/powerpoint/2010/main" w="9525">
                   <a:solidFill>
                     <a:srgbClr val="000000"/>
                   </a:solidFill>
@@ -15591,7 +15606,7 @@
             </a:ln>
             <a:extLst>
               <a:ext uri="{91240B29-F687-4f45-9708-019B960494DF}">
-                <a14:hiddenLine xmlns:p14="http://schemas.microsoft.com/office/powerpoint/2010/main" xmlns:a14="http://schemas.microsoft.com/office/drawing/2010/main" xmlns:a16="http://schemas.microsoft.com/office/drawing/2014/main" xmlns="" w="9525">
+                <a14:hiddenLine xmlns="" xmlns:a16="http://schemas.microsoft.com/office/drawing/2014/main" xmlns:a14="http://schemas.microsoft.com/office/drawing/2010/main" xmlns:p14="http://schemas.microsoft.com/office/powerpoint/2010/main" w="9525">
                   <a:solidFill>
                     <a:srgbClr val="000000"/>
                   </a:solidFill>
@@ -15674,7 +15689,7 @@
             </a:ln>
             <a:extLst>
               <a:ext uri="{91240B29-F687-4f45-9708-019B960494DF}">
-                <a14:hiddenLine xmlns:p14="http://schemas.microsoft.com/office/powerpoint/2010/main" xmlns:a14="http://schemas.microsoft.com/office/drawing/2010/main" xmlns:a16="http://schemas.microsoft.com/office/drawing/2014/main" xmlns="" w="9525">
+                <a14:hiddenLine xmlns="" xmlns:a16="http://schemas.microsoft.com/office/drawing/2014/main" xmlns:a14="http://schemas.microsoft.com/office/drawing/2010/main" xmlns:p14="http://schemas.microsoft.com/office/powerpoint/2010/main" w="9525">
                   <a:solidFill>
                     <a:srgbClr val="000000"/>
                   </a:solidFill>
@@ -15779,7 +15794,7 @@
             </a:ln>
             <a:extLst>
               <a:ext uri="{91240B29-F687-4f45-9708-019B960494DF}">
-                <a14:hiddenLine xmlns:p14="http://schemas.microsoft.com/office/powerpoint/2010/main" xmlns:a14="http://schemas.microsoft.com/office/drawing/2010/main" xmlns:a16="http://schemas.microsoft.com/office/drawing/2014/main" xmlns="" w="9525">
+                <a14:hiddenLine xmlns="" xmlns:a16="http://schemas.microsoft.com/office/drawing/2014/main" xmlns:a14="http://schemas.microsoft.com/office/drawing/2010/main" xmlns:p14="http://schemas.microsoft.com/office/powerpoint/2010/main" w="9525">
                   <a:solidFill>
                     <a:srgbClr val="000000"/>
                   </a:solidFill>
@@ -15828,7 +15843,7 @@
             </a:ln>
             <a:extLst>
               <a:ext uri="{91240B29-F687-4f45-9708-019B960494DF}">
-                <a14:hiddenLine xmlns:p14="http://schemas.microsoft.com/office/powerpoint/2010/main" xmlns:a14="http://schemas.microsoft.com/office/drawing/2010/main" xmlns:a16="http://schemas.microsoft.com/office/drawing/2014/main" xmlns="" w="9525">
+                <a14:hiddenLine xmlns="" xmlns:a16="http://schemas.microsoft.com/office/drawing/2014/main" xmlns:a14="http://schemas.microsoft.com/office/drawing/2010/main" xmlns:p14="http://schemas.microsoft.com/office/powerpoint/2010/main" w="9525">
                   <a:solidFill>
                     <a:srgbClr val="000000"/>
                   </a:solidFill>
@@ -15933,7 +15948,7 @@
             </a:ln>
             <a:extLst>
               <a:ext uri="{91240B29-F687-4f45-9708-019B960494DF}">
-                <a14:hiddenLine xmlns:p14="http://schemas.microsoft.com/office/powerpoint/2010/main" xmlns:a14="http://schemas.microsoft.com/office/drawing/2010/main" xmlns:a16="http://schemas.microsoft.com/office/drawing/2014/main" xmlns="" w="9525">
+                <a14:hiddenLine xmlns="" xmlns:a16="http://schemas.microsoft.com/office/drawing/2014/main" xmlns:a14="http://schemas.microsoft.com/office/drawing/2010/main" xmlns:p14="http://schemas.microsoft.com/office/powerpoint/2010/main" w="9525">
                   <a:solidFill>
                     <a:srgbClr val="000000"/>
                   </a:solidFill>
@@ -16010,7 +16025,7 @@
             </a:ln>
             <a:extLst>
               <a:ext uri="{91240B29-F687-4f45-9708-019B960494DF}">
-                <a14:hiddenLine xmlns:p14="http://schemas.microsoft.com/office/powerpoint/2010/main" xmlns:a14="http://schemas.microsoft.com/office/drawing/2010/main" xmlns:a16="http://schemas.microsoft.com/office/drawing/2014/main" xmlns="" w="9525">
+                <a14:hiddenLine xmlns="" xmlns:a16="http://schemas.microsoft.com/office/drawing/2014/main" xmlns:a14="http://schemas.microsoft.com/office/drawing/2010/main" xmlns:p14="http://schemas.microsoft.com/office/powerpoint/2010/main" w="9525">
                   <a:solidFill>
                     <a:srgbClr val="000000"/>
                   </a:solidFill>
@@ -16087,7 +16102,7 @@
             </a:ln>
             <a:extLst>
               <a:ext uri="{91240B29-F687-4f45-9708-019B960494DF}">
-                <a14:hiddenLine xmlns:p14="http://schemas.microsoft.com/office/powerpoint/2010/main" xmlns:a14="http://schemas.microsoft.com/office/drawing/2010/main" xmlns:a16="http://schemas.microsoft.com/office/drawing/2014/main" xmlns="" w="9525">
+                <a14:hiddenLine xmlns="" xmlns:a16="http://schemas.microsoft.com/office/drawing/2014/main" xmlns:a14="http://schemas.microsoft.com/office/drawing/2010/main" xmlns:p14="http://schemas.microsoft.com/office/powerpoint/2010/main" w="9525">
                   <a:solidFill>
                     <a:srgbClr val="000000"/>
                   </a:solidFill>
@@ -16192,7 +16207,7 @@
             </a:ln>
             <a:extLst>
               <a:ext uri="{91240B29-F687-4f45-9708-019B960494DF}">
-                <a14:hiddenLine xmlns:p14="http://schemas.microsoft.com/office/powerpoint/2010/main" xmlns:a14="http://schemas.microsoft.com/office/drawing/2010/main" xmlns:a16="http://schemas.microsoft.com/office/drawing/2014/main" xmlns="" w="9525">
+                <a14:hiddenLine xmlns="" xmlns:a16="http://schemas.microsoft.com/office/drawing/2014/main" xmlns:a14="http://schemas.microsoft.com/office/drawing/2010/main" xmlns:p14="http://schemas.microsoft.com/office/powerpoint/2010/main" w="9525">
                   <a:solidFill>
                     <a:srgbClr val="000000"/>
                   </a:solidFill>
@@ -16275,7 +16290,7 @@
             </a:ln>
             <a:extLst>
               <a:ext uri="{91240B29-F687-4f45-9708-019B960494DF}">
-                <a14:hiddenLine xmlns:p14="http://schemas.microsoft.com/office/powerpoint/2010/main" xmlns:a14="http://schemas.microsoft.com/office/drawing/2010/main" xmlns:a16="http://schemas.microsoft.com/office/drawing/2014/main" xmlns="" w="9525">
+                <a14:hiddenLine xmlns="" xmlns:a16="http://schemas.microsoft.com/office/drawing/2014/main" xmlns:a14="http://schemas.microsoft.com/office/drawing/2010/main" xmlns:p14="http://schemas.microsoft.com/office/powerpoint/2010/main" w="9525">
                   <a:solidFill>
                     <a:srgbClr val="000000"/>
                   </a:solidFill>
@@ -16352,7 +16367,7 @@
             </a:ln>
             <a:extLst>
               <a:ext uri="{91240B29-F687-4f45-9708-019B960494DF}">
-                <a14:hiddenLine xmlns:p14="http://schemas.microsoft.com/office/powerpoint/2010/main" xmlns:a14="http://schemas.microsoft.com/office/drawing/2010/main" xmlns:a16="http://schemas.microsoft.com/office/drawing/2014/main" xmlns="" w="9525">
+                <a14:hiddenLine xmlns="" xmlns:a16="http://schemas.microsoft.com/office/drawing/2014/main" xmlns:a14="http://schemas.microsoft.com/office/drawing/2010/main" xmlns:p14="http://schemas.microsoft.com/office/powerpoint/2010/main" w="9525">
                   <a:solidFill>
                     <a:srgbClr val="000000"/>
                   </a:solidFill>
@@ -16457,7 +16472,7 @@
             </a:ln>
             <a:extLst>
               <a:ext uri="{91240B29-F687-4f45-9708-019B960494DF}">
-                <a14:hiddenLine xmlns:p14="http://schemas.microsoft.com/office/powerpoint/2010/main" xmlns:a14="http://schemas.microsoft.com/office/drawing/2010/main" xmlns:a16="http://schemas.microsoft.com/office/drawing/2014/main" xmlns="" w="9525">
+                <a14:hiddenLine xmlns="" xmlns:a16="http://schemas.microsoft.com/office/drawing/2014/main" xmlns:a14="http://schemas.microsoft.com/office/drawing/2010/main" xmlns:p14="http://schemas.microsoft.com/office/powerpoint/2010/main" w="9525">
                   <a:solidFill>
                     <a:srgbClr val="000000"/>
                   </a:solidFill>
@@ -16534,7 +16549,7 @@
             </a:ln>
             <a:extLst>
               <a:ext uri="{91240B29-F687-4f45-9708-019B960494DF}">
-                <a14:hiddenLine xmlns:p14="http://schemas.microsoft.com/office/powerpoint/2010/main" xmlns:a14="http://schemas.microsoft.com/office/drawing/2010/main" xmlns:a16="http://schemas.microsoft.com/office/drawing/2014/main" xmlns="" w="9525">
+                <a14:hiddenLine xmlns="" xmlns:a16="http://schemas.microsoft.com/office/drawing/2014/main" xmlns:a14="http://schemas.microsoft.com/office/drawing/2010/main" xmlns:p14="http://schemas.microsoft.com/office/powerpoint/2010/main" w="9525">
                   <a:solidFill>
                     <a:srgbClr val="000000"/>
                   </a:solidFill>
@@ -16639,7 +16654,7 @@
             </a:ln>
             <a:extLst>
               <a:ext uri="{91240B29-F687-4f45-9708-019B960494DF}">
-                <a14:hiddenLine xmlns:p14="http://schemas.microsoft.com/office/powerpoint/2010/main" xmlns:a14="http://schemas.microsoft.com/office/drawing/2010/main" xmlns:a16="http://schemas.microsoft.com/office/drawing/2014/main" xmlns="" w="9525">
+                <a14:hiddenLine xmlns="" xmlns:a16="http://schemas.microsoft.com/office/drawing/2014/main" xmlns:a14="http://schemas.microsoft.com/office/drawing/2010/main" xmlns:p14="http://schemas.microsoft.com/office/powerpoint/2010/main" w="9525">
                   <a:solidFill>
                     <a:srgbClr val="000000"/>
                   </a:solidFill>
@@ -16716,7 +16731,7 @@
             </a:ln>
             <a:extLst>
               <a:ext uri="{91240B29-F687-4f45-9708-019B960494DF}">
-                <a14:hiddenLine xmlns:p14="http://schemas.microsoft.com/office/powerpoint/2010/main" xmlns:a14="http://schemas.microsoft.com/office/drawing/2010/main" xmlns:a16="http://schemas.microsoft.com/office/drawing/2014/main" xmlns="" w="9525">
+                <a14:hiddenLine xmlns="" xmlns:a16="http://schemas.microsoft.com/office/drawing/2014/main" xmlns:a14="http://schemas.microsoft.com/office/drawing/2010/main" xmlns:p14="http://schemas.microsoft.com/office/powerpoint/2010/main" w="9525">
                   <a:solidFill>
                     <a:srgbClr val="000000"/>
                   </a:solidFill>
@@ -16821,7 +16836,7 @@
             </a:ln>
             <a:extLst>
               <a:ext uri="{91240B29-F687-4f45-9708-019B960494DF}">
-                <a14:hiddenLine xmlns:p14="http://schemas.microsoft.com/office/powerpoint/2010/main" xmlns:a14="http://schemas.microsoft.com/office/drawing/2010/main" xmlns:a16="http://schemas.microsoft.com/office/drawing/2014/main" xmlns="" w="9525">
+                <a14:hiddenLine xmlns="" xmlns:a16="http://schemas.microsoft.com/office/drawing/2014/main" xmlns:a14="http://schemas.microsoft.com/office/drawing/2010/main" xmlns:p14="http://schemas.microsoft.com/office/powerpoint/2010/main" w="9525">
                   <a:solidFill>
                     <a:srgbClr val="000000"/>
                   </a:solidFill>
@@ -16870,7 +16885,7 @@
             </a:ln>
             <a:extLst>
               <a:ext uri="{91240B29-F687-4f45-9708-019B960494DF}">
-                <a14:hiddenLine xmlns:p14="http://schemas.microsoft.com/office/powerpoint/2010/main" xmlns:a14="http://schemas.microsoft.com/office/drawing/2010/main" xmlns:a16="http://schemas.microsoft.com/office/drawing/2014/main" xmlns="" w="9525">
+                <a14:hiddenLine xmlns="" xmlns:a16="http://schemas.microsoft.com/office/drawing/2014/main" xmlns:a14="http://schemas.microsoft.com/office/drawing/2010/main" xmlns:p14="http://schemas.microsoft.com/office/powerpoint/2010/main" w="9525">
                   <a:solidFill>
                     <a:srgbClr val="000000"/>
                   </a:solidFill>
@@ -16950,7 +16965,7 @@
             </a:ln>
             <a:extLst>
               <a:ext uri="{91240B29-F687-4f45-9708-019B960494DF}">
-                <a14:hiddenLine xmlns:p14="http://schemas.microsoft.com/office/powerpoint/2010/main" xmlns:a14="http://schemas.microsoft.com/office/drawing/2010/main" xmlns:a16="http://schemas.microsoft.com/office/drawing/2014/main" xmlns="" w="9525">
+                <a14:hiddenLine xmlns="" xmlns:a16="http://schemas.microsoft.com/office/drawing/2014/main" xmlns:a14="http://schemas.microsoft.com/office/drawing/2010/main" xmlns:p14="http://schemas.microsoft.com/office/powerpoint/2010/main" w="9525">
                   <a:solidFill>
                     <a:srgbClr val="000000"/>
                   </a:solidFill>
@@ -17055,7 +17070,7 @@
             </a:ln>
             <a:extLst>
               <a:ext uri="{91240B29-F687-4f45-9708-019B960494DF}">
-                <a14:hiddenLine xmlns:p14="http://schemas.microsoft.com/office/powerpoint/2010/main" xmlns:a14="http://schemas.microsoft.com/office/drawing/2010/main" xmlns:a16="http://schemas.microsoft.com/office/drawing/2014/main" xmlns="" w="9525">
+                <a14:hiddenLine xmlns="" xmlns:a16="http://schemas.microsoft.com/office/drawing/2014/main" xmlns:a14="http://schemas.microsoft.com/office/drawing/2010/main" xmlns:p14="http://schemas.microsoft.com/office/powerpoint/2010/main" w="9525">
                   <a:solidFill>
                     <a:srgbClr val="000000"/>
                   </a:solidFill>
@@ -17132,7 +17147,7 @@
             </a:ln>
             <a:extLst>
               <a:ext uri="{91240B29-F687-4f45-9708-019B960494DF}">
-                <a14:hiddenLine xmlns:p14="http://schemas.microsoft.com/office/powerpoint/2010/main" xmlns:a14="http://schemas.microsoft.com/office/drawing/2010/main" xmlns:a16="http://schemas.microsoft.com/office/drawing/2014/main" xmlns="" w="9525">
+                <a14:hiddenLine xmlns="" xmlns:a16="http://schemas.microsoft.com/office/drawing/2014/main" xmlns:a14="http://schemas.microsoft.com/office/drawing/2010/main" xmlns:p14="http://schemas.microsoft.com/office/powerpoint/2010/main" w="9525">
                   <a:solidFill>
                     <a:srgbClr val="000000"/>
                   </a:solidFill>
@@ -17237,7 +17252,7 @@
             </a:ln>
             <a:extLst>
               <a:ext uri="{91240B29-F687-4f45-9708-019B960494DF}">
-                <a14:hiddenLine xmlns:p14="http://schemas.microsoft.com/office/powerpoint/2010/main" xmlns:a14="http://schemas.microsoft.com/office/drawing/2010/main" xmlns:a16="http://schemas.microsoft.com/office/drawing/2014/main" xmlns="" w="9525">
+                <a14:hiddenLine xmlns="" xmlns:a16="http://schemas.microsoft.com/office/drawing/2014/main" xmlns:a14="http://schemas.microsoft.com/office/drawing/2010/main" xmlns:p14="http://schemas.microsoft.com/office/powerpoint/2010/main" w="9525">
                   <a:solidFill>
                     <a:srgbClr val="000000"/>
                   </a:solidFill>
@@ -17342,7 +17357,7 @@
             </a:ln>
             <a:extLst>
               <a:ext uri="{91240B29-F687-4f45-9708-019B960494DF}">
-                <a14:hiddenLine xmlns:p14="http://schemas.microsoft.com/office/powerpoint/2010/main" xmlns:a14="http://schemas.microsoft.com/office/drawing/2010/main" xmlns:a16="http://schemas.microsoft.com/office/drawing/2014/main" xmlns="" w="9525">
+                <a14:hiddenLine xmlns="" xmlns:a16="http://schemas.microsoft.com/office/drawing/2014/main" xmlns:a14="http://schemas.microsoft.com/office/drawing/2010/main" xmlns:p14="http://schemas.microsoft.com/office/powerpoint/2010/main" w="9525">
                   <a:solidFill>
                     <a:srgbClr val="000000"/>
                   </a:solidFill>
@@ -17422,7 +17437,7 @@
             </a:ln>
             <a:extLst>
               <a:ext uri="{91240B29-F687-4f45-9708-019B960494DF}">
-                <a14:hiddenLine xmlns:p14="http://schemas.microsoft.com/office/powerpoint/2010/main" xmlns:a14="http://schemas.microsoft.com/office/drawing/2010/main" xmlns:a16="http://schemas.microsoft.com/office/drawing/2014/main" xmlns="" w="9525">
+                <a14:hiddenLine xmlns="" xmlns:a16="http://schemas.microsoft.com/office/drawing/2014/main" xmlns:a14="http://schemas.microsoft.com/office/drawing/2010/main" xmlns:p14="http://schemas.microsoft.com/office/powerpoint/2010/main" w="9525">
                   <a:solidFill>
                     <a:srgbClr val="000000"/>
                   </a:solidFill>
@@ -17499,7 +17514,7 @@
             </a:ln>
             <a:extLst>
               <a:ext uri="{91240B29-F687-4f45-9708-019B960494DF}">
-                <a14:hiddenLine xmlns:p14="http://schemas.microsoft.com/office/powerpoint/2010/main" xmlns:a14="http://schemas.microsoft.com/office/drawing/2010/main" xmlns:a16="http://schemas.microsoft.com/office/drawing/2014/main" xmlns="" w="9525">
+                <a14:hiddenLine xmlns="" xmlns:a16="http://schemas.microsoft.com/office/drawing/2014/main" xmlns:a14="http://schemas.microsoft.com/office/drawing/2010/main" xmlns:p14="http://schemas.microsoft.com/office/powerpoint/2010/main" w="9525">
                   <a:solidFill>
                     <a:srgbClr val="000000"/>
                   </a:solidFill>
@@ -17604,7 +17619,7 @@
             </a:ln>
             <a:extLst>
               <a:ext uri="{91240B29-F687-4f45-9708-019B960494DF}">
-                <a14:hiddenLine xmlns:p14="http://schemas.microsoft.com/office/powerpoint/2010/main" xmlns:a14="http://schemas.microsoft.com/office/drawing/2010/main" xmlns:a16="http://schemas.microsoft.com/office/drawing/2014/main" xmlns="" w="9525">
+                <a14:hiddenLine xmlns="" xmlns:a16="http://schemas.microsoft.com/office/drawing/2014/main" xmlns:a14="http://schemas.microsoft.com/office/drawing/2010/main" xmlns:p14="http://schemas.microsoft.com/office/powerpoint/2010/main" w="9525">
                   <a:solidFill>
                     <a:srgbClr val="000000"/>
                   </a:solidFill>
@@ -17709,7 +17724,7 @@
             </a:ln>
             <a:extLst>
               <a:ext uri="{91240B29-F687-4f45-9708-019B960494DF}">
-                <a14:hiddenLine xmlns:p14="http://schemas.microsoft.com/office/powerpoint/2010/main" xmlns:a14="http://schemas.microsoft.com/office/drawing/2010/main" xmlns:a16="http://schemas.microsoft.com/office/drawing/2014/main" xmlns="" w="9525">
+                <a14:hiddenLine xmlns="" xmlns:a16="http://schemas.microsoft.com/office/drawing/2014/main" xmlns:a14="http://schemas.microsoft.com/office/drawing/2010/main" xmlns:p14="http://schemas.microsoft.com/office/powerpoint/2010/main" w="9525">
                   <a:solidFill>
                     <a:srgbClr val="000000"/>
                   </a:solidFill>
@@ -17786,7 +17801,7 @@
             </a:ln>
             <a:extLst>
               <a:ext uri="{91240B29-F687-4f45-9708-019B960494DF}">
-                <a14:hiddenLine xmlns:p14="http://schemas.microsoft.com/office/powerpoint/2010/main" xmlns:a14="http://schemas.microsoft.com/office/drawing/2010/main" xmlns:a16="http://schemas.microsoft.com/office/drawing/2014/main" xmlns="" w="9525">
+                <a14:hiddenLine xmlns="" xmlns:a16="http://schemas.microsoft.com/office/drawing/2014/main" xmlns:a14="http://schemas.microsoft.com/office/drawing/2010/main" xmlns:p14="http://schemas.microsoft.com/office/powerpoint/2010/main" w="9525">
                   <a:solidFill>
                     <a:srgbClr val="000000"/>
                   </a:solidFill>
@@ -17921,7 +17936,7 @@
             </a:ln>
             <a:extLst>
               <a:ext uri="{91240B29-F687-4f45-9708-019B960494DF}">
-                <a14:hiddenLine xmlns:p14="http://schemas.microsoft.com/office/powerpoint/2010/main" xmlns:a14="http://schemas.microsoft.com/office/drawing/2010/main" xmlns:a16="http://schemas.microsoft.com/office/drawing/2014/main" xmlns="" w="9525">
+                <a14:hiddenLine xmlns="" xmlns:a16="http://schemas.microsoft.com/office/drawing/2014/main" xmlns:a14="http://schemas.microsoft.com/office/drawing/2010/main" xmlns:p14="http://schemas.microsoft.com/office/powerpoint/2010/main" w="9525">
                   <a:solidFill>
                     <a:srgbClr val="000000"/>
                   </a:solidFill>
@@ -18004,7 +18019,7 @@
             </a:ln>
             <a:extLst>
               <a:ext uri="{91240B29-F687-4f45-9708-019B960494DF}">
-                <a14:hiddenLine xmlns:p14="http://schemas.microsoft.com/office/powerpoint/2010/main" xmlns:a14="http://schemas.microsoft.com/office/drawing/2010/main" xmlns:a16="http://schemas.microsoft.com/office/drawing/2014/main" xmlns="" w="9525">
+                <a14:hiddenLine xmlns="" xmlns:a16="http://schemas.microsoft.com/office/drawing/2014/main" xmlns:a14="http://schemas.microsoft.com/office/drawing/2010/main" xmlns:p14="http://schemas.microsoft.com/office/powerpoint/2010/main" w="9525">
                   <a:solidFill>
                     <a:srgbClr val="000000"/>
                   </a:solidFill>
@@ -18109,7 +18124,7 @@
             </a:ln>
             <a:extLst>
               <a:ext uri="{91240B29-F687-4f45-9708-019B960494DF}">
-                <a14:hiddenLine xmlns:p14="http://schemas.microsoft.com/office/powerpoint/2010/main" xmlns:a14="http://schemas.microsoft.com/office/drawing/2010/main" xmlns:a16="http://schemas.microsoft.com/office/drawing/2014/main" xmlns="" w="9525">
+                <a14:hiddenLine xmlns="" xmlns:a16="http://schemas.microsoft.com/office/drawing/2014/main" xmlns:a14="http://schemas.microsoft.com/office/drawing/2010/main" xmlns:p14="http://schemas.microsoft.com/office/powerpoint/2010/main" w="9525">
                   <a:solidFill>
                     <a:srgbClr val="000000"/>
                   </a:solidFill>
@@ -18239,7 +18254,7 @@
             </a:ln>
             <a:extLst>
               <a:ext uri="{91240B29-F687-4f45-9708-019B960494DF}">
-                <a14:hiddenLine xmlns:p14="http://schemas.microsoft.com/office/powerpoint/2010/main" xmlns:a14="http://schemas.microsoft.com/office/drawing/2010/main" xmlns:a16="http://schemas.microsoft.com/office/drawing/2014/main" xmlns="" w="9525">
+                <a14:hiddenLine xmlns="" xmlns:a16="http://schemas.microsoft.com/office/drawing/2014/main" xmlns:a14="http://schemas.microsoft.com/office/drawing/2010/main" xmlns:p14="http://schemas.microsoft.com/office/powerpoint/2010/main" w="9525">
                   <a:solidFill>
                     <a:srgbClr val="000000"/>
                   </a:solidFill>
@@ -18369,7 +18384,7 @@
             </a:ln>
             <a:extLst>
               <a:ext uri="{91240B29-F687-4f45-9708-019B960494DF}">
-                <a14:hiddenLine xmlns:p14="http://schemas.microsoft.com/office/powerpoint/2010/main" xmlns:a14="http://schemas.microsoft.com/office/drawing/2010/main" xmlns:a16="http://schemas.microsoft.com/office/drawing/2014/main" xmlns="" w="9525">
+                <a14:hiddenLine xmlns="" xmlns:a16="http://schemas.microsoft.com/office/drawing/2014/main" xmlns:a14="http://schemas.microsoft.com/office/drawing/2010/main" xmlns:p14="http://schemas.microsoft.com/office/powerpoint/2010/main" w="9525">
                   <a:solidFill>
                     <a:srgbClr val="000000"/>
                   </a:solidFill>
@@ -18474,7 +18489,7 @@
             </a:ln>
             <a:extLst>
               <a:ext uri="{91240B29-F687-4f45-9708-019B960494DF}">
-                <a14:hiddenLine xmlns:p14="http://schemas.microsoft.com/office/powerpoint/2010/main" xmlns:a14="http://schemas.microsoft.com/office/drawing/2010/main" xmlns:a16="http://schemas.microsoft.com/office/drawing/2014/main" xmlns="" w="9525">
+                <a14:hiddenLine xmlns="" xmlns:a16="http://schemas.microsoft.com/office/drawing/2014/main" xmlns:a14="http://schemas.microsoft.com/office/drawing/2010/main" xmlns:p14="http://schemas.microsoft.com/office/powerpoint/2010/main" w="9525">
                   <a:solidFill>
                     <a:srgbClr val="000000"/>
                   </a:solidFill>
@@ -18554,7 +18569,7 @@
             </a:ln>
             <a:extLst>
               <a:ext uri="{91240B29-F687-4f45-9708-019B960494DF}">
-                <a14:hiddenLine xmlns:p14="http://schemas.microsoft.com/office/powerpoint/2010/main" xmlns:a14="http://schemas.microsoft.com/office/drawing/2010/main" xmlns:a16="http://schemas.microsoft.com/office/drawing/2014/main" xmlns="" w="9525">
+                <a14:hiddenLine xmlns="" xmlns:a16="http://schemas.microsoft.com/office/drawing/2014/main" xmlns:a14="http://schemas.microsoft.com/office/drawing/2010/main" xmlns:p14="http://schemas.microsoft.com/office/powerpoint/2010/main" w="9525">
                   <a:solidFill>
                     <a:srgbClr val="000000"/>
                   </a:solidFill>
@@ -18659,7 +18674,7 @@
             </a:ln>
             <a:extLst>
               <a:ext uri="{91240B29-F687-4f45-9708-019B960494DF}">
-                <a14:hiddenLine xmlns:p14="http://schemas.microsoft.com/office/powerpoint/2010/main" xmlns:a14="http://schemas.microsoft.com/office/drawing/2010/main" xmlns:a16="http://schemas.microsoft.com/office/drawing/2014/main" xmlns="" w="9525">
+                <a14:hiddenLine xmlns="" xmlns:a16="http://schemas.microsoft.com/office/drawing/2014/main" xmlns:a14="http://schemas.microsoft.com/office/drawing/2010/main" xmlns:p14="http://schemas.microsoft.com/office/powerpoint/2010/main" w="9525">
                   <a:solidFill>
                     <a:srgbClr val="000000"/>
                   </a:solidFill>
@@ -18742,7 +18757,7 @@
             </a:ln>
             <a:extLst>
               <a:ext uri="{91240B29-F687-4f45-9708-019B960494DF}">
-                <a14:hiddenLine xmlns:p14="http://schemas.microsoft.com/office/powerpoint/2010/main" xmlns:a14="http://schemas.microsoft.com/office/drawing/2010/main" xmlns:a16="http://schemas.microsoft.com/office/drawing/2014/main" xmlns="" w="9525">
+                <a14:hiddenLine xmlns="" xmlns:a16="http://schemas.microsoft.com/office/drawing/2014/main" xmlns:a14="http://schemas.microsoft.com/office/drawing/2010/main" xmlns:p14="http://schemas.microsoft.com/office/powerpoint/2010/main" w="9525">
                   <a:solidFill>
                     <a:srgbClr val="000000"/>
                   </a:solidFill>
@@ -18847,7 +18862,7 @@
             </a:ln>
             <a:extLst>
               <a:ext uri="{91240B29-F687-4f45-9708-019B960494DF}">
-                <a14:hiddenLine xmlns:p14="http://schemas.microsoft.com/office/powerpoint/2010/main" xmlns:a14="http://schemas.microsoft.com/office/drawing/2010/main" xmlns:a16="http://schemas.microsoft.com/office/drawing/2014/main" xmlns="" w="9525">
+                <a14:hiddenLine xmlns="" xmlns:a16="http://schemas.microsoft.com/office/drawing/2014/main" xmlns:a14="http://schemas.microsoft.com/office/drawing/2010/main" xmlns:p14="http://schemas.microsoft.com/office/powerpoint/2010/main" w="9525">
                   <a:solidFill>
                     <a:srgbClr val="000000"/>
                   </a:solidFill>
@@ -18930,7 +18945,7 @@
             </a:ln>
             <a:extLst>
               <a:ext uri="{91240B29-F687-4f45-9708-019B960494DF}">
-                <a14:hiddenLine xmlns:p14="http://schemas.microsoft.com/office/powerpoint/2010/main" xmlns:a14="http://schemas.microsoft.com/office/drawing/2010/main" xmlns:a16="http://schemas.microsoft.com/office/drawing/2014/main" xmlns="" w="9525">
+                <a14:hiddenLine xmlns="" xmlns:a16="http://schemas.microsoft.com/office/drawing/2014/main" xmlns:a14="http://schemas.microsoft.com/office/drawing/2010/main" xmlns:p14="http://schemas.microsoft.com/office/powerpoint/2010/main" w="9525">
                   <a:solidFill>
                     <a:srgbClr val="000000"/>
                   </a:solidFill>
@@ -19035,7 +19050,7 @@
             </a:ln>
             <a:extLst>
               <a:ext uri="{91240B29-F687-4f45-9708-019B960494DF}">
-                <a14:hiddenLine xmlns:p14="http://schemas.microsoft.com/office/powerpoint/2010/main" xmlns:a14="http://schemas.microsoft.com/office/drawing/2010/main" xmlns:a16="http://schemas.microsoft.com/office/drawing/2014/main" xmlns="" w="9525">
+                <a14:hiddenLine xmlns="" xmlns:a16="http://schemas.microsoft.com/office/drawing/2014/main" xmlns:a14="http://schemas.microsoft.com/office/drawing/2010/main" xmlns:p14="http://schemas.microsoft.com/office/powerpoint/2010/main" w="9525">
                   <a:solidFill>
                     <a:srgbClr val="000000"/>
                   </a:solidFill>
@@ -19084,7 +19099,7 @@
             </a:ln>
             <a:extLst>
               <a:ext uri="{91240B29-F687-4f45-9708-019B960494DF}">
-                <a14:hiddenLine xmlns:p14="http://schemas.microsoft.com/office/powerpoint/2010/main" xmlns:a14="http://schemas.microsoft.com/office/drawing/2010/main" xmlns:a16="http://schemas.microsoft.com/office/drawing/2014/main" xmlns="" w="9525">
+                <a14:hiddenLine xmlns="" xmlns:a16="http://schemas.microsoft.com/office/drawing/2014/main" xmlns:a14="http://schemas.microsoft.com/office/drawing/2010/main" xmlns:p14="http://schemas.microsoft.com/office/powerpoint/2010/main" w="9525">
                   <a:solidFill>
                     <a:srgbClr val="000000"/>
                   </a:solidFill>
@@ -19111,6 +19126,129 @@
 </file>
 
 <file path=ppt/slides/slide10.xml><?xml version="1.0" encoding="utf-8"?>
+<p:sld xmlns:a="http://schemas.openxmlformats.org/drawingml/2006/main" xmlns:r="http://schemas.openxmlformats.org/officeDocument/2006/relationships" xmlns:p="http://schemas.openxmlformats.org/presentationml/2006/main">
+  <p:cSld>
+    <p:spTree>
+      <p:nvGrpSpPr>
+        <p:cNvPr id="1" name=""/>
+        <p:cNvGrpSpPr/>
+        <p:nvPr/>
+      </p:nvGrpSpPr>
+      <p:grpSpPr>
+        <a:xfrm>
+          <a:off x="0" y="0"/>
+          <a:ext cx="0" cy="0"/>
+          <a:chOff x="0" y="0"/>
+          <a:chExt cx="0" cy="0"/>
+        </a:xfrm>
+      </p:grpSpPr>
+      <p:sp>
+        <p:nvSpPr>
+          <p:cNvPr id="2" name="Title 1">
+            <a:extLst>
+              <a:ext uri="{FF2B5EF4-FFF2-40B4-BE49-F238E27FC236}">
+                <a16:creationId xmlns:a16="http://schemas.microsoft.com/office/drawing/2014/main" id="{089AB04D-874D-0245-A562-02212EE48CA7}"/>
+              </a:ext>
+            </a:extLst>
+          </p:cNvPr>
+          <p:cNvSpPr>
+            <a:spLocks noGrp="1"/>
+          </p:cNvSpPr>
+          <p:nvPr>
+            <p:ph type="title"/>
+          </p:nvPr>
+        </p:nvSpPr>
+        <p:spPr>
+          <a:xfrm>
+            <a:off x="1143499" y="163050"/>
+            <a:ext cx="10515600" cy="1325563"/>
+          </a:xfrm>
+        </p:spPr>
+        <p:txBody>
+          <a:bodyPr/>
+          <a:lstStyle/>
+          <a:p>
+            <a:r>
+              <a:rPr lang="en-US" dirty="0"/>
+              <a:t>Syntax</a:t>
+            </a:r>
+          </a:p>
+        </p:txBody>
+      </p:sp>
+      <p:sp>
+        <p:nvSpPr>
+          <p:cNvPr id="3" name="Content Placeholder 2">
+            <a:extLst>
+              <a:ext uri="{FF2B5EF4-FFF2-40B4-BE49-F238E27FC236}">
+                <a16:creationId xmlns:a16="http://schemas.microsoft.com/office/drawing/2014/main" id="{3713A5A2-1019-0143-BC00-1B8B12D7C198}"/>
+              </a:ext>
+            </a:extLst>
+          </p:cNvPr>
+          <p:cNvSpPr>
+            <a:spLocks noGrp="1"/>
+          </p:cNvSpPr>
+          <p:nvPr>
+            <p:ph idx="1"/>
+          </p:nvPr>
+        </p:nvSpPr>
+        <p:spPr>
+          <a:xfrm>
+            <a:off x="1143499" y="1488613"/>
+            <a:ext cx="8596668" cy="3880773"/>
+          </a:xfrm>
+        </p:spPr>
+        <p:txBody>
+          <a:bodyPr>
+            <a:normAutofit/>
+          </a:bodyPr>
+          <a:lstStyle/>
+          <a:p>
+            <a:r>
+              <a:rPr lang="en-US" dirty="0"/>
+              <a:t>All programming languages have a specific syntax</a:t>
+            </a:r>
+          </a:p>
+          <a:p>
+            <a:r>
+              <a:rPr lang="en-US" dirty="0"/>
+              <a:t>These are rules you must follow in order for your program to run properly</a:t>
+            </a:r>
+          </a:p>
+          <a:p>
+            <a:pPr lvl="1"/>
+            <a:r>
+              <a:rPr lang="en-US" dirty="0"/>
+              <a:t>Ex: Declaring variables or functions</a:t>
+            </a:r>
+          </a:p>
+          <a:p>
+            <a:r>
+              <a:rPr lang="en-US" dirty="0"/>
+              <a:t>Breaking the rules will result in errors</a:t>
+            </a:r>
+          </a:p>
+          <a:p>
+            <a:r>
+              <a:rPr lang="en-US" dirty="0"/>
+              <a:t>“Let’s eat, Grandma!” vs ”Let’s eat Grandma!”</a:t>
+            </a:r>
+          </a:p>
+        </p:txBody>
+      </p:sp>
+    </p:spTree>
+    <p:extLst>
+      <p:ext uri="{BB962C8B-B14F-4D97-AF65-F5344CB8AC3E}">
+        <p14:creationId xmlns:p14="http://schemas.microsoft.com/office/powerpoint/2010/main" val="1244393583"/>
+      </p:ext>
+    </p:extLst>
+  </p:cSld>
+  <p:clrMapOvr>
+    <a:masterClrMapping/>
+  </p:clrMapOvr>
+</p:sld>
+</file>
+
+<file path=ppt/slides/slide11.xml><?xml version="1.0" encoding="utf-8"?>
 <p:sld xmlns:a="http://schemas.openxmlformats.org/drawingml/2006/main" xmlns:r="http://schemas.openxmlformats.org/officeDocument/2006/relationships" xmlns:p="http://schemas.openxmlformats.org/presentationml/2006/main">
   <p:cSld>
     <p:spTree>
@@ -19233,190 +19371,6 @@
 </p:sld>
 </file>
 
-<file path=ppt/slides/slide11.xml><?xml version="1.0" encoding="utf-8"?>
-<p:sld xmlns:a="http://schemas.openxmlformats.org/drawingml/2006/main" xmlns:r="http://schemas.openxmlformats.org/officeDocument/2006/relationships" xmlns:p="http://schemas.openxmlformats.org/presentationml/2006/main">
-  <p:cSld>
-    <p:spTree>
-      <p:nvGrpSpPr>
-        <p:cNvPr id="1" name=""/>
-        <p:cNvGrpSpPr/>
-        <p:nvPr/>
-      </p:nvGrpSpPr>
-      <p:grpSpPr>
-        <a:xfrm>
-          <a:off x="0" y="0"/>
-          <a:ext cx="0" cy="0"/>
-          <a:chOff x="0" y="0"/>
-          <a:chExt cx="0" cy="0"/>
-        </a:xfrm>
-      </p:grpSpPr>
-      <p:sp>
-        <p:nvSpPr>
-          <p:cNvPr id="2" name="Title 1">
-            <a:extLst>
-              <a:ext uri="{FF2B5EF4-FFF2-40B4-BE49-F238E27FC236}">
-                <a16:creationId xmlns:a16="http://schemas.microsoft.com/office/drawing/2014/main" id="{089AB04D-874D-0245-A562-02212EE48CA7}"/>
-              </a:ext>
-            </a:extLst>
-          </p:cNvPr>
-          <p:cNvSpPr>
-            <a:spLocks noGrp="1"/>
-          </p:cNvSpPr>
-          <p:nvPr>
-            <p:ph type="title"/>
-          </p:nvPr>
-        </p:nvSpPr>
-        <p:spPr>
-          <a:xfrm>
-            <a:off x="1143499" y="163050"/>
-            <a:ext cx="10515600" cy="1325563"/>
-          </a:xfrm>
-        </p:spPr>
-        <p:txBody>
-          <a:bodyPr/>
-          <a:lstStyle/>
-          <a:p>
-            <a:r>
-              <a:rPr lang="en-US" dirty="0"/>
-              <a:t>Variables</a:t>
-            </a:r>
-          </a:p>
-        </p:txBody>
-      </p:sp>
-      <p:sp>
-        <p:nvSpPr>
-          <p:cNvPr id="3" name="Content Placeholder 2">
-            <a:extLst>
-              <a:ext uri="{FF2B5EF4-FFF2-40B4-BE49-F238E27FC236}">
-                <a16:creationId xmlns:a16="http://schemas.microsoft.com/office/drawing/2014/main" id="{3713A5A2-1019-0143-BC00-1B8B12D7C198}"/>
-              </a:ext>
-            </a:extLst>
-          </p:cNvPr>
-          <p:cNvSpPr>
-            <a:spLocks noGrp="1"/>
-          </p:cNvSpPr>
-          <p:nvPr>
-            <p:ph idx="1"/>
-          </p:nvPr>
-        </p:nvSpPr>
-        <p:spPr>
-          <a:xfrm>
-            <a:off x="1143499" y="1488613"/>
-            <a:ext cx="10305086" cy="4867582"/>
-          </a:xfrm>
-        </p:spPr>
-        <p:txBody>
-          <a:bodyPr>
-            <a:normAutofit fontScale="92500" lnSpcReduction="20000"/>
-          </a:bodyPr>
-          <a:lstStyle/>
-          <a:p>
-            <a:r>
-              <a:rPr lang="en-US" dirty="0"/>
-              <a:t>What is a variable?</a:t>
-            </a:r>
-          </a:p>
-          <a:p>
-            <a:pPr lvl="1"/>
-            <a:r>
-              <a:rPr lang="en-US" dirty="0"/>
-              <a:t>Something that can store information, which can be referenced and manipulated</a:t>
-            </a:r>
-          </a:p>
-          <a:p>
-            <a:pPr lvl="1"/>
-            <a:r>
-              <a:rPr lang="en-US" dirty="0"/>
-              <a:t>Think of a box with the label “score” with the number 2 in it. The box is the variable, and number 2 is its value</a:t>
-            </a:r>
-          </a:p>
-          <a:p>
-            <a:pPr lvl="2"/>
-            <a:r>
-              <a:rPr lang="en-US">
-                <a:highlight>
-                  <a:srgbClr val="000000"/>
-                </a:highlight>
-                <a:latin typeface="Courier New" panose="02070309020205020404" pitchFamily="49" charset="0"/>
-                <a:cs typeface="Courier New" panose="02070309020205020404" pitchFamily="49" charset="0"/>
-              </a:rPr>
-              <a:t>score = 2</a:t>
-            </a:r>
-            <a:endParaRPr lang="en-US" dirty="0">
-              <a:highlight>
-                <a:srgbClr val="000000"/>
-              </a:highlight>
-              <a:latin typeface="Courier New" panose="02070309020205020404" pitchFamily="49" charset="0"/>
-              <a:cs typeface="Courier New" panose="02070309020205020404" pitchFamily="49" charset="0"/>
-            </a:endParaRPr>
-          </a:p>
-          <a:p>
-            <a:pPr lvl="1"/>
-            <a:r>
-              <a:rPr lang="en-US" dirty="0"/>
-              <a:t>Each variable has a type, name, and piece of information stored inside of it</a:t>
-            </a:r>
-          </a:p>
-          <a:p>
-            <a:pPr lvl="1"/>
-            <a:r>
-              <a:rPr lang="en-US" dirty="0"/>
-              <a:t>In Python (and many languages) variables can be of two types, primitive and non-primitive (complex)</a:t>
-            </a:r>
-          </a:p>
-          <a:p>
-            <a:r>
-              <a:rPr lang="en-US" dirty="0"/>
-              <a:t>Why are they important?</a:t>
-            </a:r>
-          </a:p>
-          <a:p>
-            <a:pPr lvl="1"/>
-            <a:r>
-              <a:rPr lang="en-US" dirty="0"/>
-              <a:t>Helpful for getting input from the user</a:t>
-            </a:r>
-          </a:p>
-          <a:p>
-            <a:pPr lvl="1"/>
-            <a:r>
-              <a:rPr lang="en-US" dirty="0"/>
-              <a:t>Allows a program to be more flexible and reusable</a:t>
-            </a:r>
-          </a:p>
-          <a:p>
-            <a:pPr lvl="1"/>
-            <a:r>
-              <a:rPr lang="en-US" dirty="0"/>
-              <a:t>Manipulating variables is necessary for ton of things in programming</a:t>
-            </a:r>
-          </a:p>
-          <a:p>
-            <a:pPr lvl="2"/>
-            <a:r>
-              <a:rPr lang="en-US" dirty="0"/>
-              <a:t>Ex: adding points to a score, totaling an online web order total</a:t>
-            </a:r>
-          </a:p>
-          <a:p>
-            <a:pPr lvl="1"/>
-            <a:endParaRPr lang="en-US" dirty="0"/>
-          </a:p>
-        </p:txBody>
-      </p:sp>
-    </p:spTree>
-    <p:extLst>
-      <p:ext uri="{BB962C8B-B14F-4D97-AF65-F5344CB8AC3E}">
-        <p14:creationId xmlns:p14="http://schemas.microsoft.com/office/powerpoint/2010/main" val="1622184776"/>
-      </p:ext>
-    </p:extLst>
-  </p:cSld>
-  <p:clrMapOvr>
-    <a:masterClrMapping/>
-  </p:clrMapOvr>
-</p:sld>
-</file>
-
 <file path=ppt/slides/slide12.xml><?xml version="1.0" encoding="utf-8"?>
 <p:sld xmlns:a="http://schemas.openxmlformats.org/drawingml/2006/main" xmlns:r="http://schemas.openxmlformats.org/officeDocument/2006/relationships" xmlns:p="http://schemas.openxmlformats.org/presentationml/2006/main">
   <p:cSld>
@@ -19462,7 +19416,7 @@
           <a:p>
             <a:r>
               <a:rPr lang="en-US" dirty="0"/>
-              <a:t>Python Primitive vs Non-Primitive Variables</a:t>
+              <a:t>Variables</a:t>
             </a:r>
           </a:p>
         </p:txBody>
@@ -19486,126 +19440,120 @@
         <p:spPr>
           <a:xfrm>
             <a:off x="1143499" y="1488613"/>
-            <a:ext cx="10401730" cy="5083172"/>
+            <a:ext cx="10305086" cy="4867582"/>
           </a:xfrm>
         </p:spPr>
         <p:txBody>
           <a:bodyPr>
-            <a:normAutofit/>
+            <a:normAutofit fontScale="92500" lnSpcReduction="20000"/>
           </a:bodyPr>
           <a:lstStyle/>
           <a:p>
             <a:r>
               <a:rPr lang="en-US" dirty="0"/>
-              <a:t>Primitive/Simple</a:t>
+              <a:t>What is a variable?</a:t>
             </a:r>
           </a:p>
           <a:p>
             <a:pPr lvl="1"/>
             <a:r>
               <a:rPr lang="en-US" dirty="0"/>
-              <a:t>Integers – represent </a:t>
+              <a:t>Something that can store information, which can be referenced and manipulated</a:t>
+            </a:r>
+          </a:p>
+          <a:p>
+            <a:pPr lvl="1"/>
+            <a:r>
+              <a:rPr lang="en-US" dirty="0"/>
+              <a:t>Think of a box with the label “score” with the number 2 in it. The box is </a:t>
             </a:r>
             <a:r>
               <a:rPr lang="en-US"/>
-              <a:t>whole numbers</a:t>
-            </a:r>
+              <a:t>the variable named “score” </a:t>
+            </a:r>
+            <a:r>
+              <a:rPr lang="en-US" dirty="0"/>
+              <a:t>and number 2 is its value</a:t>
+            </a:r>
+          </a:p>
+          <a:p>
+            <a:pPr lvl="2"/>
+            <a:r>
+              <a:rPr lang="en-US">
+                <a:highlight>
+                  <a:srgbClr val="000000"/>
+                </a:highlight>
+                <a:latin typeface="Courier New" panose="02070309020205020404" pitchFamily="49" charset="0"/>
+                <a:cs typeface="Courier New" panose="02070309020205020404" pitchFamily="49" charset="0"/>
+              </a:rPr>
+              <a:t>score = 2</a:t>
+            </a:r>
+            <a:endParaRPr lang="en-US" dirty="0">
+              <a:highlight>
+                <a:srgbClr val="000000"/>
+              </a:highlight>
+              <a:latin typeface="Courier New" panose="02070309020205020404" pitchFamily="49" charset="0"/>
+              <a:cs typeface="Courier New" panose="02070309020205020404" pitchFamily="49" charset="0"/>
+            </a:endParaRPr>
+          </a:p>
+          <a:p>
+            <a:pPr lvl="1"/>
+            <a:r>
+              <a:rPr lang="en-US" dirty="0"/>
+              <a:t>Each variable has a type, name, and piece of information stored inside of it</a:t>
+            </a:r>
+          </a:p>
+          <a:p>
+            <a:pPr lvl="1"/>
+            <a:r>
+              <a:rPr lang="en-US" dirty="0"/>
+              <a:t>In Python (and many languages) variables can be of two types, primitive and non-primitive (complex)</a:t>
+            </a:r>
+          </a:p>
+          <a:p>
+            <a:r>
+              <a:rPr lang="en-US" dirty="0"/>
+              <a:t>Why are they important?</a:t>
+            </a:r>
+          </a:p>
+          <a:p>
+            <a:pPr lvl="1"/>
+            <a:r>
+              <a:rPr lang="en-US" dirty="0"/>
+              <a:t>Helpful for getting input from the user</a:t>
+            </a:r>
+          </a:p>
+          <a:p>
+            <a:pPr lvl="1"/>
+            <a:r>
+              <a:rPr lang="en-US" dirty="0"/>
+              <a:t>Allows a program to be more flexible and reusable</a:t>
+            </a:r>
+          </a:p>
+          <a:p>
+            <a:pPr lvl="1"/>
+            <a:r>
+              <a:rPr lang="en-US" dirty="0"/>
+              <a:t>Manipulating variables is necessary for ton of things in programming</a:t>
+            </a:r>
+          </a:p>
+          <a:p>
+            <a:pPr lvl="2"/>
+            <a:r>
+              <a:rPr lang="en-US" dirty="0"/>
+              <a:t>Ex: adding points to a score, totaling an online web order total</a:t>
+            </a:r>
+          </a:p>
+          <a:p>
+            <a:pPr lvl="1"/>
             <a:endParaRPr lang="en-US" dirty="0"/>
-          </a:p>
-          <a:p>
-            <a:pPr lvl="1"/>
-            <a:r>
-              <a:rPr lang="en-US" dirty="0"/>
-              <a:t>Float – represents numbers </a:t>
-            </a:r>
-            <a:r>
-              <a:rPr lang="en-US"/>
-              <a:t>with decimals</a:t>
-            </a:r>
-            <a:endParaRPr lang="en-US" dirty="0"/>
-          </a:p>
-          <a:p>
-            <a:pPr lvl="1"/>
-            <a:r>
-              <a:rPr lang="en-US" dirty="0"/>
-              <a:t>Strings – for storing characters or collection of characters (ex: </a:t>
-            </a:r>
-            <a:r>
-              <a:rPr lang="en-US"/>
-              <a:t>words)</a:t>
-            </a:r>
-            <a:endParaRPr lang="en-US" dirty="0"/>
-          </a:p>
-          <a:p>
-            <a:pPr lvl="1"/>
-            <a:r>
-              <a:rPr lang="en-US" dirty="0"/>
-              <a:t>Boolean – can store only True or False</a:t>
-            </a:r>
-          </a:p>
-          <a:p>
-            <a:r>
-              <a:rPr lang="en-US" dirty="0"/>
-              <a:t>Non-Primitive/Complex</a:t>
-            </a:r>
-          </a:p>
-          <a:p>
-            <a:pPr lvl="1"/>
-            <a:r>
-              <a:rPr lang="en-US" dirty="0"/>
-              <a:t>Lists – mutable (changeable) sequences, used to store collections of data</a:t>
-            </a:r>
-          </a:p>
-          <a:p>
-            <a:pPr lvl="1"/>
-            <a:r>
-              <a:rPr lang="en-US" dirty="0"/>
-              <a:t>Tuples – immutable (non-changeable) sequences, used to store collections of data</a:t>
-            </a:r>
-          </a:p>
-          <a:p>
-            <a:pPr lvl="1"/>
-            <a:r>
-              <a:rPr lang="en-US" dirty="0"/>
-              <a:t>Range – immutable sequence of numbers, commonly used for looping</a:t>
-            </a:r>
-          </a:p>
-          <a:p>
-            <a:pPr lvl="1"/>
-            <a:r>
-              <a:rPr lang="en-US" dirty="0"/>
-              <a:t>Dictionary – mutable map of </a:t>
-            </a:r>
-            <a:r>
-              <a:rPr lang="en-US" dirty="0" err="1"/>
-              <a:t>hashable</a:t>
-            </a:r>
-            <a:r>
-              <a:rPr lang="en-US" dirty="0"/>
-              <a:t> values to arbitrary objects (key, value pair)</a:t>
-            </a:r>
-          </a:p>
-          <a:p>
-            <a:pPr lvl="1"/>
-            <a:r>
-              <a:rPr lang="en-US" dirty="0"/>
-              <a:t>Sets – unordered collection of distinct </a:t>
-            </a:r>
-            <a:r>
-              <a:rPr lang="en-US" dirty="0" err="1"/>
-              <a:t>hashable</a:t>
-            </a:r>
-            <a:r>
-              <a:rPr lang="en-US" dirty="0"/>
-              <a:t> objects</a:t>
-            </a:r>
           </a:p>
         </p:txBody>
       </p:sp>
     </p:spTree>
     <p:extLst>
       <p:ext uri="{BB962C8B-B14F-4D97-AF65-F5344CB8AC3E}">
-        <p14:creationId xmlns:p14="http://schemas.microsoft.com/office/powerpoint/2010/main" val="600822365"/>
+        <p14:creationId xmlns:p14="http://schemas.microsoft.com/office/powerpoint/2010/main" val="1622184776"/>
       </p:ext>
     </p:extLst>
   </p:cSld>
@@ -19637,7 +19585,7 @@
           <p:cNvPr id="2" name="Title 1">
             <a:extLst>
               <a:ext uri="{FF2B5EF4-FFF2-40B4-BE49-F238E27FC236}">
-                <a16:creationId xmlns:a16="http://schemas.microsoft.com/office/drawing/2014/main" id="{089AB04D-874D-0245-A562-02212EE48CA7}"/>
+                <a16:creationId xmlns:a16="http://schemas.microsoft.com/office/drawing/2014/main" id="{F3898187-69DD-4DDD-A8C0-979C80A534C6}"/>
               </a:ext>
             </a:extLst>
           </p:cNvPr>
@@ -19648,183 +19596,52 @@
             <p:ph type="title"/>
           </p:nvPr>
         </p:nvSpPr>
-        <p:spPr>
-          <a:xfrm>
-            <a:off x="1143499" y="163050"/>
-            <a:ext cx="10515600" cy="1325563"/>
-          </a:xfrm>
-        </p:spPr>
+        <p:spPr/>
         <p:txBody>
           <a:bodyPr/>
           <a:lstStyle/>
           <a:p>
             <a:r>
-              <a:rPr lang="en-US" dirty="0"/>
-              <a:t>Some Syntax </a:t>
-            </a:r>
-            <a:r>
               <a:rPr lang="en-US"/>
-              <a:t>Around Variables - Python</a:t>
-            </a:r>
-            <a:endParaRPr lang="en-US" dirty="0"/>
+              <a:t>Python note</a:t>
+            </a:r>
           </a:p>
         </p:txBody>
       </p:sp>
-      <p:sp>
-        <p:nvSpPr>
-          <p:cNvPr id="3" name="Content Placeholder 2">
+      <p:pic>
+        <p:nvPicPr>
+          <p:cNvPr id="5" name="Picture 4">
             <a:extLst>
               <a:ext uri="{FF2B5EF4-FFF2-40B4-BE49-F238E27FC236}">
-                <a16:creationId xmlns:a16="http://schemas.microsoft.com/office/drawing/2014/main" id="{3713A5A2-1019-0143-BC00-1B8B12D7C198}"/>
+                <a16:creationId xmlns:a16="http://schemas.microsoft.com/office/drawing/2014/main" id="{BD85D0A3-500B-4247-A03A-2E2864EA4308}"/>
               </a:ext>
             </a:extLst>
           </p:cNvPr>
-          <p:cNvSpPr>
-            <a:spLocks noGrp="1"/>
-          </p:cNvSpPr>
-          <p:nvPr>
-            <p:ph idx="1"/>
-          </p:nvPr>
-        </p:nvSpPr>
+          <p:cNvPicPr>
+            <a:picLocks noChangeAspect="1"/>
+          </p:cNvPicPr>
+          <p:nvPr/>
+        </p:nvPicPr>
+        <p:blipFill>
+          <a:blip r:embed="rId2"/>
+          <a:stretch>
+            <a:fillRect/>
+          </a:stretch>
+        </p:blipFill>
         <p:spPr>
           <a:xfrm>
-            <a:off x="1143499" y="1488613"/>
-            <a:ext cx="10201008" cy="4830411"/>
+            <a:off x="3052762" y="2306112"/>
+            <a:ext cx="6086475" cy="3590925"/>
           </a:xfrm>
+          <a:prstGeom prst="rect">
+            <a:avLst/>
+          </a:prstGeom>
         </p:spPr>
-        <p:txBody>
-          <a:bodyPr>
-            <a:normAutofit fontScale="92500"/>
-          </a:bodyPr>
-          <a:lstStyle/>
-          <a:p>
-            <a:r>
-              <a:rPr lang="en-US" dirty="0"/>
-              <a:t>Names can contain only letters, numbers, and underscores.</a:t>
-            </a:r>
-          </a:p>
-          <a:p>
-            <a:pPr lvl="1"/>
-            <a:r>
-              <a:rPr lang="en-US" dirty="0"/>
-              <a:t>They can start with a letter or underscore, but not a number</a:t>
-            </a:r>
-          </a:p>
-          <a:p>
-            <a:r>
-              <a:rPr lang="en-US" dirty="0"/>
-              <a:t>Spaces are not allowed</a:t>
-            </a:r>
-          </a:p>
-          <a:p>
-            <a:pPr lvl="1"/>
-            <a:r>
-              <a:rPr lang="en-US" dirty="0"/>
-              <a:t>Ex “user_name” vs “user name”</a:t>
-            </a:r>
-          </a:p>
-          <a:p>
-            <a:r>
-              <a:rPr lang="en-US" dirty="0"/>
-              <a:t>Avoid using Python keywords and function names as </a:t>
-            </a:r>
-            <a:r>
-              <a:rPr lang="en-US"/>
-              <a:t>variable names</a:t>
-            </a:r>
-          </a:p>
-          <a:p>
-            <a:pPr lvl="1"/>
-            <a:r>
-              <a:rPr lang="en-US">
-                <a:hlinkClick r:id="rId2"/>
-              </a:rPr>
-              <a:t>Keywords</a:t>
-            </a:r>
-            <a:r>
-              <a:rPr lang="en-US"/>
-              <a:t>, </a:t>
-            </a:r>
-            <a:r>
-              <a:rPr lang="en-US">
-                <a:hlinkClick r:id="rId3"/>
-              </a:rPr>
-              <a:t>Built-In Functions</a:t>
-            </a:r>
-            <a:endParaRPr lang="en-US" dirty="0"/>
-          </a:p>
-          <a:p>
-            <a:r>
-              <a:rPr lang="en-US" dirty="0"/>
-              <a:t>Not syntax, but try to keep your variable names short but descriptive</a:t>
-            </a:r>
-          </a:p>
-          <a:p>
-            <a:pPr lvl="1"/>
-            <a:r>
-              <a:rPr lang="en-US" dirty="0"/>
-              <a:t>Ex “</a:t>
-            </a:r>
-            <a:r>
-              <a:rPr lang="en-US" dirty="0" err="1"/>
-              <a:t>total_score</a:t>
-            </a:r>
-            <a:r>
-              <a:rPr lang="en-US" dirty="0"/>
-              <a:t>” vs “</a:t>
-            </a:r>
-            <a:r>
-              <a:rPr lang="en-US" dirty="0" err="1"/>
-              <a:t>ts</a:t>
-            </a:r>
-            <a:r>
-              <a:rPr lang="en-US" dirty="0"/>
-              <a:t>” vs “</a:t>
-            </a:r>
-            <a:r>
-              <a:rPr lang="en-US" dirty="0" err="1"/>
-              <a:t>the_players_cummulative_score_so_far</a:t>
-            </a:r>
-            <a:r>
-              <a:rPr lang="en-US" dirty="0"/>
-              <a:t>”</a:t>
-            </a:r>
-          </a:p>
-          <a:p>
-            <a:r>
-              <a:rPr lang="en-US" dirty="0"/>
-              <a:t>Not syntax, but Python programmers generally prefer the underscore vs camelCase</a:t>
-            </a:r>
-          </a:p>
-          <a:p>
-            <a:pPr lvl="1"/>
-            <a:r>
-              <a:rPr lang="en-US" dirty="0"/>
-              <a:t>Ex “</a:t>
-            </a:r>
-            <a:r>
-              <a:rPr lang="en-US" dirty="0" err="1"/>
-              <a:t>user_name</a:t>
-            </a:r>
-            <a:r>
-              <a:rPr lang="en-US" dirty="0"/>
-              <a:t>” vs “</a:t>
-            </a:r>
-            <a:r>
-              <a:rPr lang="en-US" dirty="0" err="1"/>
-              <a:t>userName</a:t>
-            </a:r>
-            <a:r>
-              <a:rPr lang="en-US" dirty="0"/>
-              <a:t>”</a:t>
-            </a:r>
-          </a:p>
-        </p:txBody>
-      </p:sp>
+      </p:pic>
     </p:spTree>
     <p:extLst>
       <p:ext uri="{BB962C8B-B14F-4D97-AF65-F5344CB8AC3E}">
-        <p14:creationId xmlns:p14="http://schemas.microsoft.com/office/powerpoint/2010/main" val="4127551336"/>
+        <p14:creationId xmlns:p14="http://schemas.microsoft.com/office/powerpoint/2010/main" val="1166365298"/>
       </p:ext>
     </p:extLst>
   </p:cSld>
@@ -19879,7 +19696,7 @@
           <a:p>
             <a:r>
               <a:rPr lang="en-US" dirty="0"/>
-              <a:t>Check Understanding</a:t>
+              <a:t>Python Primitive vs Non-Primitive Variables</a:t>
             </a:r>
           </a:p>
         </p:txBody>
@@ -19903,7 +19720,7 @@
         <p:spPr>
           <a:xfrm>
             <a:off x="1143499" y="1488613"/>
-            <a:ext cx="8596668" cy="3880773"/>
+            <a:ext cx="10401730" cy="5083172"/>
           </a:xfrm>
         </p:spPr>
         <p:txBody>
@@ -19914,77 +19731,107 @@
           <a:p>
             <a:r>
               <a:rPr lang="en-US" dirty="0"/>
-              <a:t>Which of the following pieces of code have an error?</a:t>
-            </a:r>
-          </a:p>
-          <a:p>
-            <a:r>
-              <a:rPr lang="en-US" dirty="0">
-                <a:highlight>
-                  <a:srgbClr val="000000"/>
-                </a:highlight>
-                <a:latin typeface="Courier New" panose="02070309020205020404" pitchFamily="49" charset="0"/>
-                <a:cs typeface="Courier New" panose="02070309020205020404" pitchFamily="49" charset="0"/>
-              </a:rPr>
-              <a:t>Score = 12</a:t>
-            </a:r>
-          </a:p>
-          <a:p>
-            <a:r>
-              <a:rPr lang="en-US" dirty="0" err="1">
-                <a:highlight>
-                  <a:srgbClr val="000000"/>
-                </a:highlight>
-                <a:latin typeface="Courier New" panose="02070309020205020404" pitchFamily="49" charset="0"/>
-                <a:cs typeface="Courier New" panose="02070309020205020404" pitchFamily="49" charset="0"/>
-              </a:rPr>
-              <a:t>my_score</a:t>
-            </a:r>
-            <a:r>
-              <a:rPr lang="en-US" dirty="0">
-                <a:highlight>
-                  <a:srgbClr val="000000"/>
-                </a:highlight>
-                <a:latin typeface="Courier New" panose="02070309020205020404" pitchFamily="49" charset="0"/>
-                <a:cs typeface="Courier New" panose="02070309020205020404" pitchFamily="49" charset="0"/>
-              </a:rPr>
-              <a:t> = 25.0</a:t>
-            </a:r>
-          </a:p>
-          <a:p>
-            <a:r>
-              <a:rPr lang="en-US" dirty="0">
-                <a:highlight>
-                  <a:srgbClr val="000000"/>
-                </a:highlight>
-                <a:latin typeface="Courier New" panose="02070309020205020404" pitchFamily="49" charset="0"/>
-                <a:cs typeface="Courier New" panose="02070309020205020404" pitchFamily="49" charset="0"/>
-              </a:rPr>
-              <a:t>player 2 = ‘Will’</a:t>
-            </a:r>
-          </a:p>
-          <a:p>
-            <a:r>
-              <a:rPr lang="en-US" dirty="0">
-                <a:highlight>
-                  <a:srgbClr val="000000"/>
-                </a:highlight>
-                <a:latin typeface="Courier New" panose="02070309020205020404" pitchFamily="49" charset="0"/>
-                <a:cs typeface="Courier New" panose="02070309020205020404" pitchFamily="49" charset="0"/>
-              </a:rPr>
-              <a:t>_total = 124.99</a:t>
-            </a:r>
-          </a:p>
-          <a:p>
-            <a:r>
-              <a:rPr lang="en-US" dirty="0">
-                <a:highlight>
-                  <a:srgbClr val="000000"/>
-                </a:highlight>
-                <a:latin typeface="Courier New" panose="02070309020205020404" pitchFamily="49" charset="0"/>
-                <a:cs typeface="Courier New" panose="02070309020205020404" pitchFamily="49" charset="0"/>
-              </a:rPr>
-              <a:t>1_player = ‘Sam’</a:t>
+              <a:t>Primitive/Simple</a:t>
+            </a:r>
+          </a:p>
+          <a:p>
+            <a:pPr lvl="1"/>
+            <a:r>
+              <a:rPr lang="en-US" dirty="0"/>
+              <a:t>Integers – represent </a:t>
+            </a:r>
+            <a:r>
+              <a:rPr lang="en-US"/>
+              <a:t>whole numbers</a:t>
+            </a:r>
+            <a:endParaRPr lang="en-US" dirty="0"/>
+          </a:p>
+          <a:p>
+            <a:pPr lvl="1"/>
+            <a:r>
+              <a:rPr lang="en-US" dirty="0"/>
+              <a:t>Float – represents numbers </a:t>
+            </a:r>
+            <a:r>
+              <a:rPr lang="en-US"/>
+              <a:t>with decimals</a:t>
+            </a:r>
+            <a:endParaRPr lang="en-US" dirty="0"/>
+          </a:p>
+          <a:p>
+            <a:pPr lvl="1"/>
+            <a:r>
+              <a:rPr lang="en-US" dirty="0"/>
+              <a:t>Strings – for storing characters or collection of characters (ex: </a:t>
+            </a:r>
+            <a:r>
+              <a:rPr lang="en-US"/>
+              <a:t>words)</a:t>
+            </a:r>
+            <a:endParaRPr lang="en-US" dirty="0"/>
+          </a:p>
+          <a:p>
+            <a:pPr lvl="1"/>
+            <a:r>
+              <a:rPr lang="en-US" dirty="0"/>
+              <a:t>Boolean – can store only True or False</a:t>
+            </a:r>
+          </a:p>
+          <a:p>
+            <a:r>
+              <a:rPr lang="en-US" dirty="0"/>
+              <a:t>Non-Primitive/Complex</a:t>
+            </a:r>
+          </a:p>
+          <a:p>
+            <a:pPr lvl="1"/>
+            <a:r>
+              <a:rPr lang="en-US" dirty="0"/>
+              <a:t>Lists – mutable (changeable) sequences, used to store collections of data</a:t>
+            </a:r>
+          </a:p>
+          <a:p>
+            <a:pPr lvl="1"/>
+            <a:r>
+              <a:rPr lang="en-US" dirty="0"/>
+              <a:t>Tuples – immutable (non-changeable) sequences, used to store collections of data</a:t>
+            </a:r>
+          </a:p>
+          <a:p>
+            <a:pPr lvl="1"/>
+            <a:r>
+              <a:rPr lang="en-US" dirty="0"/>
+              <a:t>Range – immutable sequence of numbers, commonly used for looping</a:t>
+            </a:r>
+          </a:p>
+          <a:p>
+            <a:pPr lvl="1"/>
+            <a:r>
+              <a:rPr lang="en-US" dirty="0"/>
+              <a:t>Dictionary – mutable map of </a:t>
+            </a:r>
+            <a:r>
+              <a:rPr lang="en-US" dirty="0" err="1"/>
+              <a:t>hashable</a:t>
+            </a:r>
+            <a:r>
+              <a:rPr lang="en-US" dirty="0"/>
+              <a:t> values to arbitrary objects (key, value pair)</a:t>
+            </a:r>
+          </a:p>
+          <a:p>
+            <a:pPr lvl="1"/>
+            <a:r>
+              <a:rPr lang="en-US" dirty="0"/>
+              <a:t>Sets – unordered collection of distinct </a:t>
+            </a:r>
+            <a:r>
+              <a:rPr lang="en-US" dirty="0" err="1"/>
+              <a:t>hashable</a:t>
+            </a:r>
+            <a:r>
+              <a:rPr lang="en-US" dirty="0"/>
+              <a:t> objects</a:t>
             </a:r>
           </a:p>
         </p:txBody>
@@ -19992,7 +19839,7 @@
     </p:spTree>
     <p:extLst>
       <p:ext uri="{BB962C8B-B14F-4D97-AF65-F5344CB8AC3E}">
-        <p14:creationId xmlns:p14="http://schemas.microsoft.com/office/powerpoint/2010/main" val="3490158993"/>
+        <p14:creationId xmlns:p14="http://schemas.microsoft.com/office/powerpoint/2010/main" val="600822365"/>
       </p:ext>
     </p:extLst>
   </p:cSld>
@@ -20047,8 +19894,13 @@
           <a:p>
             <a:r>
               <a:rPr lang="en-US" dirty="0"/>
-              <a:t>Check Understanding - Answers</a:t>
-            </a:r>
+              <a:t>Some Syntax </a:t>
+            </a:r>
+            <a:r>
+              <a:rPr lang="en-US"/>
+              <a:t>Around Variables - Python</a:t>
+            </a:r>
+            <a:endParaRPr lang="en-US" dirty="0"/>
           </a:p>
         </p:txBody>
       </p:sp>
@@ -20071,138 +19923,134 @@
         <p:spPr>
           <a:xfrm>
             <a:off x="1143499" y="1488613"/>
-            <a:ext cx="8596668" cy="3880773"/>
+            <a:ext cx="10201008" cy="4830411"/>
           </a:xfrm>
         </p:spPr>
         <p:txBody>
           <a:bodyPr>
-            <a:normAutofit fontScale="70000" lnSpcReduction="20000"/>
+            <a:normAutofit fontScale="92500"/>
           </a:bodyPr>
           <a:lstStyle/>
           <a:p>
             <a:r>
               <a:rPr lang="en-US" dirty="0"/>
-              <a:t>Which of the following pieces of code have an error?</a:t>
-            </a:r>
-          </a:p>
-          <a:p>
-            <a:r>
-              <a:rPr lang="en-US" dirty="0">
-                <a:highlight>
-                  <a:srgbClr val="000000"/>
-                </a:highlight>
-                <a:latin typeface="Courier New" panose="02070309020205020404" pitchFamily="49" charset="0"/>
-                <a:cs typeface="Courier New" panose="02070309020205020404" pitchFamily="49" charset="0"/>
+              <a:t>Names can contain only letters, numbers, and underscores.</a:t>
+            </a:r>
+          </a:p>
+          <a:p>
+            <a:pPr lvl="1"/>
+            <a:r>
+              <a:rPr lang="en-US" dirty="0"/>
+              <a:t>They can start with a letter or underscore, but not a number</a:t>
+            </a:r>
+          </a:p>
+          <a:p>
+            <a:r>
+              <a:rPr lang="en-US" dirty="0"/>
+              <a:t>Spaces are not allowed</a:t>
+            </a:r>
+          </a:p>
+          <a:p>
+            <a:pPr lvl="1"/>
+            <a:r>
+              <a:rPr lang="en-US" dirty="0"/>
+              <a:t>Ex “user_name” vs “user name”</a:t>
+            </a:r>
+          </a:p>
+          <a:p>
+            <a:r>
+              <a:rPr lang="en-US" dirty="0"/>
+              <a:t>Avoid using Python keywords and function names as </a:t>
+            </a:r>
+            <a:r>
+              <a:rPr lang="en-US"/>
+              <a:t>variable names</a:t>
+            </a:r>
+          </a:p>
+          <a:p>
+            <a:pPr lvl="1"/>
+            <a:r>
+              <a:rPr lang="en-US">
+                <a:hlinkClick r:id="rId2"/>
               </a:rPr>
-              <a:t>Score = 12</a:t>
+              <a:t>Keywords</a:t>
+            </a:r>
+            <a:r>
+              <a:rPr lang="en-US"/>
+              <a:t>, </a:t>
+            </a:r>
+            <a:r>
+              <a:rPr lang="en-US">
+                <a:hlinkClick r:id="rId3"/>
+              </a:rPr>
+              <a:t>Built-In Functions</a:t>
+            </a:r>
+            <a:endParaRPr lang="en-US" dirty="0"/>
+          </a:p>
+          <a:p>
+            <a:r>
+              <a:rPr lang="en-US" dirty="0"/>
+              <a:t>Not syntax, but try to keep your variable names short but descriptive</a:t>
             </a:r>
           </a:p>
           <a:p>
             <a:pPr lvl="1"/>
             <a:r>
-              <a:rPr lang="en-US" dirty="0">
-                <a:latin typeface="Courier New" panose="02070309020205020404" pitchFamily="49" charset="0"/>
-                <a:cs typeface="Courier New" panose="02070309020205020404" pitchFamily="49" charset="0"/>
-              </a:rPr>
-              <a:t>OK – but generally bad practice to use capital letter</a:t>
-            </a:r>
-          </a:p>
-          <a:p>
-            <a:r>
-              <a:rPr lang="en-US" dirty="0" err="1">
-                <a:highlight>
-                  <a:srgbClr val="000000"/>
-                </a:highlight>
-                <a:latin typeface="Courier New" panose="02070309020205020404" pitchFamily="49" charset="0"/>
-                <a:cs typeface="Courier New" panose="02070309020205020404" pitchFamily="49" charset="0"/>
-              </a:rPr>
-              <a:t>my_score</a:t>
-            </a:r>
-            <a:r>
-              <a:rPr lang="en-US" dirty="0">
-                <a:highlight>
-                  <a:srgbClr val="000000"/>
-                </a:highlight>
-                <a:latin typeface="Courier New" panose="02070309020205020404" pitchFamily="49" charset="0"/>
-                <a:cs typeface="Courier New" panose="02070309020205020404" pitchFamily="49" charset="0"/>
-              </a:rPr>
-              <a:t> = 25.0</a:t>
+              <a:rPr lang="en-US" dirty="0"/>
+              <a:t>Ex “</a:t>
+            </a:r>
+            <a:r>
+              <a:rPr lang="en-US" dirty="0" err="1"/>
+              <a:t>total_score</a:t>
+            </a:r>
+            <a:r>
+              <a:rPr lang="en-US" dirty="0"/>
+              <a:t>” vs “</a:t>
+            </a:r>
+            <a:r>
+              <a:rPr lang="en-US" dirty="0" err="1"/>
+              <a:t>ts</a:t>
+            </a:r>
+            <a:r>
+              <a:rPr lang="en-US" dirty="0"/>
+              <a:t>” vs “</a:t>
+            </a:r>
+            <a:r>
+              <a:rPr lang="en-US" dirty="0" err="1"/>
+              <a:t>the_players_cummulative_score_so_far</a:t>
+            </a:r>
+            <a:r>
+              <a:rPr lang="en-US" dirty="0"/>
+              <a:t>”</a:t>
+            </a:r>
+          </a:p>
+          <a:p>
+            <a:r>
+              <a:rPr lang="en-US" dirty="0"/>
+              <a:t>Not syntax, but Python programmers generally prefer the underscore vs camelCase</a:t>
             </a:r>
           </a:p>
           <a:p>
             <a:pPr lvl="1"/>
             <a:r>
-              <a:rPr lang="en-US" dirty="0">
-                <a:latin typeface="Courier New" panose="02070309020205020404" pitchFamily="49" charset="0"/>
-                <a:cs typeface="Courier New" panose="02070309020205020404" pitchFamily="49" charset="0"/>
-              </a:rPr>
-              <a:t>OK</a:t>
-            </a:r>
-          </a:p>
-          <a:p>
-            <a:r>
-              <a:rPr lang="en-US" dirty="0">
-                <a:highlight>
-                  <a:srgbClr val="000000"/>
-                </a:highlight>
-                <a:latin typeface="Courier New" panose="02070309020205020404" pitchFamily="49" charset="0"/>
-                <a:cs typeface="Courier New" panose="02070309020205020404" pitchFamily="49" charset="0"/>
-              </a:rPr>
-              <a:t>player 2 = ‘Will’</a:t>
-            </a:r>
-          </a:p>
-          <a:p>
-            <a:pPr lvl="1"/>
-            <a:r>
-              <a:rPr lang="en-US" dirty="0">
-                <a:latin typeface="Courier New" panose="02070309020205020404" pitchFamily="49" charset="0"/>
-                <a:cs typeface="Courier New" panose="02070309020205020404" pitchFamily="49" charset="0"/>
-              </a:rPr>
-              <a:t>NOT OK – cannot have spaces in variable name</a:t>
-            </a:r>
-          </a:p>
-          <a:p>
-            <a:r>
-              <a:rPr lang="en-US" dirty="0">
-                <a:highlight>
-                  <a:srgbClr val="000000"/>
-                </a:highlight>
-                <a:latin typeface="Courier New" panose="02070309020205020404" pitchFamily="49" charset="0"/>
-                <a:cs typeface="Courier New" panose="02070309020205020404" pitchFamily="49" charset="0"/>
-              </a:rPr>
-              <a:t>_total = 124.99</a:t>
-            </a:r>
-          </a:p>
-          <a:p>
-            <a:pPr lvl="1"/>
-            <a:r>
-              <a:rPr lang="en-US" dirty="0">
-                <a:latin typeface="Courier New" panose="02070309020205020404" pitchFamily="49" charset="0"/>
-                <a:cs typeface="Courier New" panose="02070309020205020404" pitchFamily="49" charset="0"/>
-              </a:rPr>
-              <a:t>OK</a:t>
-            </a:r>
-          </a:p>
-          <a:p>
-            <a:r>
-              <a:rPr lang="en-US" dirty="0">
-                <a:highlight>
-                  <a:srgbClr val="000000"/>
-                </a:highlight>
-                <a:latin typeface="Courier New" panose="02070309020205020404" pitchFamily="49" charset="0"/>
-                <a:cs typeface="Courier New" panose="02070309020205020404" pitchFamily="49" charset="0"/>
-              </a:rPr>
-              <a:t>1_player = ‘Sam’</a:t>
-            </a:r>
-          </a:p>
-          <a:p>
-            <a:pPr lvl="1"/>
-            <a:r>
-              <a:rPr lang="en-US" dirty="0">
-                <a:latin typeface="Courier New" panose="02070309020205020404" pitchFamily="49" charset="0"/>
-                <a:cs typeface="Courier New" panose="02070309020205020404" pitchFamily="49" charset="0"/>
-              </a:rPr>
-              <a:t>NOT OK – cannot start with number</a:t>
+              <a:rPr lang="en-US" dirty="0"/>
+              <a:t>Ex “</a:t>
+            </a:r>
+            <a:r>
+              <a:rPr lang="en-US" dirty="0" err="1"/>
+              <a:t>user_name</a:t>
+            </a:r>
+            <a:r>
+              <a:rPr lang="en-US" dirty="0"/>
+              <a:t>” vs “</a:t>
+            </a:r>
+            <a:r>
+              <a:rPr lang="en-US" dirty="0" err="1"/>
+              <a:t>userName</a:t>
+            </a:r>
+            <a:r>
+              <a:rPr lang="en-US" dirty="0"/>
+              <a:t>”</a:t>
             </a:r>
           </a:p>
         </p:txBody>
@@ -20210,7 +20058,7 @@
     </p:spTree>
     <p:extLst>
       <p:ext uri="{BB962C8B-B14F-4D97-AF65-F5344CB8AC3E}">
-        <p14:creationId xmlns:p14="http://schemas.microsoft.com/office/powerpoint/2010/main" val="2649295826"/>
+        <p14:creationId xmlns:p14="http://schemas.microsoft.com/office/powerpoint/2010/main" val="4127551336"/>
       </p:ext>
     </p:extLst>
   </p:cSld>
@@ -20265,7 +20113,7 @@
           <a:p>
             <a:r>
               <a:rPr lang="en-US" dirty="0"/>
-              <a:t>Integers</a:t>
+              <a:t>Check Understanding</a:t>
             </a:r>
           </a:p>
         </p:txBody>
@@ -20294,99 +20142,83 @@
         </p:spPr>
         <p:txBody>
           <a:bodyPr>
-            <a:normAutofit fontScale="85000" lnSpcReduction="20000"/>
+            <a:normAutofit/>
           </a:bodyPr>
           <a:lstStyle/>
           <a:p>
             <a:r>
               <a:rPr lang="en-US" dirty="0"/>
-              <a:t>You </a:t>
-            </a:r>
-            <a:r>
-              <a:rPr lang="en-US"/>
-              <a:t>can do basic </a:t>
-            </a:r>
-            <a:r>
-              <a:rPr lang="en-US" dirty="0"/>
-              <a:t>arithmetic like add (+), subtract (-), multiply (*), and divide (/) </a:t>
-            </a:r>
-          </a:p>
-          <a:p>
-            <a:r>
-              <a:rPr lang="en-US" dirty="0"/>
-              <a:t>Python uses two multiplication symbols (**) to represent exponents</a:t>
-            </a:r>
-          </a:p>
-          <a:p>
-            <a:pPr lvl="1"/>
-            <a:r>
-              <a:rPr lang="en-US" dirty="0"/>
-              <a:t>3</a:t>
-            </a:r>
-            <a:r>
-              <a:rPr lang="en-US"/>
-              <a:t>**2 outputs 9</a:t>
-            </a:r>
-            <a:endParaRPr lang="en-US" dirty="0"/>
-          </a:p>
-          <a:p>
-            <a:r>
-              <a:rPr lang="en-US" dirty="0"/>
-              <a:t>Python follows order of operations</a:t>
-            </a:r>
-          </a:p>
-          <a:p>
-            <a:pPr lvl="1"/>
-            <a:r>
-              <a:rPr lang="en-US" dirty="0"/>
-              <a:t>2 </a:t>
-            </a:r>
-            <a:r>
-              <a:rPr lang="en-US"/>
-              <a:t>+ 3*4 outputs 14</a:t>
-            </a:r>
-            <a:endParaRPr lang="en-US" dirty="0"/>
-          </a:p>
-          <a:p>
-            <a:pPr lvl="1"/>
-            <a:r>
-              <a:rPr lang="en-US" dirty="0"/>
-              <a:t>(2+3)*</a:t>
-            </a:r>
-            <a:r>
-              <a:rPr lang="en-US"/>
-              <a:t>4 outputs </a:t>
-            </a:r>
-            <a:r>
-              <a:rPr lang="en-US" dirty="0"/>
-              <a:t>20 </a:t>
-            </a:r>
-          </a:p>
-          <a:p>
-            <a:r>
-              <a:rPr lang="en-US" dirty="0"/>
-              <a:t>Quirk – When you divide two integers, Python will give the answer as a float</a:t>
-            </a:r>
-          </a:p>
-          <a:p>
-            <a:pPr lvl="1"/>
-            <a:r>
-              <a:rPr lang="en-US"/>
-              <a:t>4/2 outputs 2.0</a:t>
-            </a:r>
-            <a:endParaRPr lang="en-US" dirty="0"/>
-          </a:p>
-          <a:p>
-            <a:r>
-              <a:rPr lang="en-US" dirty="0"/>
-              <a:t>Large numbers can be written using underscores for readability</a:t>
-            </a:r>
-          </a:p>
-          <a:p>
-            <a:pPr lvl="1"/>
-            <a:r>
-              <a:rPr lang="en-US" dirty="0"/>
-              <a:t>1_000_000 vs 1000000</a:t>
+              <a:t>Which of the following pieces of code have an error?</a:t>
+            </a:r>
+          </a:p>
+          <a:p>
+            <a:r>
+              <a:rPr lang="en-US" dirty="0">
+                <a:highlight>
+                  <a:srgbClr val="000000"/>
+                </a:highlight>
+                <a:latin typeface="Courier New" panose="02070309020205020404" pitchFamily="49" charset="0"/>
+                <a:cs typeface="Courier New" panose="02070309020205020404" pitchFamily="49" charset="0"/>
+              </a:rPr>
+              <a:t>Score = 12</a:t>
+            </a:r>
+          </a:p>
+          <a:p>
+            <a:r>
+              <a:rPr lang="en-US" dirty="0" err="1">
+                <a:highlight>
+                  <a:srgbClr val="000000"/>
+                </a:highlight>
+                <a:latin typeface="Courier New" panose="02070309020205020404" pitchFamily="49" charset="0"/>
+                <a:cs typeface="Courier New" panose="02070309020205020404" pitchFamily="49" charset="0"/>
+              </a:rPr>
+              <a:t>my_score</a:t>
+            </a:r>
+            <a:r>
+              <a:rPr lang="en-US" dirty="0">
+                <a:highlight>
+                  <a:srgbClr val="000000"/>
+                </a:highlight>
+                <a:latin typeface="Courier New" panose="02070309020205020404" pitchFamily="49" charset="0"/>
+                <a:cs typeface="Courier New" panose="02070309020205020404" pitchFamily="49" charset="0"/>
+              </a:rPr>
+              <a:t> = 25.0</a:t>
+            </a:r>
+          </a:p>
+          <a:p>
+            <a:r>
+              <a:rPr lang="en-US" dirty="0">
+                <a:highlight>
+                  <a:srgbClr val="000000"/>
+                </a:highlight>
+                <a:latin typeface="Courier New" panose="02070309020205020404" pitchFamily="49" charset="0"/>
+                <a:cs typeface="Courier New" panose="02070309020205020404" pitchFamily="49" charset="0"/>
+              </a:rPr>
+              <a:t>player 2 = ‘Will’</a:t>
+            </a:r>
+          </a:p>
+          <a:p>
+            <a:r>
+              <a:rPr lang="en-US" dirty="0">
+                <a:highlight>
+                  <a:srgbClr val="000000"/>
+                </a:highlight>
+                <a:latin typeface="Courier New" panose="02070309020205020404" pitchFamily="49" charset="0"/>
+                <a:cs typeface="Courier New" panose="02070309020205020404" pitchFamily="49" charset="0"/>
+              </a:rPr>
+              <a:t>_total = 124.99</a:t>
+            </a:r>
+          </a:p>
+          <a:p>
+            <a:r>
+              <a:rPr lang="en-US" dirty="0">
+                <a:highlight>
+                  <a:srgbClr val="000000"/>
+                </a:highlight>
+                <a:latin typeface="Courier New" panose="02070309020205020404" pitchFamily="49" charset="0"/>
+                <a:cs typeface="Courier New" panose="02070309020205020404" pitchFamily="49" charset="0"/>
+              </a:rPr>
+              <a:t>1_player = ‘Sam’</a:t>
             </a:r>
           </a:p>
         </p:txBody>
@@ -20394,7 +20226,7 @@
     </p:spTree>
     <p:extLst>
       <p:ext uri="{BB962C8B-B14F-4D97-AF65-F5344CB8AC3E}">
-        <p14:creationId xmlns:p14="http://schemas.microsoft.com/office/powerpoint/2010/main" val="1411778005"/>
+        <p14:creationId xmlns:p14="http://schemas.microsoft.com/office/powerpoint/2010/main" val="3490158993"/>
       </p:ext>
     </p:extLst>
   </p:cSld>
@@ -20449,6 +20281,408 @@
           <a:p>
             <a:r>
               <a:rPr lang="en-US" dirty="0"/>
+              <a:t>Check Understanding - Answers</a:t>
+            </a:r>
+          </a:p>
+        </p:txBody>
+      </p:sp>
+      <p:sp>
+        <p:nvSpPr>
+          <p:cNvPr id="3" name="Content Placeholder 2">
+            <a:extLst>
+              <a:ext uri="{FF2B5EF4-FFF2-40B4-BE49-F238E27FC236}">
+                <a16:creationId xmlns:a16="http://schemas.microsoft.com/office/drawing/2014/main" id="{3713A5A2-1019-0143-BC00-1B8B12D7C198}"/>
+              </a:ext>
+            </a:extLst>
+          </p:cNvPr>
+          <p:cNvSpPr>
+            <a:spLocks noGrp="1"/>
+          </p:cNvSpPr>
+          <p:nvPr>
+            <p:ph idx="1"/>
+          </p:nvPr>
+        </p:nvSpPr>
+        <p:spPr>
+          <a:xfrm>
+            <a:off x="1143499" y="1488613"/>
+            <a:ext cx="8596668" cy="3880773"/>
+          </a:xfrm>
+        </p:spPr>
+        <p:txBody>
+          <a:bodyPr>
+            <a:normAutofit fontScale="70000" lnSpcReduction="20000"/>
+          </a:bodyPr>
+          <a:lstStyle/>
+          <a:p>
+            <a:r>
+              <a:rPr lang="en-US" dirty="0"/>
+              <a:t>Which of the following pieces of code have an error?</a:t>
+            </a:r>
+          </a:p>
+          <a:p>
+            <a:r>
+              <a:rPr lang="en-US" dirty="0">
+                <a:highlight>
+                  <a:srgbClr val="000000"/>
+                </a:highlight>
+                <a:latin typeface="Courier New" panose="02070309020205020404" pitchFamily="49" charset="0"/>
+                <a:cs typeface="Courier New" panose="02070309020205020404" pitchFamily="49" charset="0"/>
+              </a:rPr>
+              <a:t>Score = 12</a:t>
+            </a:r>
+          </a:p>
+          <a:p>
+            <a:pPr lvl="1"/>
+            <a:r>
+              <a:rPr lang="en-US" dirty="0">
+                <a:latin typeface="Courier New" panose="02070309020205020404" pitchFamily="49" charset="0"/>
+                <a:cs typeface="Courier New" panose="02070309020205020404" pitchFamily="49" charset="0"/>
+              </a:rPr>
+              <a:t>OK – but generally bad practice to use capital letter</a:t>
+            </a:r>
+          </a:p>
+          <a:p>
+            <a:r>
+              <a:rPr lang="en-US" dirty="0" err="1">
+                <a:highlight>
+                  <a:srgbClr val="000000"/>
+                </a:highlight>
+                <a:latin typeface="Courier New" panose="02070309020205020404" pitchFamily="49" charset="0"/>
+                <a:cs typeface="Courier New" panose="02070309020205020404" pitchFamily="49" charset="0"/>
+              </a:rPr>
+              <a:t>my_score</a:t>
+            </a:r>
+            <a:r>
+              <a:rPr lang="en-US" dirty="0">
+                <a:highlight>
+                  <a:srgbClr val="000000"/>
+                </a:highlight>
+                <a:latin typeface="Courier New" panose="02070309020205020404" pitchFamily="49" charset="0"/>
+                <a:cs typeface="Courier New" panose="02070309020205020404" pitchFamily="49" charset="0"/>
+              </a:rPr>
+              <a:t> = 25.0</a:t>
+            </a:r>
+          </a:p>
+          <a:p>
+            <a:pPr lvl="1"/>
+            <a:r>
+              <a:rPr lang="en-US" dirty="0">
+                <a:latin typeface="Courier New" panose="02070309020205020404" pitchFamily="49" charset="0"/>
+                <a:cs typeface="Courier New" panose="02070309020205020404" pitchFamily="49" charset="0"/>
+              </a:rPr>
+              <a:t>OK</a:t>
+            </a:r>
+          </a:p>
+          <a:p>
+            <a:r>
+              <a:rPr lang="en-US" dirty="0">
+                <a:highlight>
+                  <a:srgbClr val="000000"/>
+                </a:highlight>
+                <a:latin typeface="Courier New" panose="02070309020205020404" pitchFamily="49" charset="0"/>
+                <a:cs typeface="Courier New" panose="02070309020205020404" pitchFamily="49" charset="0"/>
+              </a:rPr>
+              <a:t>player 2 = ‘Will’</a:t>
+            </a:r>
+          </a:p>
+          <a:p>
+            <a:pPr lvl="1"/>
+            <a:r>
+              <a:rPr lang="en-US" dirty="0">
+                <a:latin typeface="Courier New" panose="02070309020205020404" pitchFamily="49" charset="0"/>
+                <a:cs typeface="Courier New" panose="02070309020205020404" pitchFamily="49" charset="0"/>
+              </a:rPr>
+              <a:t>NOT OK – cannot have spaces in variable name</a:t>
+            </a:r>
+          </a:p>
+          <a:p>
+            <a:r>
+              <a:rPr lang="en-US" dirty="0">
+                <a:highlight>
+                  <a:srgbClr val="000000"/>
+                </a:highlight>
+                <a:latin typeface="Courier New" panose="02070309020205020404" pitchFamily="49" charset="0"/>
+                <a:cs typeface="Courier New" panose="02070309020205020404" pitchFamily="49" charset="0"/>
+              </a:rPr>
+              <a:t>_total = 124.99</a:t>
+            </a:r>
+          </a:p>
+          <a:p>
+            <a:pPr lvl="1"/>
+            <a:r>
+              <a:rPr lang="en-US" dirty="0">
+                <a:latin typeface="Courier New" panose="02070309020205020404" pitchFamily="49" charset="0"/>
+                <a:cs typeface="Courier New" panose="02070309020205020404" pitchFamily="49" charset="0"/>
+              </a:rPr>
+              <a:t>OK</a:t>
+            </a:r>
+          </a:p>
+          <a:p>
+            <a:r>
+              <a:rPr lang="en-US" dirty="0">
+                <a:highlight>
+                  <a:srgbClr val="000000"/>
+                </a:highlight>
+                <a:latin typeface="Courier New" panose="02070309020205020404" pitchFamily="49" charset="0"/>
+                <a:cs typeface="Courier New" panose="02070309020205020404" pitchFamily="49" charset="0"/>
+              </a:rPr>
+              <a:t>1_player = ‘Sam’</a:t>
+            </a:r>
+          </a:p>
+          <a:p>
+            <a:pPr lvl="1"/>
+            <a:r>
+              <a:rPr lang="en-US" dirty="0">
+                <a:latin typeface="Courier New" panose="02070309020205020404" pitchFamily="49" charset="0"/>
+                <a:cs typeface="Courier New" panose="02070309020205020404" pitchFamily="49" charset="0"/>
+              </a:rPr>
+              <a:t>NOT OK – cannot start with number</a:t>
+            </a:r>
+          </a:p>
+        </p:txBody>
+      </p:sp>
+    </p:spTree>
+    <p:extLst>
+      <p:ext uri="{BB962C8B-B14F-4D97-AF65-F5344CB8AC3E}">
+        <p14:creationId xmlns:p14="http://schemas.microsoft.com/office/powerpoint/2010/main" val="2649295826"/>
+      </p:ext>
+    </p:extLst>
+  </p:cSld>
+  <p:clrMapOvr>
+    <a:masterClrMapping/>
+  </p:clrMapOvr>
+</p:sld>
+</file>
+
+<file path=ppt/slides/slide18.xml><?xml version="1.0" encoding="utf-8"?>
+<p:sld xmlns:a="http://schemas.openxmlformats.org/drawingml/2006/main" xmlns:r="http://schemas.openxmlformats.org/officeDocument/2006/relationships" xmlns:p="http://schemas.openxmlformats.org/presentationml/2006/main">
+  <p:cSld>
+    <p:spTree>
+      <p:nvGrpSpPr>
+        <p:cNvPr id="1" name=""/>
+        <p:cNvGrpSpPr/>
+        <p:nvPr/>
+      </p:nvGrpSpPr>
+      <p:grpSpPr>
+        <a:xfrm>
+          <a:off x="0" y="0"/>
+          <a:ext cx="0" cy="0"/>
+          <a:chOff x="0" y="0"/>
+          <a:chExt cx="0" cy="0"/>
+        </a:xfrm>
+      </p:grpSpPr>
+      <p:sp>
+        <p:nvSpPr>
+          <p:cNvPr id="2" name="Title 1">
+            <a:extLst>
+              <a:ext uri="{FF2B5EF4-FFF2-40B4-BE49-F238E27FC236}">
+                <a16:creationId xmlns:a16="http://schemas.microsoft.com/office/drawing/2014/main" id="{089AB04D-874D-0245-A562-02212EE48CA7}"/>
+              </a:ext>
+            </a:extLst>
+          </p:cNvPr>
+          <p:cNvSpPr>
+            <a:spLocks noGrp="1"/>
+          </p:cNvSpPr>
+          <p:nvPr>
+            <p:ph type="title"/>
+          </p:nvPr>
+        </p:nvSpPr>
+        <p:spPr>
+          <a:xfrm>
+            <a:off x="1143499" y="163050"/>
+            <a:ext cx="10515600" cy="1325563"/>
+          </a:xfrm>
+        </p:spPr>
+        <p:txBody>
+          <a:bodyPr/>
+          <a:lstStyle/>
+          <a:p>
+            <a:r>
+              <a:rPr lang="en-US" dirty="0"/>
+              <a:t>Integers</a:t>
+            </a:r>
+          </a:p>
+        </p:txBody>
+      </p:sp>
+      <p:sp>
+        <p:nvSpPr>
+          <p:cNvPr id="3" name="Content Placeholder 2">
+            <a:extLst>
+              <a:ext uri="{FF2B5EF4-FFF2-40B4-BE49-F238E27FC236}">
+                <a16:creationId xmlns:a16="http://schemas.microsoft.com/office/drawing/2014/main" id="{3713A5A2-1019-0143-BC00-1B8B12D7C198}"/>
+              </a:ext>
+            </a:extLst>
+          </p:cNvPr>
+          <p:cNvSpPr>
+            <a:spLocks noGrp="1"/>
+          </p:cNvSpPr>
+          <p:nvPr>
+            <p:ph idx="1"/>
+          </p:nvPr>
+        </p:nvSpPr>
+        <p:spPr>
+          <a:xfrm>
+            <a:off x="1143499" y="1488613"/>
+            <a:ext cx="8596668" cy="3880773"/>
+          </a:xfrm>
+        </p:spPr>
+        <p:txBody>
+          <a:bodyPr>
+            <a:normAutofit fontScale="85000" lnSpcReduction="20000"/>
+          </a:bodyPr>
+          <a:lstStyle/>
+          <a:p>
+            <a:r>
+              <a:rPr lang="en-US" dirty="0"/>
+              <a:t>You </a:t>
+            </a:r>
+            <a:r>
+              <a:rPr lang="en-US"/>
+              <a:t>can do basic </a:t>
+            </a:r>
+            <a:r>
+              <a:rPr lang="en-US" dirty="0"/>
+              <a:t>arithmetic like add (+), subtract (-), multiply (*), and divide (/) </a:t>
+            </a:r>
+          </a:p>
+          <a:p>
+            <a:r>
+              <a:rPr lang="en-US" dirty="0"/>
+              <a:t>Python uses two multiplication symbols (**) to represent exponents</a:t>
+            </a:r>
+          </a:p>
+          <a:p>
+            <a:pPr lvl="1"/>
+            <a:r>
+              <a:rPr lang="en-US" dirty="0"/>
+              <a:t>3</a:t>
+            </a:r>
+            <a:r>
+              <a:rPr lang="en-US"/>
+              <a:t>**2 outputs 9</a:t>
+            </a:r>
+            <a:endParaRPr lang="en-US" dirty="0"/>
+          </a:p>
+          <a:p>
+            <a:r>
+              <a:rPr lang="en-US" dirty="0"/>
+              <a:t>Python follows order of operations</a:t>
+            </a:r>
+          </a:p>
+          <a:p>
+            <a:pPr lvl="1"/>
+            <a:r>
+              <a:rPr lang="en-US" dirty="0"/>
+              <a:t>2 </a:t>
+            </a:r>
+            <a:r>
+              <a:rPr lang="en-US"/>
+              <a:t>+ 3*4 outputs 14</a:t>
+            </a:r>
+            <a:endParaRPr lang="en-US" dirty="0"/>
+          </a:p>
+          <a:p>
+            <a:pPr lvl="1"/>
+            <a:r>
+              <a:rPr lang="en-US" dirty="0"/>
+              <a:t>(2+3)*</a:t>
+            </a:r>
+            <a:r>
+              <a:rPr lang="en-US"/>
+              <a:t>4 outputs </a:t>
+            </a:r>
+            <a:r>
+              <a:rPr lang="en-US" dirty="0"/>
+              <a:t>20 </a:t>
+            </a:r>
+          </a:p>
+          <a:p>
+            <a:r>
+              <a:rPr lang="en-US" dirty="0"/>
+              <a:t>Quirk – When you divide two integers, Python will give the answer as a float</a:t>
+            </a:r>
+          </a:p>
+          <a:p>
+            <a:pPr lvl="1"/>
+            <a:r>
+              <a:rPr lang="en-US"/>
+              <a:t>4/2 outputs 2.0</a:t>
+            </a:r>
+            <a:endParaRPr lang="en-US" dirty="0"/>
+          </a:p>
+          <a:p>
+            <a:r>
+              <a:rPr lang="en-US" dirty="0"/>
+              <a:t>Large numbers can be written using underscores for readability</a:t>
+            </a:r>
+          </a:p>
+          <a:p>
+            <a:pPr lvl="1"/>
+            <a:r>
+              <a:rPr lang="en-US" dirty="0"/>
+              <a:t>1_000_000 vs 1000000</a:t>
+            </a:r>
+          </a:p>
+        </p:txBody>
+      </p:sp>
+    </p:spTree>
+    <p:extLst>
+      <p:ext uri="{BB962C8B-B14F-4D97-AF65-F5344CB8AC3E}">
+        <p14:creationId xmlns:p14="http://schemas.microsoft.com/office/powerpoint/2010/main" val="1411778005"/>
+      </p:ext>
+    </p:extLst>
+  </p:cSld>
+  <p:clrMapOvr>
+    <a:masterClrMapping/>
+  </p:clrMapOvr>
+</p:sld>
+</file>
+
+<file path=ppt/slides/slide19.xml><?xml version="1.0" encoding="utf-8"?>
+<p:sld xmlns:a="http://schemas.openxmlformats.org/drawingml/2006/main" xmlns:r="http://schemas.openxmlformats.org/officeDocument/2006/relationships" xmlns:p="http://schemas.openxmlformats.org/presentationml/2006/main">
+  <p:cSld>
+    <p:spTree>
+      <p:nvGrpSpPr>
+        <p:cNvPr id="1" name=""/>
+        <p:cNvGrpSpPr/>
+        <p:nvPr/>
+      </p:nvGrpSpPr>
+      <p:grpSpPr>
+        <a:xfrm>
+          <a:off x="0" y="0"/>
+          <a:ext cx="0" cy="0"/>
+          <a:chOff x="0" y="0"/>
+          <a:chExt cx="0" cy="0"/>
+        </a:xfrm>
+      </p:grpSpPr>
+      <p:sp>
+        <p:nvSpPr>
+          <p:cNvPr id="2" name="Title 1">
+            <a:extLst>
+              <a:ext uri="{FF2B5EF4-FFF2-40B4-BE49-F238E27FC236}">
+                <a16:creationId xmlns:a16="http://schemas.microsoft.com/office/drawing/2014/main" id="{089AB04D-874D-0245-A562-02212EE48CA7}"/>
+              </a:ext>
+            </a:extLst>
+          </p:cNvPr>
+          <p:cNvSpPr>
+            <a:spLocks noGrp="1"/>
+          </p:cNvSpPr>
+          <p:nvPr>
+            <p:ph type="title"/>
+          </p:nvPr>
+        </p:nvSpPr>
+        <p:spPr>
+          <a:xfrm>
+            <a:off x="1143499" y="163050"/>
+            <a:ext cx="10515600" cy="1325563"/>
+          </a:xfrm>
+        </p:spPr>
+        <p:txBody>
+          <a:bodyPr/>
+          <a:lstStyle/>
+          <a:p>
+            <a:r>
+              <a:rPr lang="en-US" dirty="0"/>
               <a:t>Floats</a:t>
             </a:r>
           </a:p>
@@ -20556,7 +20790,171 @@
 </p:sld>
 </file>
 
-<file path=ppt/slides/slide18.xml><?xml version="1.0" encoding="utf-8"?>
+<file path=ppt/slides/slide2.xml><?xml version="1.0" encoding="utf-8"?>
+<p:sld xmlns:a="http://schemas.openxmlformats.org/drawingml/2006/main" xmlns:r="http://schemas.openxmlformats.org/officeDocument/2006/relationships" xmlns:p="http://schemas.openxmlformats.org/presentationml/2006/main">
+  <p:cSld>
+    <p:spTree>
+      <p:nvGrpSpPr>
+        <p:cNvPr id="1" name=""/>
+        <p:cNvGrpSpPr/>
+        <p:nvPr/>
+      </p:nvGrpSpPr>
+      <p:grpSpPr>
+        <a:xfrm>
+          <a:off x="0" y="0"/>
+          <a:ext cx="0" cy="0"/>
+          <a:chOff x="0" y="0"/>
+          <a:chExt cx="0" cy="0"/>
+        </a:xfrm>
+      </p:grpSpPr>
+      <p:sp>
+        <p:nvSpPr>
+          <p:cNvPr id="2" name="Title 1">
+            <a:extLst>
+              <a:ext uri="{FF2B5EF4-FFF2-40B4-BE49-F238E27FC236}">
+                <a16:creationId xmlns:a16="http://schemas.microsoft.com/office/drawing/2014/main" id="{01BC9E0A-8CC6-4302-925B-7CAD4C197137}"/>
+              </a:ext>
+            </a:extLst>
+          </p:cNvPr>
+          <p:cNvSpPr>
+            <a:spLocks noGrp="1"/>
+          </p:cNvSpPr>
+          <p:nvPr>
+            <p:ph type="title"/>
+          </p:nvPr>
+        </p:nvSpPr>
+        <p:spPr/>
+        <p:txBody>
+          <a:bodyPr/>
+          <a:lstStyle/>
+          <a:p>
+            <a:r>
+              <a:rPr lang="en-US"/>
+              <a:t>What this class is and is not</a:t>
+            </a:r>
+          </a:p>
+        </p:txBody>
+      </p:sp>
+      <p:sp>
+        <p:nvSpPr>
+          <p:cNvPr id="4" name="Content Placeholder 3">
+            <a:extLst>
+              <a:ext uri="{FF2B5EF4-FFF2-40B4-BE49-F238E27FC236}">
+                <a16:creationId xmlns:a16="http://schemas.microsoft.com/office/drawing/2014/main" id="{B3540642-F7B7-4DB4-A5C3-1733E0E73F1C}"/>
+              </a:ext>
+            </a:extLst>
+          </p:cNvPr>
+          <p:cNvSpPr>
+            <a:spLocks noGrp="1"/>
+          </p:cNvSpPr>
+          <p:nvPr>
+            <p:ph sz="half" idx="1"/>
+          </p:nvPr>
+        </p:nvSpPr>
+        <p:spPr/>
+        <p:txBody>
+          <a:bodyPr/>
+          <a:lstStyle/>
+          <a:p>
+            <a:r>
+              <a:rPr lang="en-US"/>
+              <a:t>IS</a:t>
+            </a:r>
+          </a:p>
+          <a:p>
+            <a:pPr lvl="1"/>
+            <a:r>
+              <a:rPr lang="en-US"/>
+              <a:t>Introductory</a:t>
+            </a:r>
+          </a:p>
+          <a:p>
+            <a:pPr lvl="1"/>
+            <a:r>
+              <a:rPr lang="en-US"/>
+              <a:t>No programming experience required</a:t>
+            </a:r>
+          </a:p>
+          <a:p>
+            <a:pPr lvl="1"/>
+            <a:r>
+              <a:rPr lang="en-US"/>
+              <a:t>Similar to my 75 minute in-class lectures</a:t>
+            </a:r>
+          </a:p>
+          <a:p>
+            <a:pPr lvl="2"/>
+            <a:r>
+              <a:rPr lang="en-US"/>
+              <a:t>Some content has been modified for the YouTube medium though</a:t>
+            </a:r>
+          </a:p>
+          <a:p>
+            <a:pPr lvl="1"/>
+            <a:endParaRPr lang="en-US"/>
+          </a:p>
+        </p:txBody>
+      </p:sp>
+      <p:sp>
+        <p:nvSpPr>
+          <p:cNvPr id="5" name="Content Placeholder 4">
+            <a:extLst>
+              <a:ext uri="{FF2B5EF4-FFF2-40B4-BE49-F238E27FC236}">
+                <a16:creationId xmlns:a16="http://schemas.microsoft.com/office/drawing/2014/main" id="{129AEFC6-CAEB-4F98-900F-C9DCE7C8774C}"/>
+              </a:ext>
+            </a:extLst>
+          </p:cNvPr>
+          <p:cNvSpPr>
+            <a:spLocks noGrp="1"/>
+          </p:cNvSpPr>
+          <p:nvPr>
+            <p:ph sz="half" idx="2"/>
+          </p:nvPr>
+        </p:nvSpPr>
+        <p:spPr/>
+        <p:txBody>
+          <a:bodyPr/>
+          <a:lstStyle/>
+          <a:p>
+            <a:r>
+              <a:rPr lang="en-US"/>
+              <a:t>IS NOT</a:t>
+            </a:r>
+          </a:p>
+          <a:p>
+            <a:pPr lvl="1"/>
+            <a:r>
+              <a:rPr lang="en-US"/>
+              <a:t>Going to make you an expert programmer</a:t>
+            </a:r>
+          </a:p>
+          <a:p>
+            <a:pPr lvl="1"/>
+            <a:r>
+              <a:rPr lang="en-US"/>
+              <a:t>A Python mastery course</a:t>
+            </a:r>
+          </a:p>
+          <a:p>
+            <a:pPr lvl="1"/>
+            <a:endParaRPr lang="en-US"/>
+          </a:p>
+        </p:txBody>
+      </p:sp>
+    </p:spTree>
+    <p:extLst>
+      <p:ext uri="{BB962C8B-B14F-4D97-AF65-F5344CB8AC3E}">
+        <p14:creationId xmlns:p14="http://schemas.microsoft.com/office/powerpoint/2010/main" val="1431737700"/>
+      </p:ext>
+    </p:extLst>
+  </p:cSld>
+  <p:clrMapOvr>
+    <a:masterClrMapping/>
+  </p:clrMapOvr>
+</p:sld>
+</file>
+
+<file path=ppt/slides/slide20.xml><?xml version="1.0" encoding="utf-8"?>
 <p:sld xmlns:a="http://schemas.openxmlformats.org/drawingml/2006/main" xmlns:r="http://schemas.openxmlformats.org/officeDocument/2006/relationships" xmlns:p="http://schemas.openxmlformats.org/presentationml/2006/main">
   <p:cSld>
     <p:spTree>
@@ -20653,7 +21051,7 @@
 </p:sld>
 </file>
 
-<file path=ppt/slides/slide19.xml><?xml version="1.0" encoding="utf-8"?>
+<file path=ppt/slides/slide21.xml><?xml version="1.0" encoding="utf-8"?>
 <p:sld xmlns:a="http://schemas.openxmlformats.org/drawingml/2006/main" xmlns:r="http://schemas.openxmlformats.org/officeDocument/2006/relationships" xmlns:p="http://schemas.openxmlformats.org/presentationml/2006/main">
   <p:cSld>
     <p:spTree>
@@ -20984,148 +21382,7 @@
 </p:sld>
 </file>
 
-<file path=ppt/slides/slide2.xml><?xml version="1.0" encoding="utf-8"?>
-<p:sld xmlns:a="http://schemas.openxmlformats.org/drawingml/2006/main" xmlns:r="http://schemas.openxmlformats.org/officeDocument/2006/relationships" xmlns:p="http://schemas.openxmlformats.org/presentationml/2006/main">
-  <p:cSld>
-    <p:spTree>
-      <p:nvGrpSpPr>
-        <p:cNvPr id="1" name=""/>
-        <p:cNvGrpSpPr/>
-        <p:nvPr/>
-      </p:nvGrpSpPr>
-      <p:grpSpPr>
-        <a:xfrm>
-          <a:off x="0" y="0"/>
-          <a:ext cx="0" cy="0"/>
-          <a:chOff x="0" y="0"/>
-          <a:chExt cx="0" cy="0"/>
-        </a:xfrm>
-      </p:grpSpPr>
-      <p:sp>
-        <p:nvSpPr>
-          <p:cNvPr id="2" name="Title 1">
-            <a:extLst>
-              <a:ext uri="{FF2B5EF4-FFF2-40B4-BE49-F238E27FC236}">
-                <a16:creationId xmlns:a16="http://schemas.microsoft.com/office/drawing/2014/main" id="{5C86CBF7-69F7-7B44-ABCE-F80D6130EA7B}"/>
-              </a:ext>
-            </a:extLst>
-          </p:cNvPr>
-          <p:cNvSpPr>
-            <a:spLocks noGrp="1"/>
-          </p:cNvSpPr>
-          <p:nvPr>
-            <p:ph type="title"/>
-          </p:nvPr>
-        </p:nvSpPr>
-        <p:spPr>
-          <a:xfrm>
-            <a:off x="1143000" y="153192"/>
-            <a:ext cx="10515600" cy="1325563"/>
-          </a:xfrm>
-        </p:spPr>
-        <p:txBody>
-          <a:bodyPr/>
-          <a:lstStyle/>
-          <a:p>
-            <a:r>
-              <a:rPr lang="en-US" dirty="0"/>
-              <a:t>About Me</a:t>
-            </a:r>
-          </a:p>
-        </p:txBody>
-      </p:sp>
-      <p:sp>
-        <p:nvSpPr>
-          <p:cNvPr id="3" name="Content Placeholder 2">
-            <a:extLst>
-              <a:ext uri="{FF2B5EF4-FFF2-40B4-BE49-F238E27FC236}">
-                <a16:creationId xmlns:a16="http://schemas.microsoft.com/office/drawing/2014/main" id="{1095E837-F77E-AE4D-944C-919B5D780AAA}"/>
-              </a:ext>
-            </a:extLst>
-          </p:cNvPr>
-          <p:cNvSpPr>
-            <a:spLocks noGrp="1"/>
-          </p:cNvSpPr>
-          <p:nvPr>
-            <p:ph idx="1"/>
-          </p:nvPr>
-        </p:nvSpPr>
-        <p:spPr>
-          <a:xfrm>
-            <a:off x="1143000" y="1478755"/>
-            <a:ext cx="10515600" cy="4351338"/>
-          </a:xfrm>
-        </p:spPr>
-        <p:txBody>
-          <a:bodyPr/>
-          <a:lstStyle/>
-          <a:p>
-            <a:r>
-              <a:rPr lang="en-US" dirty="0"/>
-              <a:t>Programming professionally for </a:t>
-            </a:r>
-            <a:r>
-              <a:rPr lang="en-US"/>
-              <a:t>almost since 2015</a:t>
-            </a:r>
-            <a:endParaRPr lang="en-US" dirty="0"/>
-          </a:p>
-          <a:p>
-            <a:r>
-              <a:rPr lang="en-US" dirty="0"/>
-              <a:t>First job was RPG on an IBM Mainframe (AS400/I-Series)</a:t>
-            </a:r>
-          </a:p>
-          <a:p>
-            <a:r>
-              <a:rPr lang="en-US" dirty="0"/>
-              <a:t>Then moved to Java with the Spring ecosystem</a:t>
-            </a:r>
-          </a:p>
-          <a:p>
-            <a:pPr lvl="1"/>
-            <a:r>
-              <a:rPr lang="en-US" dirty="0"/>
-              <a:t>Ecommerce</a:t>
-            </a:r>
-          </a:p>
-          <a:p>
-            <a:pPr lvl="1"/>
-            <a:r>
-              <a:rPr lang="en-US" dirty="0"/>
-              <a:t>Satellite Imagery</a:t>
-            </a:r>
-          </a:p>
-          <a:p>
-            <a:pPr lvl="1"/>
-            <a:r>
-              <a:rPr lang="en-US" dirty="0"/>
-              <a:t>Travel &amp; Hospitality</a:t>
-            </a:r>
-          </a:p>
-          <a:p>
-            <a:r>
-              <a:rPr lang="en-US"/>
-              <a:t>I have a B.B.A. in Accounting (super useful) and a M.S. in Software Engineering</a:t>
-            </a:r>
-            <a:endParaRPr lang="en-US" dirty="0"/>
-          </a:p>
-        </p:txBody>
-      </p:sp>
-    </p:spTree>
-    <p:extLst>
-      <p:ext uri="{BB962C8B-B14F-4D97-AF65-F5344CB8AC3E}">
-        <p14:creationId xmlns:p14="http://schemas.microsoft.com/office/powerpoint/2010/main" val="830997286"/>
-      </p:ext>
-    </p:extLst>
-  </p:cSld>
-  <p:clrMapOvr>
-    <a:masterClrMapping/>
-  </p:clrMapOvr>
-</p:sld>
-</file>
-
-<file path=ppt/slides/slide20.xml><?xml version="1.0" encoding="utf-8"?>
+<file path=ppt/slides/slide22.xml><?xml version="1.0" encoding="utf-8"?>
 <p:sld xmlns:a="http://schemas.openxmlformats.org/drawingml/2006/main" xmlns:r="http://schemas.openxmlformats.org/officeDocument/2006/relationships" xmlns:p="http://schemas.openxmlformats.org/presentationml/2006/main">
   <p:cSld>
     <p:spTree>
@@ -21306,7 +21563,7 @@
 </p:sld>
 </file>
 
-<file path=ppt/slides/slide21.xml><?xml version="1.0" encoding="utf-8"?>
+<file path=ppt/slides/slide23.xml><?xml version="1.0" encoding="utf-8"?>
 <p:sld xmlns:a="http://schemas.openxmlformats.org/drawingml/2006/main" xmlns:r="http://schemas.openxmlformats.org/officeDocument/2006/relationships" xmlns:p="http://schemas.openxmlformats.org/presentationml/2006/main">
   <p:cSld>
     <p:spTree>
@@ -21521,7 +21778,257 @@
 </p:sld>
 </file>
 
+<file path=ppt/slides/slide24.xml><?xml version="1.0" encoding="utf-8"?>
+<p:sld xmlns:a="http://schemas.openxmlformats.org/drawingml/2006/main" xmlns:r="http://schemas.openxmlformats.org/officeDocument/2006/relationships" xmlns:p="http://schemas.openxmlformats.org/presentationml/2006/main">
+  <p:cSld>
+    <p:spTree>
+      <p:nvGrpSpPr>
+        <p:cNvPr id="1" name=""/>
+        <p:cNvGrpSpPr/>
+        <p:nvPr/>
+      </p:nvGrpSpPr>
+      <p:grpSpPr>
+        <a:xfrm>
+          <a:off x="0" y="0"/>
+          <a:ext cx="0" cy="0"/>
+          <a:chOff x="0" y="0"/>
+          <a:chExt cx="0" cy="0"/>
+        </a:xfrm>
+      </p:grpSpPr>
+      <p:sp>
+        <p:nvSpPr>
+          <p:cNvPr id="2" name="Title 1">
+            <a:extLst>
+              <a:ext uri="{FF2B5EF4-FFF2-40B4-BE49-F238E27FC236}">
+                <a16:creationId xmlns:a16="http://schemas.microsoft.com/office/drawing/2014/main" id="{703704C0-0B70-4A45-A37D-05FEDDF08ACE}"/>
+              </a:ext>
+            </a:extLst>
+          </p:cNvPr>
+          <p:cNvSpPr>
+            <a:spLocks noGrp="1"/>
+          </p:cNvSpPr>
+          <p:nvPr>
+            <p:ph type="title"/>
+          </p:nvPr>
+        </p:nvSpPr>
+        <p:spPr/>
+        <p:txBody>
+          <a:bodyPr/>
+          <a:lstStyle/>
+          <a:p>
+            <a:r>
+              <a:rPr lang="en-US"/>
+              <a:t>VS Code extensions</a:t>
+            </a:r>
+          </a:p>
+        </p:txBody>
+      </p:sp>
+      <p:pic>
+        <p:nvPicPr>
+          <p:cNvPr id="5" name="Picture 4">
+            <a:extLst>
+              <a:ext uri="{FF2B5EF4-FFF2-40B4-BE49-F238E27FC236}">
+                <a16:creationId xmlns:a16="http://schemas.microsoft.com/office/drawing/2014/main" id="{77D76AC0-9CCC-403F-AF97-5719A26C8B67}"/>
+              </a:ext>
+            </a:extLst>
+          </p:cNvPr>
+          <p:cNvPicPr>
+            <a:picLocks noChangeAspect="1"/>
+          </p:cNvPicPr>
+          <p:nvPr/>
+        </p:nvPicPr>
+        <p:blipFill>
+          <a:blip r:embed="rId2"/>
+          <a:stretch>
+            <a:fillRect/>
+          </a:stretch>
+        </p:blipFill>
+        <p:spPr>
+          <a:xfrm>
+            <a:off x="880533" y="1975551"/>
+            <a:ext cx="9905998" cy="4263931"/>
+          </a:xfrm>
+          <a:prstGeom prst="rect">
+            <a:avLst/>
+          </a:prstGeom>
+        </p:spPr>
+      </p:pic>
+      <p:cxnSp>
+        <p:nvCxnSpPr>
+          <p:cNvPr id="7" name="Straight Arrow Connector 6">
+            <a:extLst>
+              <a:ext uri="{FF2B5EF4-FFF2-40B4-BE49-F238E27FC236}">
+                <a16:creationId xmlns:a16="http://schemas.microsoft.com/office/drawing/2014/main" id="{25D562B2-237C-4A62-B463-7694E0E9EE2F}"/>
+              </a:ext>
+            </a:extLst>
+          </p:cNvPr>
+          <p:cNvCxnSpPr/>
+          <p:nvPr/>
+        </p:nvCxnSpPr>
+        <p:spPr>
+          <a:xfrm>
+            <a:off x="483650" y="4496430"/>
+            <a:ext cx="468535" cy="120912"/>
+          </a:xfrm>
+          <a:prstGeom prst="straightConnector1">
+            <a:avLst/>
+          </a:prstGeom>
+          <a:ln w="38100">
+            <a:solidFill>
+              <a:srgbClr val="FF0000"/>
+            </a:solidFill>
+            <a:tailEnd type="triangle"/>
+          </a:ln>
+        </p:spPr>
+        <p:style>
+          <a:lnRef idx="1">
+            <a:schemeClr val="accent4"/>
+          </a:lnRef>
+          <a:fillRef idx="0">
+            <a:schemeClr val="accent4"/>
+          </a:fillRef>
+          <a:effectRef idx="0">
+            <a:schemeClr val="accent4"/>
+          </a:effectRef>
+          <a:fontRef idx="minor">
+            <a:schemeClr val="tx1"/>
+          </a:fontRef>
+        </p:style>
+      </p:cxnSp>
+    </p:spTree>
+    <p:extLst>
+      <p:ext uri="{BB962C8B-B14F-4D97-AF65-F5344CB8AC3E}">
+        <p14:creationId xmlns:p14="http://schemas.microsoft.com/office/powerpoint/2010/main" val="1271743506"/>
+      </p:ext>
+    </p:extLst>
+  </p:cSld>
+  <p:clrMapOvr>
+    <a:masterClrMapping/>
+  </p:clrMapOvr>
+</p:sld>
+</file>
+
 <file path=ppt/slides/slide3.xml><?xml version="1.0" encoding="utf-8"?>
+<p:sld xmlns:a="http://schemas.openxmlformats.org/drawingml/2006/main" xmlns:r="http://schemas.openxmlformats.org/officeDocument/2006/relationships" xmlns:p="http://schemas.openxmlformats.org/presentationml/2006/main">
+  <p:cSld>
+    <p:spTree>
+      <p:nvGrpSpPr>
+        <p:cNvPr id="1" name=""/>
+        <p:cNvGrpSpPr/>
+        <p:nvPr/>
+      </p:nvGrpSpPr>
+      <p:grpSpPr>
+        <a:xfrm>
+          <a:off x="0" y="0"/>
+          <a:ext cx="0" cy="0"/>
+          <a:chOff x="0" y="0"/>
+          <a:chExt cx="0" cy="0"/>
+        </a:xfrm>
+      </p:grpSpPr>
+      <p:sp>
+        <p:nvSpPr>
+          <p:cNvPr id="2" name="Title 1">
+            <a:extLst>
+              <a:ext uri="{FF2B5EF4-FFF2-40B4-BE49-F238E27FC236}">
+                <a16:creationId xmlns:a16="http://schemas.microsoft.com/office/drawing/2014/main" id="{5C86CBF7-69F7-7B44-ABCE-F80D6130EA7B}"/>
+              </a:ext>
+            </a:extLst>
+          </p:cNvPr>
+          <p:cNvSpPr>
+            <a:spLocks noGrp="1"/>
+          </p:cNvSpPr>
+          <p:nvPr>
+            <p:ph type="title"/>
+          </p:nvPr>
+        </p:nvSpPr>
+        <p:spPr>
+          <a:xfrm>
+            <a:off x="1143000" y="153192"/>
+            <a:ext cx="10515600" cy="1325563"/>
+          </a:xfrm>
+        </p:spPr>
+        <p:txBody>
+          <a:bodyPr/>
+          <a:lstStyle/>
+          <a:p>
+            <a:r>
+              <a:rPr lang="en-US" dirty="0"/>
+              <a:t>About Me</a:t>
+            </a:r>
+          </a:p>
+        </p:txBody>
+      </p:sp>
+      <p:sp>
+        <p:nvSpPr>
+          <p:cNvPr id="3" name="Content Placeholder 2">
+            <a:extLst>
+              <a:ext uri="{FF2B5EF4-FFF2-40B4-BE49-F238E27FC236}">
+                <a16:creationId xmlns:a16="http://schemas.microsoft.com/office/drawing/2014/main" id="{1095E837-F77E-AE4D-944C-919B5D780AAA}"/>
+              </a:ext>
+            </a:extLst>
+          </p:cNvPr>
+          <p:cNvSpPr>
+            <a:spLocks noGrp="1"/>
+          </p:cNvSpPr>
+          <p:nvPr>
+            <p:ph idx="1"/>
+          </p:nvPr>
+        </p:nvSpPr>
+        <p:spPr>
+          <a:xfrm>
+            <a:off x="1143000" y="1478755"/>
+            <a:ext cx="10515600" cy="4351338"/>
+          </a:xfrm>
+        </p:spPr>
+        <p:txBody>
+          <a:bodyPr/>
+          <a:lstStyle/>
+          <a:p>
+            <a:r>
+              <a:rPr lang="en-US" dirty="0"/>
+              <a:t>Programming </a:t>
+            </a:r>
+            <a:r>
+              <a:rPr lang="en-US"/>
+              <a:t>professionally since 2015</a:t>
+            </a:r>
+            <a:endParaRPr lang="en-US" dirty="0"/>
+          </a:p>
+          <a:p>
+            <a:r>
+              <a:rPr lang="en-US" dirty="0"/>
+              <a:t>First job was RPG on an IBM Mainframe (AS400/I-Series)</a:t>
+            </a:r>
+          </a:p>
+          <a:p>
+            <a:r>
+              <a:rPr lang="en-US" dirty="0"/>
+              <a:t>Then moved to Java with the Spring ecosystem</a:t>
+            </a:r>
+          </a:p>
+          <a:p>
+            <a:r>
+              <a:rPr lang="en-US"/>
+              <a:t>I have a B.B.A. in Accounting (super useful) and a M.S. in Software Engineering</a:t>
+            </a:r>
+            <a:endParaRPr lang="en-US" dirty="0"/>
+          </a:p>
+        </p:txBody>
+      </p:sp>
+    </p:spTree>
+    <p:extLst>
+      <p:ext uri="{BB962C8B-B14F-4D97-AF65-F5344CB8AC3E}">
+        <p14:creationId xmlns:p14="http://schemas.microsoft.com/office/powerpoint/2010/main" val="830997286"/>
+      </p:ext>
+    </p:extLst>
+  </p:cSld>
+  <p:clrMapOvr>
+    <a:masterClrMapping/>
+  </p:clrMapOvr>
+</p:sld>
+</file>
+
+<file path=ppt/slides/slide4.xml><?xml version="1.0" encoding="utf-8"?>
 <p:sld xmlns:a="http://schemas.openxmlformats.org/drawingml/2006/main" xmlns:r="http://schemas.openxmlformats.org/officeDocument/2006/relationships" xmlns:p="http://schemas.openxmlformats.org/presentationml/2006/main">
   <p:cSld>
     <p:spTree>
@@ -21592,7 +22099,7 @@
         <p:spPr>
           <a:xfrm>
             <a:off x="1141413" y="1290918"/>
-            <a:ext cx="9905998" cy="4500283"/>
+            <a:ext cx="9905998" cy="5026755"/>
           </a:xfrm>
         </p:spPr>
         <p:txBody>
@@ -21603,30 +22110,48 @@
           <a:p>
             <a:r>
               <a:rPr lang="en-US" dirty="0"/>
-              <a:t>Access to a computer</a:t>
-            </a:r>
-          </a:p>
-          <a:p>
+              <a:t>Access to </a:t>
+            </a:r>
+            <a:r>
+              <a:rPr lang="en-US"/>
+              <a:t>a computer</a:t>
+            </a:r>
+          </a:p>
+          <a:p>
+            <a:r>
+              <a:rPr lang="en-US"/>
+              <a:t>Getting the following setup is part of your HW</a:t>
+            </a:r>
+            <a:endParaRPr lang="en-US" dirty="0"/>
+          </a:p>
+          <a:p>
+            <a:pPr lvl="1"/>
             <a:r>
               <a:rPr lang="en-US" dirty="0"/>
               <a:t>Python 3.x</a:t>
             </a:r>
           </a:p>
           <a:p>
+            <a:pPr lvl="1"/>
             <a:r>
               <a:rPr lang="en-US" dirty="0"/>
-              <a:t>Text editor/IDE</a:t>
-            </a:r>
-          </a:p>
-          <a:p>
-            <a:pPr lvl="1"/>
+              <a:t>Text editor</a:t>
+            </a:r>
+            <a:r>
+              <a:rPr lang="en-US"/>
+              <a:t>/IDE </a:t>
+            </a:r>
+            <a:endParaRPr lang="en-US" dirty="0"/>
+          </a:p>
+          <a:p>
+            <a:pPr lvl="2"/>
             <a:r>
               <a:rPr lang="en-US" dirty="0"/>
               <a:t>Notepad++</a:t>
             </a:r>
           </a:p>
           <a:p>
-            <a:pPr lvl="1"/>
+            <a:pPr lvl="2"/>
             <a:r>
               <a:rPr lang="en-US" dirty="0">
                 <a:solidFill>
@@ -21650,7 +22175,7 @@
             </a:endParaRPr>
           </a:p>
           <a:p>
-            <a:pPr lvl="1"/>
+            <a:pPr lvl="2"/>
             <a:r>
               <a:rPr lang="en-US">
                 <a:solidFill>
@@ -21666,14 +22191,14 @@
             </a:endParaRPr>
           </a:p>
           <a:p>
-            <a:pPr lvl="1"/>
+            <a:pPr lvl="2"/>
             <a:r>
               <a:rPr lang="en-US" dirty="0"/>
               <a:t>Terminal/Command Line</a:t>
             </a:r>
           </a:p>
           <a:p>
-            <a:pPr lvl="1"/>
+            <a:pPr lvl="2"/>
             <a:r>
               <a:rPr lang="en-US" dirty="0"/>
               <a:t>Online editors (ex: Repl.</a:t>
@@ -21690,138 +22215,6 @@
     <p:extLst>
       <p:ext uri="{BB962C8B-B14F-4D97-AF65-F5344CB8AC3E}">
         <p14:creationId xmlns:p14="http://schemas.microsoft.com/office/powerpoint/2010/main" val="2626440704"/>
-      </p:ext>
-    </p:extLst>
-  </p:cSld>
-  <p:clrMapOvr>
-    <a:masterClrMapping/>
-  </p:clrMapOvr>
-</p:sld>
-</file>
-
-<file path=ppt/slides/slide4.xml><?xml version="1.0" encoding="utf-8"?>
-<p:sld xmlns:a="http://schemas.openxmlformats.org/drawingml/2006/main" xmlns:r="http://schemas.openxmlformats.org/officeDocument/2006/relationships" xmlns:p="http://schemas.openxmlformats.org/presentationml/2006/main">
-  <p:cSld>
-    <p:spTree>
-      <p:nvGrpSpPr>
-        <p:cNvPr id="1" name=""/>
-        <p:cNvGrpSpPr/>
-        <p:nvPr/>
-      </p:nvGrpSpPr>
-      <p:grpSpPr>
-        <a:xfrm>
-          <a:off x="0" y="0"/>
-          <a:ext cx="0" cy="0"/>
-          <a:chOff x="0" y="0"/>
-          <a:chExt cx="0" cy="0"/>
-        </a:xfrm>
-      </p:grpSpPr>
-      <p:sp>
-        <p:nvSpPr>
-          <p:cNvPr id="2" name="Title 1">
-            <a:extLst>
-              <a:ext uri="{FF2B5EF4-FFF2-40B4-BE49-F238E27FC236}">
-                <a16:creationId xmlns:a16="http://schemas.microsoft.com/office/drawing/2014/main" id="{089AB04D-874D-0245-A562-02212EE48CA7}"/>
-              </a:ext>
-            </a:extLst>
-          </p:cNvPr>
-          <p:cNvSpPr>
-            <a:spLocks noGrp="1"/>
-          </p:cNvSpPr>
-          <p:nvPr>
-            <p:ph type="title"/>
-          </p:nvPr>
-        </p:nvSpPr>
-        <p:spPr>
-          <a:xfrm>
-            <a:off x="1143242" y="162579"/>
-            <a:ext cx="10515600" cy="1325563"/>
-          </a:xfrm>
-        </p:spPr>
-        <p:txBody>
-          <a:bodyPr/>
-          <a:lstStyle/>
-          <a:p>
-            <a:r>
-              <a:rPr lang="en-US" dirty="0"/>
-              <a:t>Let’s Jump In</a:t>
-            </a:r>
-          </a:p>
-        </p:txBody>
-      </p:sp>
-      <p:sp>
-        <p:nvSpPr>
-          <p:cNvPr id="3" name="Content Placeholder 2">
-            <a:extLst>
-              <a:ext uri="{FF2B5EF4-FFF2-40B4-BE49-F238E27FC236}">
-                <a16:creationId xmlns:a16="http://schemas.microsoft.com/office/drawing/2014/main" id="{3713A5A2-1019-0143-BC00-1B8B12D7C198}"/>
-              </a:ext>
-            </a:extLst>
-          </p:cNvPr>
-          <p:cNvSpPr>
-            <a:spLocks noGrp="1"/>
-          </p:cNvSpPr>
-          <p:nvPr>
-            <p:ph idx="1"/>
-          </p:nvPr>
-        </p:nvSpPr>
-        <p:spPr>
-          <a:xfrm>
-            <a:off x="1143242" y="1488142"/>
-            <a:ext cx="8596668" cy="3880773"/>
-          </a:xfrm>
-        </p:spPr>
-        <p:txBody>
-          <a:bodyPr>
-            <a:normAutofit lnSpcReduction="10000"/>
-          </a:bodyPr>
-          <a:lstStyle/>
-          <a:p>
-            <a:r>
-              <a:rPr lang="en-US" dirty="0"/>
-              <a:t>What is programming?</a:t>
-            </a:r>
-          </a:p>
-          <a:p>
-            <a:pPr lvl="1"/>
-            <a:r>
-              <a:rPr lang="en-US" dirty="0"/>
-              <a:t>“The action or process of writing computer programs” – Oxford Languages</a:t>
-            </a:r>
-          </a:p>
-          <a:p>
-            <a:pPr lvl="1"/>
-            <a:r>
-              <a:rPr lang="en-US" dirty="0"/>
-              <a:t>“The process of preparing an instructional program for a device” – Merriam-Webster</a:t>
-            </a:r>
-          </a:p>
-          <a:p>
-            <a:pPr lvl="1"/>
-            <a:r>
-              <a:rPr lang="en-US" dirty="0"/>
-              <a:t>These definitions are not super clear, so I prefer to define it as “attempting to get a computer to complete a specific task correctly by giving it commands/instructions”</a:t>
-            </a:r>
-          </a:p>
-          <a:p>
-            <a:r>
-              <a:rPr lang="en-US" dirty="0"/>
-              <a:t>How do we provide instructions?</a:t>
-            </a:r>
-          </a:p>
-          <a:p>
-            <a:pPr lvl="1"/>
-            <a:r>
-              <a:rPr lang="en-US" dirty="0"/>
-              <a:t>Programming languages!</a:t>
-            </a:r>
-          </a:p>
-        </p:txBody>
-      </p:sp>
-    </p:spTree>
-    <p:extLst>
-      <p:ext uri="{BB962C8B-B14F-4D97-AF65-F5344CB8AC3E}">
-        <p14:creationId xmlns:p14="http://schemas.microsoft.com/office/powerpoint/2010/main" val="1056604679"/>
       </p:ext>
     </p:extLst>
   </p:cSld>
@@ -21866,7 +22259,7 @@
         </p:nvSpPr>
         <p:spPr>
           <a:xfrm>
-            <a:off x="1143499" y="163050"/>
+            <a:off x="1143242" y="162579"/>
             <a:ext cx="10515600" cy="1325563"/>
           </a:xfrm>
         </p:spPr>
@@ -21876,7 +22269,7 @@
           <a:p>
             <a:r>
               <a:rPr lang="en-US" dirty="0"/>
-              <a:t>Programming Languages</a:t>
+              <a:t>Let’s Jump In</a:t>
             </a:r>
           </a:p>
         </p:txBody>
@@ -21899,8 +22292,8 @@
         </p:nvSpPr>
         <p:spPr>
           <a:xfrm>
-            <a:off x="1143498" y="1488613"/>
-            <a:ext cx="10334823" cy="4979094"/>
+            <a:off x="1143242" y="1488142"/>
+            <a:ext cx="8596668" cy="3880773"/>
           </a:xfrm>
         </p:spPr>
         <p:txBody>
@@ -21911,75 +22304,43 @@
           <a:p>
             <a:r>
               <a:rPr lang="en-US" dirty="0"/>
-              <a:t>What is a programming language?</a:t>
+              <a:t>What is programming?</a:t>
             </a:r>
           </a:p>
           <a:p>
             <a:pPr lvl="1"/>
             <a:r>
+              <a:rPr lang="en-US" dirty="0"/>
+              <a:t>“The action or process of writing computer programs” – Oxford Languages</a:t>
+            </a:r>
+          </a:p>
+          <a:p>
+            <a:pPr lvl="1"/>
+            <a:r>
+              <a:rPr lang="en-US" dirty="0"/>
+              <a:t>“The process of preparing an instructional program for a device” – Merriam-Webster</a:t>
+            </a:r>
+          </a:p>
+          <a:p>
+            <a:pPr lvl="1"/>
+            <a:r>
+              <a:rPr lang="en-US" dirty="0"/>
+              <a:t>These definitions are not super clear, so I prefer to define it as “attempting to get a computer to complete a specific task correctly by giving it commands/instructions”</a:t>
+            </a:r>
+          </a:p>
+          <a:p>
+            <a:r>
               <a:rPr lang="en-US"/>
-              <a:t>They’re a way of providing a computer with instructions</a:t>
-            </a:r>
-          </a:p>
-          <a:p>
-            <a:pPr lvl="1"/>
-            <a:r>
-              <a:rPr lang="en-US"/>
-              <a:t>They </a:t>
-            </a:r>
-            <a:r>
-              <a:rPr lang="en-US" dirty="0"/>
-              <a:t>can serve as a middle-man to the computer’s language</a:t>
-            </a:r>
-          </a:p>
-          <a:p>
-            <a:pPr lvl="2"/>
-            <a:r>
-              <a:rPr lang="en-US" dirty="0"/>
-              <a:t>Computers understand machine code. Without programming languages you’d have to program using 0s and 1s</a:t>
-            </a:r>
-          </a:p>
-          <a:p>
-            <a:pPr lvl="2"/>
-            <a:r>
-              <a:rPr lang="en-US" dirty="0"/>
-              <a:t>Programming languages make it easier by allowing us to write code using more familiar syntax</a:t>
-            </a:r>
-          </a:p>
-          <a:p>
-            <a:pPr lvl="2"/>
-            <a:r>
-              <a:rPr lang="en-US" dirty="0"/>
-              <a:t>Not all programming languages are the same, some are “higher level” and others are “low level”</a:t>
-            </a:r>
-          </a:p>
-          <a:p>
-            <a:pPr lvl="3"/>
-            <a:r>
-              <a:rPr lang="en-US" dirty="0"/>
-              <a:t>High Level: Python, Java, C#</a:t>
-            </a:r>
-          </a:p>
-          <a:p>
-            <a:pPr lvl="3"/>
-            <a:r>
-              <a:rPr lang="en-US" dirty="0"/>
-              <a:t>Low Level: Assembly, Machine</a:t>
-            </a:r>
-          </a:p>
-          <a:p>
-            <a:pPr lvl="3"/>
-            <a:r>
-              <a:rPr lang="en-US" dirty="0"/>
-              <a:t>Middle: C, C++</a:t>
-            </a:r>
+              <a:t>What is the role of programming languages?</a:t>
+            </a:r>
+            <a:endParaRPr lang="en-US" dirty="0"/>
           </a:p>
         </p:txBody>
       </p:sp>
     </p:spTree>
     <p:extLst>
       <p:ext uri="{BB962C8B-B14F-4D97-AF65-F5344CB8AC3E}">
-        <p14:creationId xmlns:p14="http://schemas.microsoft.com/office/powerpoint/2010/main" val="2840496418"/>
+        <p14:creationId xmlns:p14="http://schemas.microsoft.com/office/powerpoint/2010/main" val="1056604679"/>
       </p:ext>
     </p:extLst>
   </p:cSld>
@@ -22024,6 +22385,156 @@
         </p:nvSpPr>
         <p:spPr>
           <a:xfrm>
+            <a:off x="1143499" y="163050"/>
+            <a:ext cx="10515600" cy="1325563"/>
+          </a:xfrm>
+        </p:spPr>
+        <p:txBody>
+          <a:bodyPr/>
+          <a:lstStyle/>
+          <a:p>
+            <a:r>
+              <a:rPr lang="en-US" dirty="0"/>
+              <a:t>Programming Languages</a:t>
+            </a:r>
+          </a:p>
+        </p:txBody>
+      </p:sp>
+      <p:sp>
+        <p:nvSpPr>
+          <p:cNvPr id="3" name="Content Placeholder 2">
+            <a:extLst>
+              <a:ext uri="{FF2B5EF4-FFF2-40B4-BE49-F238E27FC236}">
+                <a16:creationId xmlns:a16="http://schemas.microsoft.com/office/drawing/2014/main" id="{3713A5A2-1019-0143-BC00-1B8B12D7C198}"/>
+              </a:ext>
+            </a:extLst>
+          </p:cNvPr>
+          <p:cNvSpPr>
+            <a:spLocks noGrp="1"/>
+          </p:cNvSpPr>
+          <p:nvPr>
+            <p:ph idx="1"/>
+          </p:nvPr>
+        </p:nvSpPr>
+        <p:spPr>
+          <a:xfrm>
+            <a:off x="1143498" y="1488613"/>
+            <a:ext cx="10334823" cy="4979094"/>
+          </a:xfrm>
+        </p:spPr>
+        <p:txBody>
+          <a:bodyPr>
+            <a:normAutofit/>
+          </a:bodyPr>
+          <a:lstStyle/>
+          <a:p>
+            <a:r>
+              <a:rPr lang="en-US"/>
+              <a:t>They’re a way of providing a computer with instructions</a:t>
+            </a:r>
+          </a:p>
+          <a:p>
+            <a:r>
+              <a:rPr lang="en-US"/>
+              <a:t>They </a:t>
+            </a:r>
+            <a:r>
+              <a:rPr lang="en-US" dirty="0"/>
+              <a:t>can serve as a middle-man to the computer’s language</a:t>
+            </a:r>
+          </a:p>
+          <a:p>
+            <a:pPr lvl="1"/>
+            <a:r>
+              <a:rPr lang="en-US" dirty="0"/>
+              <a:t>Computers understand machine code. Without programming languages you’d have to program using 0s and 1s</a:t>
+            </a:r>
+          </a:p>
+          <a:p>
+            <a:pPr lvl="1"/>
+            <a:r>
+              <a:rPr lang="en-US" dirty="0"/>
+              <a:t>Programming languages make it easier by allowing us to write code using more familiar syntax</a:t>
+            </a:r>
+          </a:p>
+          <a:p>
+            <a:pPr lvl="1"/>
+            <a:r>
+              <a:rPr lang="en-US" dirty="0"/>
+              <a:t>Not all programming languages are the same, some are “higher level” and others are “low level”</a:t>
+            </a:r>
+          </a:p>
+          <a:p>
+            <a:pPr lvl="2"/>
+            <a:r>
+              <a:rPr lang="en-US" dirty="0"/>
+              <a:t>High Level: Python, Java, C#</a:t>
+            </a:r>
+          </a:p>
+          <a:p>
+            <a:pPr lvl="2"/>
+            <a:r>
+              <a:rPr lang="en-US" dirty="0"/>
+              <a:t>Low Level: Assembly, Machine</a:t>
+            </a:r>
+          </a:p>
+          <a:p>
+            <a:pPr lvl="2"/>
+            <a:r>
+              <a:rPr lang="en-US" dirty="0"/>
+              <a:t>Middle: C, C++</a:t>
+            </a:r>
+          </a:p>
+        </p:txBody>
+      </p:sp>
+    </p:spTree>
+    <p:extLst>
+      <p:ext uri="{BB962C8B-B14F-4D97-AF65-F5344CB8AC3E}">
+        <p14:creationId xmlns:p14="http://schemas.microsoft.com/office/powerpoint/2010/main" val="2840496418"/>
+      </p:ext>
+    </p:extLst>
+  </p:cSld>
+  <p:clrMapOvr>
+    <a:masterClrMapping/>
+  </p:clrMapOvr>
+</p:sld>
+</file>
+
+<file path=ppt/slides/slide7.xml><?xml version="1.0" encoding="utf-8"?>
+<p:sld xmlns:a="http://schemas.openxmlformats.org/drawingml/2006/main" xmlns:r="http://schemas.openxmlformats.org/officeDocument/2006/relationships" xmlns:p="http://schemas.openxmlformats.org/presentationml/2006/main">
+  <p:cSld>
+    <p:spTree>
+      <p:nvGrpSpPr>
+        <p:cNvPr id="1" name=""/>
+        <p:cNvGrpSpPr/>
+        <p:nvPr/>
+      </p:nvGrpSpPr>
+      <p:grpSpPr>
+        <a:xfrm>
+          <a:off x="0" y="0"/>
+          <a:ext cx="0" cy="0"/>
+          <a:chOff x="0" y="0"/>
+          <a:chExt cx="0" cy="0"/>
+        </a:xfrm>
+      </p:grpSpPr>
+      <p:sp>
+        <p:nvSpPr>
+          <p:cNvPr id="2" name="Title 1">
+            <a:extLst>
+              <a:ext uri="{FF2B5EF4-FFF2-40B4-BE49-F238E27FC236}">
+                <a16:creationId xmlns:a16="http://schemas.microsoft.com/office/drawing/2014/main" id="{089AB04D-874D-0245-A562-02212EE48CA7}"/>
+              </a:ext>
+            </a:extLst>
+          </p:cNvPr>
+          <p:cNvSpPr>
+            <a:spLocks noGrp="1"/>
+          </p:cNvSpPr>
+          <p:nvPr>
+            <p:ph type="title"/>
+          </p:nvPr>
+        </p:nvSpPr>
+        <p:spPr>
+          <a:xfrm>
             <a:off x="1143000" y="146102"/>
             <a:ext cx="10515600" cy="1325563"/>
           </a:xfrm>
@@ -22061,7 +22572,7 @@
         </p:blipFill>
         <p:spPr>
           <a:xfrm>
-            <a:off x="2125222" y="3223668"/>
+            <a:off x="2314147" y="3541063"/>
             <a:ext cx="6868052" cy="3228149"/>
           </a:xfrm>
           <a:prstGeom prst="rect">
@@ -22091,7 +22602,7 @@
         </p:blipFill>
         <p:spPr>
           <a:xfrm>
-            <a:off x="2939873" y="1746512"/>
+            <a:off x="3128798" y="2004444"/>
             <a:ext cx="5238750" cy="876300"/>
           </a:xfrm>
           <a:prstGeom prst="rect">
@@ -22099,6 +22610,76 @@
           </a:prstGeom>
         </p:spPr>
       </p:pic>
+      <p:sp>
+        <p:nvSpPr>
+          <p:cNvPr id="3" name="TextBox 2">
+            <a:extLst>
+              <a:ext uri="{FF2B5EF4-FFF2-40B4-BE49-F238E27FC236}">
+                <a16:creationId xmlns:a16="http://schemas.microsoft.com/office/drawing/2014/main" id="{0358ED7B-5293-4FF7-9301-603E7828B426}"/>
+              </a:ext>
+            </a:extLst>
+          </p:cNvPr>
+          <p:cNvSpPr txBox="1"/>
+          <p:nvPr/>
+        </p:nvSpPr>
+        <p:spPr>
+          <a:xfrm>
+            <a:off x="4359753" y="3052111"/>
+            <a:ext cx="2398990" cy="369332"/>
+          </a:xfrm>
+          <a:prstGeom prst="rect">
+            <a:avLst/>
+          </a:prstGeom>
+          <a:noFill/>
+        </p:spPr>
+        <p:txBody>
+          <a:bodyPr wrap="none" rtlCol="0">
+            <a:spAutoFit/>
+          </a:bodyPr>
+          <a:lstStyle/>
+          <a:p>
+            <a:r>
+              <a:rPr lang="en-US"/>
+              <a:t>Assembly “Hello World”</a:t>
+            </a:r>
+          </a:p>
+        </p:txBody>
+      </p:sp>
+      <p:sp>
+        <p:nvSpPr>
+          <p:cNvPr id="6" name="TextBox 5">
+            <a:extLst>
+              <a:ext uri="{FF2B5EF4-FFF2-40B4-BE49-F238E27FC236}">
+                <a16:creationId xmlns:a16="http://schemas.microsoft.com/office/drawing/2014/main" id="{0C70B1A7-1585-4DE2-A090-C13779BC9185}"/>
+              </a:ext>
+            </a:extLst>
+          </p:cNvPr>
+          <p:cNvSpPr txBox="1"/>
+          <p:nvPr/>
+        </p:nvSpPr>
+        <p:spPr>
+          <a:xfrm>
+            <a:off x="4479176" y="1476543"/>
+            <a:ext cx="2160143" cy="369332"/>
+          </a:xfrm>
+          <a:prstGeom prst="rect">
+            <a:avLst/>
+          </a:prstGeom>
+          <a:noFill/>
+        </p:spPr>
+        <p:txBody>
+          <a:bodyPr wrap="none" rtlCol="0">
+            <a:spAutoFit/>
+          </a:bodyPr>
+          <a:lstStyle/>
+          <a:p>
+            <a:r>
+              <a:rPr lang="en-US"/>
+              <a:t>Python “Hello World”</a:t>
+            </a:r>
+          </a:p>
+        </p:txBody>
+      </p:sp>
     </p:spTree>
     <p:extLst>
       <p:ext uri="{BB962C8B-B14F-4D97-AF65-F5344CB8AC3E}">
@@ -22112,7 +22693,7 @@
 </p:sld>
 </file>
 
-<file path=ppt/slides/slide7.xml><?xml version="1.0" encoding="utf-8"?>
+<file path=ppt/slides/slide8.xml><?xml version="1.0" encoding="utf-8"?>
 <p:sld xmlns:a="http://schemas.openxmlformats.org/drawingml/2006/main" xmlns:r="http://schemas.openxmlformats.org/officeDocument/2006/relationships" xmlns:p="http://schemas.openxmlformats.org/presentationml/2006/main">
   <p:cSld>
     <p:spTree>
@@ -22223,154 +22804,6 @@
 </p:sld>
 </file>
 
-<file path=ppt/slides/slide8.xml><?xml version="1.0" encoding="utf-8"?>
-<p:sld xmlns:a="http://schemas.openxmlformats.org/drawingml/2006/main" xmlns:r="http://schemas.openxmlformats.org/officeDocument/2006/relationships" xmlns:p="http://schemas.openxmlformats.org/presentationml/2006/main">
-  <p:cSld>
-    <p:spTree>
-      <p:nvGrpSpPr>
-        <p:cNvPr id="1" name=""/>
-        <p:cNvGrpSpPr/>
-        <p:nvPr/>
-      </p:nvGrpSpPr>
-      <p:grpSpPr>
-        <a:xfrm>
-          <a:off x="0" y="0"/>
-          <a:ext cx="0" cy="0"/>
-          <a:chOff x="0" y="0"/>
-          <a:chExt cx="0" cy="0"/>
-        </a:xfrm>
-      </p:grpSpPr>
-      <p:sp>
-        <p:nvSpPr>
-          <p:cNvPr id="2" name="Title 1">
-            <a:extLst>
-              <a:ext uri="{FF2B5EF4-FFF2-40B4-BE49-F238E27FC236}">
-                <a16:creationId xmlns:a16="http://schemas.microsoft.com/office/drawing/2014/main" id="{089AB04D-874D-0245-A562-02212EE48CA7}"/>
-              </a:ext>
-            </a:extLst>
-          </p:cNvPr>
-          <p:cNvSpPr>
-            <a:spLocks noGrp="1"/>
-          </p:cNvSpPr>
-          <p:nvPr>
-            <p:ph type="title"/>
-          </p:nvPr>
-        </p:nvSpPr>
-        <p:spPr>
-          <a:xfrm>
-            <a:off x="1143499" y="163050"/>
-            <a:ext cx="10515600" cy="1325563"/>
-          </a:xfrm>
-        </p:spPr>
-        <p:txBody>
-          <a:bodyPr/>
-          <a:lstStyle/>
-          <a:p>
-            <a:r>
-              <a:rPr lang="en-US" dirty="0"/>
-              <a:t>Python</a:t>
-            </a:r>
-          </a:p>
-        </p:txBody>
-      </p:sp>
-      <p:sp>
-        <p:nvSpPr>
-          <p:cNvPr id="3" name="Content Placeholder 2">
-            <a:extLst>
-              <a:ext uri="{FF2B5EF4-FFF2-40B4-BE49-F238E27FC236}">
-                <a16:creationId xmlns:a16="http://schemas.microsoft.com/office/drawing/2014/main" id="{3713A5A2-1019-0143-BC00-1B8B12D7C198}"/>
-              </a:ext>
-            </a:extLst>
-          </p:cNvPr>
-          <p:cNvSpPr>
-            <a:spLocks noGrp="1"/>
-          </p:cNvSpPr>
-          <p:nvPr>
-            <p:ph idx="1"/>
-          </p:nvPr>
-        </p:nvSpPr>
-        <p:spPr>
-          <a:xfrm>
-            <a:off x="1143499" y="1488613"/>
-            <a:ext cx="8596668" cy="3880773"/>
-          </a:xfrm>
-        </p:spPr>
-        <p:txBody>
-          <a:bodyPr>
-            <a:normAutofit fontScale="92500" lnSpcReduction="10000"/>
-          </a:bodyPr>
-          <a:lstStyle/>
-          <a:p>
-            <a:r>
-              <a:rPr lang="en-US" dirty="0"/>
-              <a:t>For this class, we will be using the Python programming language (v3.x).</a:t>
-            </a:r>
-          </a:p>
-          <a:p>
-            <a:r>
-              <a:rPr lang="en-US" dirty="0"/>
-              <a:t>v2.x is for legacy support, try to avoid programming in v2.x unless you </a:t>
-            </a:r>
-            <a:r>
-              <a:rPr lang="en-US"/>
-              <a:t>have to</a:t>
-            </a:r>
-          </a:p>
-          <a:p>
-            <a:pPr lvl="1"/>
-            <a:r>
-              <a:rPr lang="en-US"/>
-              <a:t>If you’re on a Windows machine, you likely don’t have v2 or v3 installed</a:t>
-            </a:r>
-          </a:p>
-          <a:p>
-            <a:pPr lvl="1"/>
-            <a:r>
-              <a:rPr lang="en-US"/>
-              <a:t>If you’re on a Mac or Linux, you may have v2 installed </a:t>
-            </a:r>
-            <a:endParaRPr lang="en-US" dirty="0"/>
-          </a:p>
-          <a:p>
-            <a:r>
-              <a:rPr lang="en-US" dirty="0"/>
-              <a:t>Python is a popular beginner language</a:t>
-            </a:r>
-          </a:p>
-          <a:p>
-            <a:pPr lvl="1"/>
-            <a:r>
-              <a:rPr lang="en-US" dirty="0"/>
-              <a:t>Easier syntax for beginners to learn</a:t>
-            </a:r>
-          </a:p>
-          <a:p>
-            <a:pPr lvl="1"/>
-            <a:r>
-              <a:rPr lang="en-US" dirty="0"/>
-              <a:t>As of 2014, it was the most popular intro language at the top </a:t>
-            </a:r>
-            <a:r>
-              <a:rPr lang="en-US"/>
-              <a:t>computer universities</a:t>
-            </a:r>
-            <a:endParaRPr lang="en-US" dirty="0"/>
-          </a:p>
-        </p:txBody>
-      </p:sp>
-    </p:spTree>
-    <p:extLst>
-      <p:ext uri="{BB962C8B-B14F-4D97-AF65-F5344CB8AC3E}">
-        <p14:creationId xmlns:p14="http://schemas.microsoft.com/office/powerpoint/2010/main" val="2341259573"/>
-      </p:ext>
-    </p:extLst>
-  </p:cSld>
-  <p:clrMapOvr>
-    <a:masterClrMapping/>
-  </p:clrMapOvr>
-</p:sld>
-</file>
-
 <file path=ppt/slides/slide9.xml><?xml version="1.0" encoding="utf-8"?>
 <p:sld xmlns:a="http://schemas.openxmlformats.org/drawingml/2006/main" xmlns:r="http://schemas.openxmlformats.org/officeDocument/2006/relationships" xmlns:p="http://schemas.openxmlformats.org/presentationml/2006/main">
   <p:cSld>
@@ -22416,7 +22849,7 @@
           <a:p>
             <a:r>
               <a:rPr lang="en-US" dirty="0"/>
-              <a:t>Syntax</a:t>
+              <a:t>Python</a:t>
             </a:r>
           </a:p>
         </p:txBody>
@@ -22445,46 +22878,71 @@
         </p:spPr>
         <p:txBody>
           <a:bodyPr>
-            <a:normAutofit/>
+            <a:normAutofit fontScale="92500" lnSpcReduction="10000"/>
           </a:bodyPr>
           <a:lstStyle/>
           <a:p>
             <a:r>
               <a:rPr lang="en-US" dirty="0"/>
-              <a:t>All programming languages have a specific syntax</a:t>
+              <a:t>For this class, we will be using the Python programming language (v3.x).</a:t>
             </a:r>
           </a:p>
           <a:p>
             <a:r>
               <a:rPr lang="en-US" dirty="0"/>
-              <a:t>These are rules you must follow in order for your program to run properly</a:t>
+              <a:t>v2.x is for legacy support, try to avoid programming in v2.x unless you </a:t>
+            </a:r>
+            <a:r>
+              <a:rPr lang="en-US"/>
+              <a:t>have to</a:t>
             </a:r>
           </a:p>
           <a:p>
             <a:pPr lvl="1"/>
             <a:r>
+              <a:rPr lang="en-US"/>
+              <a:t>If you’re on a Windows machine, you likely don’t have v2 or v3 installed</a:t>
+            </a:r>
+          </a:p>
+          <a:p>
+            <a:pPr lvl="1"/>
+            <a:r>
+              <a:rPr lang="en-US"/>
+              <a:t>If you’re on a Mac or Linux, you may have v2 installed </a:t>
+            </a:r>
+            <a:endParaRPr lang="en-US" dirty="0"/>
+          </a:p>
+          <a:p>
+            <a:r>
               <a:rPr lang="en-US" dirty="0"/>
-              <a:t>Ex: Declaring variables or functions</a:t>
-            </a:r>
-          </a:p>
-          <a:p>
+              <a:t>Python is a popular beginner language</a:t>
+            </a:r>
+          </a:p>
+          <a:p>
+            <a:pPr lvl="1"/>
             <a:r>
               <a:rPr lang="en-US" dirty="0"/>
-              <a:t>Breaking the rules will result in errors</a:t>
-            </a:r>
-          </a:p>
-          <a:p>
+              <a:t>Easier syntax for beginners to learn</a:t>
+            </a:r>
+          </a:p>
+          <a:p>
+            <a:pPr lvl="1"/>
             <a:r>
               <a:rPr lang="en-US" dirty="0"/>
-              <a:t>“Let’s eat, Grandma!” vs ”Let’s eat Grandma!”</a:t>
-            </a:r>
+              <a:t>As of 2014, it was the most popular intro language at the top </a:t>
+            </a:r>
+            <a:r>
+              <a:rPr lang="en-US"/>
+              <a:t>computer universities</a:t>
+            </a:r>
+            <a:endParaRPr lang="en-US" dirty="0"/>
           </a:p>
         </p:txBody>
       </p:sp>
     </p:spTree>
     <p:extLst>
       <p:ext uri="{BB962C8B-B14F-4D97-AF65-F5344CB8AC3E}">
-        <p14:creationId xmlns:p14="http://schemas.microsoft.com/office/powerpoint/2010/main" val="1244393583"/>
+        <p14:creationId xmlns:p14="http://schemas.microsoft.com/office/powerpoint/2010/main" val="2341259573"/>
       </p:ext>
     </p:extLst>
   </p:cSld>

</xml_diff>